<commit_message>
docs: de-jargon the unified deck for a general student audience
Replace insider terms that appeared without explanation:
- "失敗分類學" → "Claude 的「失敗分類學」" + define it inline (S10)
- 協議/策略分離 now has concrete examples + a plug-socket analogy (S11)
- "v3" → "先前一次沒有防護的進化實驗" (S9, S20)
- "iter22" glossed as "進化到第 22 代" at first appearance (S2)
- removed orphan "#6"/"#7" titles (they referenced the cut
  "10 directions" slide that doesn't exist in this deck) (S16, S17)
- "fallback 分數" → "保底分數（fallback）" (S9); glossed island term (S23)
- shortened S10 title so it no longer overflows to two lines

Co-Authored-By: Claude Opus 4.8 <noreply@anthropic.com>
</commit_message>
<xml_diff>
--- a/docs/slides/人AI進化_整合教學投影片.pptx
+++ b/docs/slides/人AI進化_整合教學投影片.pptx
@@ -4443,7 +4443,7 @@
                 <a:ea typeface="Georgia" pitchFamily="34" charset="-122"/>
                 <a:cs typeface="Georgia" pitchFamily="34" charset="-120"/>
               </a:rPr>
-              <a:t>協作模式 ①：好問題 → 失敗分類學</a:t>
+              <a:t>協作模式 ①：Claude 的「失敗分類學」</a:t>
             </a:r>
             <a:endParaRPr lang="en-US" sz="2800" dirty="0"/>
           </a:p>
@@ -5454,24 +5454,27 @@
         </p:nvSpPr>
         <p:spPr>
           <a:xfrm>
-            <a:off x="4846320" y="5440680"/>
-            <a:ext cx="6812280" cy="640080"/>
-          </a:xfrm>
-          <a:prstGeom prst="rect">
-            <a:avLst/>
-          </a:prstGeom>
-          <a:noFill/>
-          <a:ln/>
-        </p:spPr>
-        <p:txBody>
-          <a:bodyPr wrap="square" lIns="0" tIns="0" rIns="0" bIns="0" rtlCol="0" anchor="ctr"/>
-          <a:lstStyle/>
-          <a:p>
-            <a:pPr indent="0" marL="0">
-              <a:buNone/>
-            </a:pPr>
-            <a:r>
-              <a:rPr lang="en-US" sz="1200" i="1" dirty="0">
+            <a:off x="4846320" y="5394960"/>
+            <a:ext cx="6812280" cy="685800"/>
+          </a:xfrm>
+          <a:prstGeom prst="rect">
+            <a:avLst/>
+          </a:prstGeom>
+          <a:noFill/>
+          <a:ln/>
+        </p:spPr>
+        <p:txBody>
+          <a:bodyPr wrap="square" lIns="0" tIns="0" rIns="0" bIns="0" rtlCol="0" anchor="ctr"/>
+          <a:lstStyle/>
+          <a:p>
+            <a:pPr indent="0" marL="0">
+              <a:lnSpc>
+                <a:spcPts val="1600"/>
+              </a:lnSpc>
+              <a:buNone/>
+            </a:pPr>
+            <a:r>
+              <a:rPr lang="en-US" sz="1150" i="1" dirty="0">
                 <a:solidFill>
                   <a:srgbClr val="3A5BA0"/>
                 </a:solidFill>
@@ -5479,9 +5482,9 @@
                 <a:ea typeface="Calibri" pitchFamily="34" charset="-122"/>
                 <a:cs typeface="Calibri" pitchFamily="34" charset="-120"/>
               </a:rPr>
-              <a:t>Claude 的答：不直接 try/except，先做「失敗分類學」5 層 → 金句：fitness 只告訴你「壞了」，不告訴你「哪裡壞了」。</a:t>
-            </a:r>
-            <a:endParaRPr lang="en-US" sz="1200" dirty="0"/>
+              <a:t>Claude 沒直接 try/except，而是先把「工具呼叫會怎麼壞」拆成 5 層——這套分法就叫「失敗分類學」。金句：fitness 只告訴你「壞了」，不告訴你「哪裡壞了」。</a:t>
+            </a:r>
+            <a:endParaRPr lang="en-US" sz="1150" dirty="0"/>
           </a:p>
         </p:txBody>
       </p:sp>
@@ -5728,7 +5731,7 @@
         </p:nvSpPr>
         <p:spPr>
           <a:xfrm>
-            <a:off x="868680" y="2011680"/>
+            <a:off x="868680" y="1993392"/>
             <a:ext cx="10607040" cy="457200"/>
           </a:xfrm>
           <a:prstGeom prst="rect">
@@ -5753,7 +5756,7 @@
                 <a:ea typeface="Georgia" pitchFamily="34" charset="-122"/>
                 <a:cs typeface="Georgia" pitchFamily="34" charset="-120"/>
               </a:rPr>
-              <a:t>協議層（Protocol）— 凍結、機器驗證、程式碼強制</a:t>
+              <a:t>協議層（Protocol）— 凍結、不准進化亂改</a:t>
             </a:r>
             <a:endParaRPr lang="en-US" sz="1800" dirty="0"/>
           </a:p>
@@ -5767,24 +5770,24 @@
         </p:nvSpPr>
         <p:spPr>
           <a:xfrm>
-            <a:off x="868680" y="2606040"/>
-            <a:ext cx="10607040" cy="822960"/>
-          </a:xfrm>
-          <a:prstGeom prst="rect">
-            <a:avLst/>
-          </a:prstGeom>
-          <a:noFill/>
-          <a:ln/>
-        </p:spPr>
-        <p:txBody>
-          <a:bodyPr wrap="square" lIns="0" tIns="0" rIns="0" bIns="0" rtlCol="0" anchor="ctr"/>
-          <a:lstStyle/>
-          <a:p>
-            <a:pPr indent="0" marL="0">
-              <a:buNone/>
-            </a:pPr>
-            <a:r>
-              <a:rPr lang="en-US" sz="1450" dirty="0">
+            <a:off x="868680" y="2487168"/>
+            <a:ext cx="10607040" cy="457200"/>
+          </a:xfrm>
+          <a:prstGeom prst="rect">
+            <a:avLst/>
+          </a:prstGeom>
+          <a:noFill/>
+          <a:ln/>
+        </p:spPr>
+        <p:txBody>
+          <a:bodyPr wrap="square" lIns="0" tIns="0" rIns="0" bIns="0" rtlCol="0" anchor="ctr"/>
+          <a:lstStyle/>
+          <a:p>
+            <a:pPr indent="0" marL="0">
+              <a:buNone/>
+            </a:pPr>
+            <a:r>
+              <a:rPr lang="en-US" sz="1400" dirty="0">
                 <a:solidFill>
                   <a:srgbClr val="23272E"/>
                 </a:solidFill>
@@ -5792,15 +5795,68 @@
                 <a:ea typeface="Calibri" pitchFamily="34" charset="-122"/>
                 <a:cs typeface="Calibri" pitchFamily="34" charset="-120"/>
               </a:rPr>
-              <a:t>「工具怎麼被呼叫」：函式簽名、參數 schema、ReAct 格式、回傳格式、註冊機制</a:t>
-            </a:r>
-            <a:endParaRPr lang="en-US" sz="1450" dirty="0"/>
-          </a:p>
-        </p:txBody>
-      </p:sp>
-      <p:sp>
-        <p:nvSpPr>
-          <p:cNvPr id="9" name="Shape 7"/>
+              <a:t>「工具怎麼被呼叫」：函式簽名、參數格式、回傳格式、註冊機制</a:t>
+            </a:r>
+            <a:endParaRPr lang="en-US" sz="1400" dirty="0"/>
+          </a:p>
+        </p:txBody>
+      </p:sp>
+      <p:sp>
+        <p:nvSpPr>
+          <p:cNvPr id="9" name="Text 7"/>
+          <p:cNvSpPr/>
+          <p:nvPr/>
+        </p:nvSpPr>
+        <p:spPr>
+          <a:xfrm>
+            <a:off x="868680" y="2971800"/>
+            <a:ext cx="10607040" cy="457200"/>
+          </a:xfrm>
+          <a:prstGeom prst="rect">
+            <a:avLst/>
+          </a:prstGeom>
+          <a:noFill/>
+          <a:ln/>
+        </p:spPr>
+        <p:txBody>
+          <a:bodyPr wrap="square" lIns="0" tIns="0" rIns="0" bIns="0" rtlCol="0" anchor="ctr"/>
+          <a:lstStyle/>
+          <a:p>
+            <a:pPr indent="0" marL="0">
+              <a:buNone/>
+            </a:pPr>
+            <a:r>
+              <a:rPr lang="en-US" sz="1400" b="1" i="1" dirty="0">
+                <a:solidFill>
+                  <a:srgbClr val="1E2761"/>
+                </a:solidFill>
+                <a:latin typeface="Calibri" pitchFamily="34" charset="0"/>
+                <a:ea typeface="Calibri" pitchFamily="34" charset="-122"/>
+                <a:cs typeface="Calibri" pitchFamily="34" charset="-120"/>
+              </a:rPr>
+              <a:t>例：</a:t>
+            </a:r>
+            <a:pPr indent="0" marL="0">
+              <a:buNone/>
+            </a:pPr>
+            <a:r>
+              <a:rPr lang="en-US" sz="1400" i="1" dirty="0">
+                <a:solidFill>
+                  <a:srgbClr val="23272E"/>
+                </a:solidFill>
+                <a:latin typeface="Calibri" pitchFamily="34" charset="0"/>
+                <a:ea typeface="Calibri" pitchFamily="34" charset="-122"/>
+                <a:cs typeface="Calibri" pitchFamily="34" charset="-120"/>
+              </a:rPr>
+              <a:t>「只能查 user / item / review 這幾種資料」——固定不變，誰都不能改。</a:t>
+            </a:r>
+            <a:endParaRPr lang="en-US" sz="1400" dirty="0"/>
+          </a:p>
+        </p:txBody>
+      </p:sp>
+      <p:sp>
+        <p:nvSpPr>
+          <p:cNvPr id="10" name="Shape 8"/>
           <p:cNvSpPr/>
           <p:nvPr/>
         </p:nvSpPr>
@@ -5832,7 +5888,7 @@
       </p:sp>
       <p:sp>
         <p:nvSpPr>
-          <p:cNvPr id="10" name="Shape 8"/>
+          <p:cNvPr id="11" name="Shape 9"/>
           <p:cNvSpPr/>
           <p:nvPr/>
         </p:nvSpPr>
@@ -5852,13 +5908,13 @@
       </p:sp>
       <p:sp>
         <p:nvSpPr>
-          <p:cNvPr id="11" name="Text 9"/>
-          <p:cNvSpPr/>
-          <p:nvPr/>
-        </p:nvSpPr>
-        <p:spPr>
-          <a:xfrm>
-            <a:off x="868680" y="3931920"/>
+          <p:cNvPr id="12" name="Text 10"/>
+          <p:cNvSpPr/>
+          <p:nvPr/>
+        </p:nvSpPr>
+        <p:spPr>
+          <a:xfrm>
+            <a:off x="868680" y="3913632"/>
             <a:ext cx="10607040" cy="457200"/>
           </a:xfrm>
           <a:prstGeom prst="rect">
@@ -5891,30 +5947,30 @@
       </p:sp>
       <p:sp>
         <p:nvSpPr>
-          <p:cNvPr id="12" name="Text 10"/>
-          <p:cNvSpPr/>
-          <p:nvPr/>
-        </p:nvSpPr>
-        <p:spPr>
-          <a:xfrm>
-            <a:off x="868680" y="4526280"/>
-            <a:ext cx="10607040" cy="822960"/>
-          </a:xfrm>
-          <a:prstGeom prst="rect">
-            <a:avLst/>
-          </a:prstGeom>
-          <a:noFill/>
-          <a:ln/>
-        </p:spPr>
-        <p:txBody>
-          <a:bodyPr wrap="square" lIns="0" tIns="0" rIns="0" bIns="0" rtlCol="0" anchor="ctr"/>
-          <a:lstStyle/>
-          <a:p>
-            <a:pPr indent="0" marL="0">
-              <a:buNone/>
-            </a:pPr>
-            <a:r>
-              <a:rPr lang="en-US" sz="1450" dirty="0">
+          <p:cNvPr id="13" name="Text 11"/>
+          <p:cNvSpPr/>
+          <p:nvPr/>
+        </p:nvSpPr>
+        <p:spPr>
+          <a:xfrm>
+            <a:off x="868680" y="4407408"/>
+            <a:ext cx="10607040" cy="457200"/>
+          </a:xfrm>
+          <a:prstGeom prst="rect">
+            <a:avLst/>
+          </a:prstGeom>
+          <a:noFill/>
+          <a:ln/>
+        </p:spPr>
+        <p:txBody>
+          <a:bodyPr wrap="square" lIns="0" tIns="0" rIns="0" bIns="0" rtlCol="0" anchor="ctr"/>
+          <a:lstStyle/>
+          <a:p>
+            <a:pPr indent="0" marL="0">
+              <a:buNone/>
+            </a:pPr>
+            <a:r>
+              <a:rPr lang="en-US" sz="1400" dirty="0">
                 <a:solidFill>
                   <a:srgbClr val="23272E"/>
                 </a:solidFill>
@@ -5922,46 +5978,60 @@
                 <a:ea typeface="Calibri" pitchFamily="34" charset="-122"/>
                 <a:cs typeface="Calibri" pitchFamily="34" charset="-120"/>
               </a:rPr>
-              <a:t>「工具被怎麼使用」：查什麼、查多少、何時查、怎麼消化結果、甚至「需要什麼新工具」</a:t>
-            </a:r>
-            <a:endParaRPr lang="en-US" sz="1450" dirty="0"/>
-          </a:p>
-        </p:txBody>
-      </p:sp>
-      <p:sp>
-        <p:nvSpPr>
-          <p:cNvPr id="13" name="Text 11"/>
-          <p:cNvSpPr/>
-          <p:nvPr/>
-        </p:nvSpPr>
-        <p:spPr>
-          <a:xfrm>
-            <a:off x="548640" y="5760720"/>
-            <a:ext cx="10972800" cy="365760"/>
-          </a:xfrm>
-          <a:prstGeom prst="rect">
-            <a:avLst/>
-          </a:prstGeom>
-          <a:noFill/>
-          <a:ln/>
-        </p:spPr>
-        <p:txBody>
-          <a:bodyPr wrap="square" lIns="0" tIns="0" rIns="0" bIns="0" rtlCol="0" anchor="ctr"/>
-          <a:lstStyle/>
-          <a:p>
-            <a:pPr indent="0" marL="0">
-              <a:buNone/>
-            </a:pPr>
-            <a:r>
-              <a:rPr lang="en-US" sz="1400" i="1" dirty="0">
-                <a:solidFill>
-                  <a:srgbClr val="3A5BA0"/>
+              <a:t>「工具被怎麼使用」：查哪幾種、查幾筆、何時查、怎麼消化、甚至需要什麼新工具</a:t>
+            </a:r>
+            <a:endParaRPr lang="en-US" sz="1400" dirty="0"/>
+          </a:p>
+        </p:txBody>
+      </p:sp>
+      <p:sp>
+        <p:nvSpPr>
+          <p:cNvPr id="14" name="Text 12"/>
+          <p:cNvSpPr/>
+          <p:nvPr/>
+        </p:nvSpPr>
+        <p:spPr>
+          <a:xfrm>
+            <a:off x="868680" y="4892040"/>
+            <a:ext cx="10607040" cy="457200"/>
+          </a:xfrm>
+          <a:prstGeom prst="rect">
+            <a:avLst/>
+          </a:prstGeom>
+          <a:noFill/>
+          <a:ln/>
+        </p:spPr>
+        <p:txBody>
+          <a:bodyPr wrap="square" lIns="0" tIns="0" rIns="0" bIns="0" rtlCol="0" anchor="ctr"/>
+          <a:lstStyle/>
+          <a:p>
+            <a:pPr indent="0" marL="0">
+              <a:buNone/>
+            </a:pPr>
+            <a:r>
+              <a:rPr lang="en-US" sz="1400" b="1" i="1" dirty="0">
+                <a:solidFill>
+                  <a:srgbClr val="B5791F"/>
                 </a:solidFill>
                 <a:latin typeface="Calibri" pitchFamily="34" charset="0"/>
                 <a:ea typeface="Calibri" pitchFamily="34" charset="-122"/>
                 <a:cs typeface="Calibri" pitchFamily="34" charset="-120"/>
               </a:rPr>
-              <a:t>所有 L0/L1/L2 防護都建立在這條原則上。</a:t>
+              <a:t>例：</a:t>
+            </a:r>
+            <a:pPr indent="0" marL="0">
+              <a:buNone/>
+            </a:pPr>
+            <a:r>
+              <a:rPr lang="en-US" sz="1400" i="1" dirty="0">
+                <a:solidFill>
+                  <a:srgbClr val="23272E"/>
+                </a:solidFill>
+                <a:latin typeface="Calibri" pitchFamily="34" charset="0"/>
+                <a:ea typeface="Calibri" pitchFamily="34" charset="-122"/>
+                <a:cs typeface="Calibri" pitchFamily="34" charset="-120"/>
+              </a:rPr>
+              <a:t>「這一輪查 user + review、各取 15 筆、按最近排序」——放手讓進化去試。</a:t>
             </a:r>
             <a:endParaRPr lang="en-US" sz="1400" dirty="0"/>
           </a:p>
@@ -5969,7 +6039,46 @@
       </p:sp>
       <p:sp>
         <p:nvSpPr>
-          <p:cNvPr id="14" name="Text 12"/>
+          <p:cNvPr id="15" name="Text 13"/>
+          <p:cNvSpPr/>
+          <p:nvPr/>
+        </p:nvSpPr>
+        <p:spPr>
+          <a:xfrm>
+            <a:off x="548640" y="5715000"/>
+            <a:ext cx="11109960" cy="365760"/>
+          </a:xfrm>
+          <a:prstGeom prst="rect">
+            <a:avLst/>
+          </a:prstGeom>
+          <a:noFill/>
+          <a:ln/>
+        </p:spPr>
+        <p:txBody>
+          <a:bodyPr wrap="square" lIns="0" tIns="0" rIns="0" bIns="0" rtlCol="0" anchor="ctr"/>
+          <a:lstStyle/>
+          <a:p>
+            <a:pPr indent="0" marL="0">
+              <a:buNone/>
+            </a:pPr>
+            <a:r>
+              <a:rPr lang="en-US" sz="1400" i="1" dirty="0">
+                <a:solidFill>
+                  <a:srgbClr val="3A5BA0"/>
+                </a:solidFill>
+                <a:latin typeface="Calibri" pitchFamily="34" charset="0"/>
+                <a:ea typeface="Calibri" pitchFamily="34" charset="-122"/>
+                <a:cs typeface="Calibri" pitchFamily="34" charset="-120"/>
+              </a:rPr>
+              <a:t>好比插座：插座規格是「協議」（固定），要插什麼電器是「策略」（自由）——形狀統一，用法無限。</a:t>
+            </a:r>
+            <a:endParaRPr lang="en-US" sz="1400" dirty="0"/>
+          </a:p>
+        </p:txBody>
+      </p:sp>
+      <p:sp>
+        <p:nvSpPr>
+          <p:cNvPr id="16" name="Text 14"/>
           <p:cNvSpPr/>
           <p:nvPr/>
         </p:nvSpPr>
@@ -9155,7 +9264,7 @@
                 <a:ea typeface="Georgia" pitchFamily="34" charset="-122"/>
                 <a:cs typeface="Georgia" pitchFamily="34" charset="-120"/>
               </a:rPr>
-              <a:t>#7 Train / Val 切分：過擬合照妖鏡</a:t>
+              <a:t>Train / Val 切分：過擬合照妖鏡</a:t>
             </a:r>
             <a:endParaRPr lang="en-US" sz="2800" dirty="0"/>
           </a:p>
@@ -9716,7 +9825,7 @@
                 <a:ea typeface="Georgia" pitchFamily="34" charset="-122"/>
                 <a:cs typeface="Georgia" pitchFamily="34" charset="-120"/>
               </a:rPr>
-              <a:t>#6 MAP-Elites 自訂維度</a:t>
+              <a:t>MAP-Elites 自訂維度</a:t>
             </a:r>
             <a:endParaRPr lang="en-US" sz="2800" dirty="0"/>
           </a:p>
@@ -11606,7 +11715,7 @@
                 <a:ea typeface="Calibri" pitchFamily="34" charset="-122"/>
                 <a:cs typeface="Calibri" pitchFamily="34" charset="-120"/>
               </a:rPr>
-              <a:t>iter22：進化自己長出的量化公式</a:t>
+              <a:t>iter22（進化到第 22 代）長出的量化公式</a:t>
             </a:r>
             <a:endParaRPr lang="en-US" sz="1350" dirty="0"/>
           </a:p>
@@ -12110,7 +12219,7 @@
                 <a:ea typeface="Georgia" pitchFamily="34" charset="-122"/>
                 <a:cs typeface="Georgia" pitchFamily="34" charset="-120"/>
               </a:rPr>
-              <a:t>沒框架（v3）</a:t>
+              <a:t>沒防護的先前實驗</a:t>
             </a:r>
             <a:endParaRPr lang="en-US" sz="1600" dirty="0"/>
           </a:p>
@@ -14812,7 +14921,7 @@
                 <a:ea typeface="Calibri" pitchFamily="34" charset="-122"/>
                 <a:cs typeface="Calibri" pitchFamily="34" charset="-120"/>
               </a:rPr>
-              <a:t>migration 把 iter22 基因散到 3 島 → 多樣性塌掉，整族卡同一山頭</a:t>
+              <a:t>OpenEvolve 把族群分成 3 個獨立演化的「島」；遷移又把 iter22 基因散到三島 → 多樣性塌掉</a:t>
             </a:r>
             <a:endParaRPr lang="en-US" sz="1400" dirty="0"/>
           </a:p>
@@ -23296,23 +23405,23 @@
         <p:spPr>
           <a:xfrm>
             <a:off x="548640" y="1737360"/>
-            <a:ext cx="10972800" cy="365760"/>
-          </a:xfrm>
-          <a:prstGeom prst="rect">
-            <a:avLst/>
-          </a:prstGeom>
-          <a:noFill/>
-          <a:ln/>
-        </p:spPr>
-        <p:txBody>
-          <a:bodyPr wrap="square" lIns="0" tIns="0" rIns="0" bIns="0" rtlCol="0" anchor="ctr"/>
-          <a:lstStyle/>
-          <a:p>
-            <a:pPr indent="0" marL="0">
-              <a:buNone/>
-            </a:pPr>
-            <a:r>
-              <a:rPr lang="en-US" sz="1600" dirty="0">
+            <a:ext cx="11109960" cy="365760"/>
+          </a:xfrm>
+          <a:prstGeom prst="rect">
+            <a:avLst/>
+          </a:prstGeom>
+          <a:noFill/>
+          <a:ln/>
+        </p:spPr>
+        <p:txBody>
+          <a:bodyPr wrap="square" lIns="0" tIns="0" rIns="0" bIns="0" rtlCol="0" anchor="ctr"/>
+          <a:lstStyle/>
+          <a:p>
+            <a:pPr indent="0" marL="0">
+              <a:buNone/>
+            </a:pPr>
+            <a:r>
+              <a:rPr lang="en-US" sz="1550" dirty="0">
                 <a:solidFill>
                   <a:srgbClr val="23272E"/>
                 </a:solidFill>
@@ -23320,9 +23429,9 @@
                 <a:ea typeface="Calibri" pitchFamily="34" charset="-122"/>
                 <a:cs typeface="Calibri" pitchFamily="34" charset="-120"/>
               </a:rPr>
-              <a:t>v3 進化中，agent prompt 的突變導致 tool 呼叫失效 → 整條 pipeline 崩潰</a:t>
-            </a:r>
-            <a:endParaRPr lang="en-US" sz="1600" dirty="0"/>
+              <a:t>在先前一次「沒有防護」的進化實驗裡，agent prompt 的突變導致工具呼叫失效 → 整條流程崩潰</a:t>
+            </a:r>
+            <a:endParaRPr lang="en-US" sz="1550" dirty="0"/>
           </a:p>
         </p:txBody>
       </p:sp>
@@ -23446,7 +23555,7 @@
                 <a:ea typeface="Calibri" pitchFamily="34" charset="-122"/>
                 <a:cs typeface="Calibri" pitchFamily="34" charset="-120"/>
               </a:rPr>
-              <a:t>fallback 分數</a:t>
+              <a:t>保底分數（fallback）</a:t>
             </a:r>
             <a:endParaRPr lang="en-US" sz="1300" dirty="0"/>
           </a:p>
@@ -23485,7 +23594,7 @@
                 <a:ea typeface="Calibri" pitchFamily="34" charset="-122"/>
                 <a:cs typeface="Calibri" pitchFamily="34" charset="-120"/>
               </a:rPr>
-              <a:t>v3 約 36% iteration 反覆掉到這地板——工具呼叫一壞，預測流程整個垮掉。</a:t>
+              <a:t>那次約 36% 的迭代反覆掉到這地板——工具呼叫一壞，預測流程整個垮掉。</a:t>
             </a:r>
             <a:endParaRPr lang="en-US" sz="1350" dirty="0"/>
           </a:p>

</xml_diff>

<commit_message>
docs: make every ‹code› reference a clickable GitHub permalink (unified deck)
Each file:line token in the footer is now a hyperlink to the file at
that line on GitHub, pinned to commit facfd59 so line numbers never
drift. Implemented by auto-detecting known filenames in codeRef() — the
27 footer strings are unchanged. 64 links across all 27 slides; links
render blue + underlined and open the browser at the exact line.

- codeRef() splits the footer into text/link runs via a filename→path
  map + line-anchor builder
- continuation refs (":120", "/:106") reuse the previous file; a
  word-boundary guard stops config values like "num_islands:3" from
  being mistaken for a line number

Co-Authored-By: Claude Opus 4.8 <noreply@anthropic.com>
</commit_message>
<xml_diff>
--- a/docs/slides/人AI進化_整合教學投影片.pptx
+++ b/docs/slides/人AI進化_整合教學投影片.pptx
@@ -4313,7 +4313,98 @@
                 <a:ea typeface="Consolas" pitchFamily="34" charset="-122"/>
                 <a:cs typeface="Consolas" pitchFamily="34" charset="-120"/>
               </a:rPr>
-              <a:t>repo · 進入點 openevolve_evaluator.py · config/openevolve_config.yaml · config/agents_evolving.yaml</a:t>
+              <a:t>repo · 進入點 </a:t>
+            </a:r>
+            <a:pPr indent="0" marL="0">
+              <a:buNone/>
+            </a:pPr>
+            <a:r>
+              <a:rPr lang="en-US" sz="900" u="sng" dirty="0">
+                <a:solidFill>
+                  <a:srgbClr val="CADCFC"/>
+                </a:solidFill>
+                <a:latin typeface="Consolas" pitchFamily="34" charset="0"/>
+                <a:ea typeface="Consolas" pitchFamily="34" charset="-122"/>
+                <a:cs typeface="Consolas" pitchFamily="34" charset="-120"/>
+                <a:hlinkClick r:id="rId1" invalidUrl="" action="" tgtFrame="" tooltip="" history="1" highlightClick="0" endSnd="0">
+                  <a:extLst>
+                    <a:ext uri="{A12FA001-AC4F-418D-AE19-62706E023703}">
+                      <ahyp:hlinkClr xmlns:ahyp="http://schemas.microsoft.com/office/drawing/2018/hyperlinkcolor" val="tx"/>
+                    </a:ext>
+                  </a:extLst>
+                </a:hlinkClick>
+              </a:rPr>
+              <a:t>openevolve_evaluator.py</a:t>
+            </a:r>
+            <a:pPr indent="0" marL="0">
+              <a:buNone/>
+            </a:pPr>
+            <a:r>
+              <a:rPr lang="en-US" sz="900" dirty="0">
+                <a:solidFill>
+                  <a:srgbClr val="8FA3C8"/>
+                </a:solidFill>
+                <a:latin typeface="Consolas" pitchFamily="34" charset="0"/>
+                <a:ea typeface="Consolas" pitchFamily="34" charset="-122"/>
+                <a:cs typeface="Consolas" pitchFamily="34" charset="-120"/>
+              </a:rPr>
+              <a:t> · </a:t>
+            </a:r>
+            <a:pPr indent="0" marL="0">
+              <a:buNone/>
+            </a:pPr>
+            <a:r>
+              <a:rPr lang="en-US" sz="900" u="sng" dirty="0">
+                <a:solidFill>
+                  <a:srgbClr val="CADCFC"/>
+                </a:solidFill>
+                <a:latin typeface="Consolas" pitchFamily="34" charset="0"/>
+                <a:ea typeface="Consolas" pitchFamily="34" charset="-122"/>
+                <a:cs typeface="Consolas" pitchFamily="34" charset="-120"/>
+                <a:hlinkClick r:id="rId2" invalidUrl="" action="" tgtFrame="" tooltip="" history="1" highlightClick="0" endSnd="0">
+                  <a:extLst>
+                    <a:ext uri="{A12FA001-AC4F-418D-AE19-62706E023703}">
+                      <ahyp:hlinkClr xmlns:ahyp="http://schemas.microsoft.com/office/drawing/2018/hyperlinkcolor" val="tx"/>
+                    </a:ext>
+                  </a:extLst>
+                </a:hlinkClick>
+              </a:rPr>
+              <a:t>config/openevolve_config.yaml</a:t>
+            </a:r>
+            <a:pPr indent="0" marL="0">
+              <a:buNone/>
+            </a:pPr>
+            <a:r>
+              <a:rPr lang="en-US" sz="900" dirty="0">
+                <a:solidFill>
+                  <a:srgbClr val="8FA3C8"/>
+                </a:solidFill>
+                <a:latin typeface="Consolas" pitchFamily="34" charset="0"/>
+                <a:ea typeface="Consolas" pitchFamily="34" charset="-122"/>
+                <a:cs typeface="Consolas" pitchFamily="34" charset="-120"/>
+              </a:rPr>
+              <a:t> · </a:t>
+            </a:r>
+            <a:pPr indent="0" marL="0">
+              <a:buNone/>
+            </a:pPr>
+            <a:r>
+              <a:rPr lang="en-US" sz="900" u="sng" dirty="0">
+                <a:solidFill>
+                  <a:srgbClr val="CADCFC"/>
+                </a:solidFill>
+                <a:latin typeface="Consolas" pitchFamily="34" charset="0"/>
+                <a:ea typeface="Consolas" pitchFamily="34" charset="-122"/>
+                <a:cs typeface="Consolas" pitchFamily="34" charset="-120"/>
+                <a:hlinkClick r:id="rId3" invalidUrl="" action="" tgtFrame="" tooltip="" history="1" highlightClick="0" endSnd="0">
+                  <a:extLst>
+                    <a:ext uri="{A12FA001-AC4F-418D-AE19-62706E023703}">
+                      <ahyp:hlinkClr xmlns:ahyp="http://schemas.microsoft.com/office/drawing/2018/hyperlinkcolor" val="tx"/>
+                    </a:ext>
+                  </a:extLst>
+                </a:hlinkClick>
+              </a:rPr>
+              <a:t>config/agents_evolving.yaml</a:t>
             </a:r>
             <a:endParaRPr lang="en-US" sz="900" dirty="0"/>
           </a:p>
@@ -5535,7 +5626,42 @@
                 <a:ea typeface="Consolas" pitchFamily="34" charset="-122"/>
                 <a:cs typeface="Consolas" pitchFamily="34" charset="-120"/>
               </a:rPr>
-              <a:t>5 層分類學 docs/evolution_design_notes.md §3 ｜ 落地 src/tools/{interaction_tool_wrapper,retrieval_executor,tool_loader}.py</a:t>
+              <a:t>5 層分類學 </a:t>
+            </a:r>
+            <a:pPr indent="0" marL="0">
+              <a:buNone/>
+            </a:pPr>
+            <a:r>
+              <a:rPr lang="en-US" sz="900" u="sng" dirty="0">
+                <a:solidFill>
+                  <a:srgbClr val="3A5BA0"/>
+                </a:solidFill>
+                <a:latin typeface="Consolas" pitchFamily="34" charset="0"/>
+                <a:ea typeface="Consolas" pitchFamily="34" charset="-122"/>
+                <a:cs typeface="Consolas" pitchFamily="34" charset="-120"/>
+                <a:hlinkClick r:id="rId1" invalidUrl="" action="" tgtFrame="" tooltip="" history="1" highlightClick="0" endSnd="0">
+                  <a:extLst>
+                    <a:ext uri="{A12FA001-AC4F-418D-AE19-62706E023703}">
+                      <ahyp:hlinkClr xmlns:ahyp="http://schemas.microsoft.com/office/drawing/2018/hyperlinkcolor" val="tx"/>
+                    </a:ext>
+                  </a:extLst>
+                </a:hlinkClick>
+              </a:rPr>
+              <a:t>docs/evolution_design_notes.md</a:t>
+            </a:r>
+            <a:pPr indent="0" marL="0">
+              <a:buNone/>
+            </a:pPr>
+            <a:r>
+              <a:rPr lang="en-US" sz="900" dirty="0">
+                <a:solidFill>
+                  <a:srgbClr val="6B7280"/>
+                </a:solidFill>
+                <a:latin typeface="Consolas" pitchFamily="34" charset="0"/>
+                <a:ea typeface="Consolas" pitchFamily="34" charset="-122"/>
+                <a:cs typeface="Consolas" pitchFamily="34" charset="-120"/>
+              </a:rPr>
+              <a:t> §3 ｜ 落地 src/tools/{interaction_tool_wrapper,retrieval_executor,tool_loader}.py</a:t>
             </a:r>
             <a:endParaRPr lang="en-US" sz="900" dirty="0"/>
           </a:p>
@@ -6123,7 +6249,77 @@
                 <a:ea typeface="Consolas" pitchFamily="34" charset="-122"/>
                 <a:cs typeface="Consolas" pitchFamily="34" charset="-120"/>
               </a:rPr>
-              <a:t>協議 retrieval_executor.py:28-30 ALLOWED_QUERIES/STRATEGIES（凍結）｜ 策略 agents_evolving.yaml:11-16 retrieval_policy</a:t>
+              <a:t>協議 </a:t>
+            </a:r>
+            <a:pPr indent="0" marL="0">
+              <a:buNone/>
+            </a:pPr>
+            <a:r>
+              <a:rPr lang="en-US" sz="900" u="sng" dirty="0">
+                <a:solidFill>
+                  <a:srgbClr val="3A5BA0"/>
+                </a:solidFill>
+                <a:latin typeface="Consolas" pitchFamily="34" charset="0"/>
+                <a:ea typeface="Consolas" pitchFamily="34" charset="-122"/>
+                <a:cs typeface="Consolas" pitchFamily="34" charset="-120"/>
+                <a:hlinkClick r:id="rId1" invalidUrl="" action="" tgtFrame="" tooltip="" history="1" highlightClick="0" endSnd="0">
+                  <a:extLst>
+                    <a:ext uri="{A12FA001-AC4F-418D-AE19-62706E023703}">
+                      <ahyp:hlinkClr xmlns:ahyp="http://schemas.microsoft.com/office/drawing/2018/hyperlinkcolor" val="tx"/>
+                    </a:ext>
+                  </a:extLst>
+                </a:hlinkClick>
+              </a:rPr>
+              <a:t>retrieval_executor.py:28-30</a:t>
+            </a:r>
+            <a:pPr indent="0" marL="0">
+              <a:buNone/>
+            </a:pPr>
+            <a:r>
+              <a:rPr lang="en-US" sz="900" dirty="0">
+                <a:solidFill>
+                  <a:srgbClr val="6B7280"/>
+                </a:solidFill>
+                <a:latin typeface="Consolas" pitchFamily="34" charset="0"/>
+                <a:ea typeface="Consolas" pitchFamily="34" charset="-122"/>
+                <a:cs typeface="Consolas" pitchFamily="34" charset="-120"/>
+              </a:rPr>
+              <a:t> ALLOWED_QUERIES/STRATEGIES（凍結）｜ 策略 </a:t>
+            </a:r>
+            <a:pPr indent="0" marL="0">
+              <a:buNone/>
+            </a:pPr>
+            <a:r>
+              <a:rPr lang="en-US" sz="900" u="sng" dirty="0">
+                <a:solidFill>
+                  <a:srgbClr val="3A5BA0"/>
+                </a:solidFill>
+                <a:latin typeface="Consolas" pitchFamily="34" charset="0"/>
+                <a:ea typeface="Consolas" pitchFamily="34" charset="-122"/>
+                <a:cs typeface="Consolas" pitchFamily="34" charset="-120"/>
+                <a:hlinkClick r:id="rId2" invalidUrl="" action="" tgtFrame="" tooltip="" history="1" highlightClick="0" endSnd="0">
+                  <a:extLst>
+                    <a:ext uri="{A12FA001-AC4F-418D-AE19-62706E023703}">
+                      <ahyp:hlinkClr xmlns:ahyp="http://schemas.microsoft.com/office/drawing/2018/hyperlinkcolor" val="tx"/>
+                    </a:ext>
+                  </a:extLst>
+                </a:hlinkClick>
+              </a:rPr>
+              <a:t>agents_evolving.yaml:11-16</a:t>
+            </a:r>
+            <a:pPr indent="0" marL="0">
+              <a:buNone/>
+            </a:pPr>
+            <a:r>
+              <a:rPr lang="en-US" sz="900" dirty="0">
+                <a:solidFill>
+                  <a:srgbClr val="6B7280"/>
+                </a:solidFill>
+                <a:latin typeface="Consolas" pitchFamily="34" charset="0"/>
+                <a:ea typeface="Consolas" pitchFamily="34" charset="-122"/>
+                <a:cs typeface="Consolas" pitchFamily="34" charset="-120"/>
+              </a:rPr>
+              <a:t> retrieval_policy</a:t>
             </a:r>
             <a:endParaRPr lang="en-US" sz="900" dirty="0"/>
           </a:p>
@@ -7013,15 +7209,106 @@
               <a:buNone/>
             </a:pPr>
             <a:r>
-              <a:rPr lang="en-US" sz="900" dirty="0">
-                <a:solidFill>
-                  <a:srgbClr val="6B7280"/>
+              <a:rPr lang="en-US" sz="900" u="sng" dirty="0">
+                <a:solidFill>
+                  <a:srgbClr val="3A5BA0"/>
                 </a:solidFill>
                 <a:latin typeface="Consolas" pitchFamily="34" charset="0"/>
                 <a:ea typeface="Consolas" pitchFamily="34" charset="-122"/>
                 <a:cs typeface="Consolas" pitchFamily="34" charset="-120"/>
-              </a:rPr>
-              <a:t>interaction_tool_wrapper.py:21 _record · :26 drain_tool_log ｜ openevolve_evaluator.py:31 _summarize_tool_use</a:t>
+                <a:hlinkClick r:id="rId1" invalidUrl="" action="" tgtFrame="" tooltip="" history="1" highlightClick="0" endSnd="0">
+                  <a:extLst>
+                    <a:ext uri="{A12FA001-AC4F-418D-AE19-62706E023703}">
+                      <ahyp:hlinkClr xmlns:ahyp="http://schemas.microsoft.com/office/drawing/2018/hyperlinkcolor" val="tx"/>
+                    </a:ext>
+                  </a:extLst>
+                </a:hlinkClick>
+              </a:rPr>
+              <a:t>interaction_tool_wrapper.py:21</a:t>
+            </a:r>
+            <a:pPr indent="0" marL="0">
+              <a:buNone/>
+            </a:pPr>
+            <a:r>
+              <a:rPr lang="en-US" sz="900" dirty="0">
+                <a:solidFill>
+                  <a:srgbClr val="6B7280"/>
+                </a:solidFill>
+                <a:latin typeface="Consolas" pitchFamily="34" charset="0"/>
+                <a:ea typeface="Consolas" pitchFamily="34" charset="-122"/>
+                <a:cs typeface="Consolas" pitchFamily="34" charset="-120"/>
+              </a:rPr>
+              <a:t> _record · </a:t>
+            </a:r>
+            <a:pPr indent="0" marL="0">
+              <a:buNone/>
+            </a:pPr>
+            <a:r>
+              <a:rPr lang="en-US" sz="900" u="sng" dirty="0">
+                <a:solidFill>
+                  <a:srgbClr val="3A5BA0"/>
+                </a:solidFill>
+                <a:latin typeface="Consolas" pitchFamily="34" charset="0"/>
+                <a:ea typeface="Consolas" pitchFamily="34" charset="-122"/>
+                <a:cs typeface="Consolas" pitchFamily="34" charset="-120"/>
+                <a:hlinkClick r:id="rId2" invalidUrl="" action="" tgtFrame="" tooltip="" history="1" highlightClick="0" endSnd="0">
+                  <a:extLst>
+                    <a:ext uri="{A12FA001-AC4F-418D-AE19-62706E023703}">
+                      <ahyp:hlinkClr xmlns:ahyp="http://schemas.microsoft.com/office/drawing/2018/hyperlinkcolor" val="tx"/>
+                    </a:ext>
+                  </a:extLst>
+                </a:hlinkClick>
+              </a:rPr>
+              <a:t>:26</a:t>
+            </a:r>
+            <a:pPr indent="0" marL="0">
+              <a:buNone/>
+            </a:pPr>
+            <a:r>
+              <a:rPr lang="en-US" sz="900" dirty="0">
+                <a:solidFill>
+                  <a:srgbClr val="6B7280"/>
+                </a:solidFill>
+                <a:latin typeface="Consolas" pitchFamily="34" charset="0"/>
+                <a:ea typeface="Consolas" pitchFamily="34" charset="-122"/>
+                <a:cs typeface="Consolas" pitchFamily="34" charset="-120"/>
+              </a:rPr>
+              <a:t> drain_tool_log ｜ </a:t>
+            </a:r>
+            <a:pPr indent="0" marL="0">
+              <a:buNone/>
+            </a:pPr>
+            <a:r>
+              <a:rPr lang="en-US" sz="900" u="sng" dirty="0">
+                <a:solidFill>
+                  <a:srgbClr val="3A5BA0"/>
+                </a:solidFill>
+                <a:latin typeface="Consolas" pitchFamily="34" charset="0"/>
+                <a:ea typeface="Consolas" pitchFamily="34" charset="-122"/>
+                <a:cs typeface="Consolas" pitchFamily="34" charset="-120"/>
+                <a:hlinkClick r:id="rId3" invalidUrl="" action="" tgtFrame="" tooltip="" history="1" highlightClick="0" endSnd="0">
+                  <a:extLst>
+                    <a:ext uri="{A12FA001-AC4F-418D-AE19-62706E023703}">
+                      <ahyp:hlinkClr xmlns:ahyp="http://schemas.microsoft.com/office/drawing/2018/hyperlinkcolor" val="tx"/>
+                    </a:ext>
+                  </a:extLst>
+                </a:hlinkClick>
+              </a:rPr>
+              <a:t>openevolve_evaluator.py:31</a:t>
+            </a:r>
+            <a:pPr indent="0" marL="0">
+              <a:buNone/>
+            </a:pPr>
+            <a:r>
+              <a:rPr lang="en-US" sz="900" dirty="0">
+                <a:solidFill>
+                  <a:srgbClr val="6B7280"/>
+                </a:solidFill>
+                <a:latin typeface="Consolas" pitchFamily="34" charset="0"/>
+                <a:ea typeface="Consolas" pitchFamily="34" charset="-122"/>
+                <a:cs typeface="Consolas" pitchFamily="34" charset="-120"/>
+              </a:rPr>
+              <a:t> _summarize_tool_use</a:t>
             </a:r>
             <a:endParaRPr lang="en-US" sz="900" dirty="0"/>
           </a:p>
@@ -7604,15 +7891,141 @@
               <a:buNone/>
             </a:pPr>
             <a:r>
-              <a:rPr lang="en-US" sz="900" dirty="0">
-                <a:solidFill>
-                  <a:srgbClr val="6B7280"/>
+              <a:rPr lang="en-US" sz="900" u="sng" dirty="0">
+                <a:solidFill>
+                  <a:srgbClr val="3A5BA0"/>
                 </a:solidFill>
                 <a:latin typeface="Consolas" pitchFamily="34" charset="0"/>
                 <a:ea typeface="Consolas" pitchFamily="34" charset="-122"/>
                 <a:cs typeface="Consolas" pitchFamily="34" charset="-120"/>
-              </a:rPr>
-              <a:t>retrieval_executor.py:44 _clamp_int · :53 normalize_policy · :29 ALLOWED_QUERIES · :140 execute_policy</a:t>
+                <a:hlinkClick r:id="rId1" invalidUrl="" action="" tgtFrame="" tooltip="" history="1" highlightClick="0" endSnd="0">
+                  <a:extLst>
+                    <a:ext uri="{A12FA001-AC4F-418D-AE19-62706E023703}">
+                      <ahyp:hlinkClr xmlns:ahyp="http://schemas.microsoft.com/office/drawing/2018/hyperlinkcolor" val="tx"/>
+                    </a:ext>
+                  </a:extLst>
+                </a:hlinkClick>
+              </a:rPr>
+              <a:t>retrieval_executor.py:44</a:t>
+            </a:r>
+            <a:pPr indent="0" marL="0">
+              <a:buNone/>
+            </a:pPr>
+            <a:r>
+              <a:rPr lang="en-US" sz="900" dirty="0">
+                <a:solidFill>
+                  <a:srgbClr val="6B7280"/>
+                </a:solidFill>
+                <a:latin typeface="Consolas" pitchFamily="34" charset="0"/>
+                <a:ea typeface="Consolas" pitchFamily="34" charset="-122"/>
+                <a:cs typeface="Consolas" pitchFamily="34" charset="-120"/>
+              </a:rPr>
+              <a:t> _clamp_int · </a:t>
+            </a:r>
+            <a:pPr indent="0" marL="0">
+              <a:buNone/>
+            </a:pPr>
+            <a:r>
+              <a:rPr lang="en-US" sz="900" u="sng" dirty="0">
+                <a:solidFill>
+                  <a:srgbClr val="3A5BA0"/>
+                </a:solidFill>
+                <a:latin typeface="Consolas" pitchFamily="34" charset="0"/>
+                <a:ea typeface="Consolas" pitchFamily="34" charset="-122"/>
+                <a:cs typeface="Consolas" pitchFamily="34" charset="-120"/>
+                <a:hlinkClick r:id="rId2" invalidUrl="" action="" tgtFrame="" tooltip="" history="1" highlightClick="0" endSnd="0">
+                  <a:extLst>
+                    <a:ext uri="{A12FA001-AC4F-418D-AE19-62706E023703}">
+                      <ahyp:hlinkClr xmlns:ahyp="http://schemas.microsoft.com/office/drawing/2018/hyperlinkcolor" val="tx"/>
+                    </a:ext>
+                  </a:extLst>
+                </a:hlinkClick>
+              </a:rPr>
+              <a:t>:53</a:t>
+            </a:r>
+            <a:pPr indent="0" marL="0">
+              <a:buNone/>
+            </a:pPr>
+            <a:r>
+              <a:rPr lang="en-US" sz="900" dirty="0">
+                <a:solidFill>
+                  <a:srgbClr val="6B7280"/>
+                </a:solidFill>
+                <a:latin typeface="Consolas" pitchFamily="34" charset="0"/>
+                <a:ea typeface="Consolas" pitchFamily="34" charset="-122"/>
+                <a:cs typeface="Consolas" pitchFamily="34" charset="-120"/>
+              </a:rPr>
+              <a:t> normalize_policy · </a:t>
+            </a:r>
+            <a:pPr indent="0" marL="0">
+              <a:buNone/>
+            </a:pPr>
+            <a:r>
+              <a:rPr lang="en-US" sz="900" u="sng" dirty="0">
+                <a:solidFill>
+                  <a:srgbClr val="3A5BA0"/>
+                </a:solidFill>
+                <a:latin typeface="Consolas" pitchFamily="34" charset="0"/>
+                <a:ea typeface="Consolas" pitchFamily="34" charset="-122"/>
+                <a:cs typeface="Consolas" pitchFamily="34" charset="-120"/>
+                <a:hlinkClick r:id="rId3" invalidUrl="" action="" tgtFrame="" tooltip="" history="1" highlightClick="0" endSnd="0">
+                  <a:extLst>
+                    <a:ext uri="{A12FA001-AC4F-418D-AE19-62706E023703}">
+                      <ahyp:hlinkClr xmlns:ahyp="http://schemas.microsoft.com/office/drawing/2018/hyperlinkcolor" val="tx"/>
+                    </a:ext>
+                  </a:extLst>
+                </a:hlinkClick>
+              </a:rPr>
+              <a:t>:29</a:t>
+            </a:r>
+            <a:pPr indent="0" marL="0">
+              <a:buNone/>
+            </a:pPr>
+            <a:r>
+              <a:rPr lang="en-US" sz="900" dirty="0">
+                <a:solidFill>
+                  <a:srgbClr val="6B7280"/>
+                </a:solidFill>
+                <a:latin typeface="Consolas" pitchFamily="34" charset="0"/>
+                <a:ea typeface="Consolas" pitchFamily="34" charset="-122"/>
+                <a:cs typeface="Consolas" pitchFamily="34" charset="-120"/>
+              </a:rPr>
+              <a:t> ALLOWED_QUERIES · </a:t>
+            </a:r>
+            <a:pPr indent="0" marL="0">
+              <a:buNone/>
+            </a:pPr>
+            <a:r>
+              <a:rPr lang="en-US" sz="900" u="sng" dirty="0">
+                <a:solidFill>
+                  <a:srgbClr val="3A5BA0"/>
+                </a:solidFill>
+                <a:latin typeface="Consolas" pitchFamily="34" charset="0"/>
+                <a:ea typeface="Consolas" pitchFamily="34" charset="-122"/>
+                <a:cs typeface="Consolas" pitchFamily="34" charset="-120"/>
+                <a:hlinkClick r:id="rId4" invalidUrl="" action="" tgtFrame="" tooltip="" history="1" highlightClick="0" endSnd="0">
+                  <a:extLst>
+                    <a:ext uri="{A12FA001-AC4F-418D-AE19-62706E023703}">
+                      <ahyp:hlinkClr xmlns:ahyp="http://schemas.microsoft.com/office/drawing/2018/hyperlinkcolor" val="tx"/>
+                    </a:ext>
+                  </a:extLst>
+                </a:hlinkClick>
+              </a:rPr>
+              <a:t>:140</a:t>
+            </a:r>
+            <a:pPr indent="0" marL="0">
+              <a:buNone/>
+            </a:pPr>
+            <a:r>
+              <a:rPr lang="en-US" sz="900" dirty="0">
+                <a:solidFill>
+                  <a:srgbClr val="6B7280"/>
+                </a:solidFill>
+                <a:latin typeface="Consolas" pitchFamily="34" charset="0"/>
+                <a:ea typeface="Consolas" pitchFamily="34" charset="-122"/>
+                <a:cs typeface="Consolas" pitchFamily="34" charset="-120"/>
+              </a:rPr>
+              <a:t> execute_policy</a:t>
             </a:r>
             <a:endParaRPr lang="en-US" sz="900" dirty="0"/>
           </a:p>
@@ -8176,15 +8589,71 @@
               <a:buNone/>
             </a:pPr>
             <a:r>
-              <a:rPr lang="en-US" sz="900" dirty="0">
-                <a:solidFill>
-                  <a:srgbClr val="6B7280"/>
+              <a:rPr lang="en-US" sz="900" u="sng" dirty="0">
+                <a:solidFill>
+                  <a:srgbClr val="3A5BA0"/>
                 </a:solidFill>
                 <a:latin typeface="Consolas" pitchFamily="34" charset="0"/>
                 <a:ea typeface="Consolas" pitchFamily="34" charset="-122"/>
                 <a:cs typeface="Consolas" pitchFamily="34" charset="-120"/>
-              </a:rPr>
-              <a:t>src/flows/serving_flow.py:85-93 execute_policy → retrieved_context 注入 ｜ simulation_crew.py:42-50 data_retriever 無 tools</a:t>
+                <a:hlinkClick r:id="rId1" invalidUrl="" action="" tgtFrame="" tooltip="" history="1" highlightClick="0" endSnd="0">
+                  <a:extLst>
+                    <a:ext uri="{A12FA001-AC4F-418D-AE19-62706E023703}">
+                      <ahyp:hlinkClr xmlns:ahyp="http://schemas.microsoft.com/office/drawing/2018/hyperlinkcolor" val="tx"/>
+                    </a:ext>
+                  </a:extLst>
+                </a:hlinkClick>
+              </a:rPr>
+              <a:t>src/flows/serving_flow.py:85-93</a:t>
+            </a:r>
+            <a:pPr indent="0" marL="0">
+              <a:buNone/>
+            </a:pPr>
+            <a:r>
+              <a:rPr lang="en-US" sz="900" dirty="0">
+                <a:solidFill>
+                  <a:srgbClr val="6B7280"/>
+                </a:solidFill>
+                <a:latin typeface="Consolas" pitchFamily="34" charset="0"/>
+                <a:ea typeface="Consolas" pitchFamily="34" charset="-122"/>
+                <a:cs typeface="Consolas" pitchFamily="34" charset="-120"/>
+              </a:rPr>
+              <a:t> execute_policy → retrieved_context 注入 ｜ </a:t>
+            </a:r>
+            <a:pPr indent="0" marL="0">
+              <a:buNone/>
+            </a:pPr>
+            <a:r>
+              <a:rPr lang="en-US" sz="900" u="sng" dirty="0">
+                <a:solidFill>
+                  <a:srgbClr val="3A5BA0"/>
+                </a:solidFill>
+                <a:latin typeface="Consolas" pitchFamily="34" charset="0"/>
+                <a:ea typeface="Consolas" pitchFamily="34" charset="-122"/>
+                <a:cs typeface="Consolas" pitchFamily="34" charset="-120"/>
+                <a:hlinkClick r:id="rId2" invalidUrl="" action="" tgtFrame="" tooltip="" history="1" highlightClick="0" endSnd="0">
+                  <a:extLst>
+                    <a:ext uri="{A12FA001-AC4F-418D-AE19-62706E023703}">
+                      <ahyp:hlinkClr xmlns:ahyp="http://schemas.microsoft.com/office/drawing/2018/hyperlinkcolor" val="tx"/>
+                    </a:ext>
+                  </a:extLst>
+                </a:hlinkClick>
+              </a:rPr>
+              <a:t>simulation_crew.py:42-50</a:t>
+            </a:r>
+            <a:pPr indent="0" marL="0">
+              <a:buNone/>
+            </a:pPr>
+            <a:r>
+              <a:rPr lang="en-US" sz="900" dirty="0">
+                <a:solidFill>
+                  <a:srgbClr val="6B7280"/>
+                </a:solidFill>
+                <a:latin typeface="Consolas" pitchFamily="34" charset="0"/>
+                <a:ea typeface="Consolas" pitchFamily="34" charset="-122"/>
+                <a:cs typeface="Consolas" pitchFamily="34" charset="-120"/>
+              </a:rPr>
+              <a:t> data_retriever 無 tools</a:t>
             </a:r>
             <a:endParaRPr lang="en-US" sz="900" dirty="0"/>
           </a:p>
@@ -9126,15 +9595,246 @@
               <a:buNone/>
             </a:pPr>
             <a:r>
-              <a:rPr lang="en-US" sz="900" dirty="0">
-                <a:solidFill>
-                  <a:srgbClr val="6B7280"/>
+              <a:rPr lang="en-US" sz="900" u="sng" dirty="0">
+                <a:solidFill>
+                  <a:srgbClr val="3A5BA0"/>
                 </a:solidFill>
                 <a:latin typeface="Consolas" pitchFamily="34" charset="0"/>
                 <a:ea typeface="Consolas" pitchFamily="34" charset="-122"/>
                 <a:cs typeface="Consolas" pitchFamily="34" charset="-120"/>
-              </a:rPr>
-              <a:t>tool_loader.py:77/:106/:120/:156 四關卡 · :60 ReadOnlyKit · :164 docstring ｜ simulation_crew.py:53-62 裝給 analyst</a:t>
+                <a:hlinkClick r:id="rId1" invalidUrl="" action="" tgtFrame="" tooltip="" history="1" highlightClick="0" endSnd="0">
+                  <a:extLst>
+                    <a:ext uri="{A12FA001-AC4F-418D-AE19-62706E023703}">
+                      <ahyp:hlinkClr xmlns:ahyp="http://schemas.microsoft.com/office/drawing/2018/hyperlinkcolor" val="tx"/>
+                    </a:ext>
+                  </a:extLst>
+                </a:hlinkClick>
+              </a:rPr>
+              <a:t>tool_loader.py:77</a:t>
+            </a:r>
+            <a:pPr indent="0" marL="0">
+              <a:buNone/>
+            </a:pPr>
+            <a:r>
+              <a:rPr lang="en-US" sz="900" dirty="0">
+                <a:solidFill>
+                  <a:srgbClr val="6B7280"/>
+                </a:solidFill>
+                <a:latin typeface="Consolas" pitchFamily="34" charset="0"/>
+                <a:ea typeface="Consolas" pitchFamily="34" charset="-122"/>
+                <a:cs typeface="Consolas" pitchFamily="34" charset="-120"/>
+              </a:rPr>
+              <a:t>/</a:t>
+            </a:r>
+            <a:pPr indent="0" marL="0">
+              <a:buNone/>
+            </a:pPr>
+            <a:r>
+              <a:rPr lang="en-US" sz="900" u="sng" dirty="0">
+                <a:solidFill>
+                  <a:srgbClr val="3A5BA0"/>
+                </a:solidFill>
+                <a:latin typeface="Consolas" pitchFamily="34" charset="0"/>
+                <a:ea typeface="Consolas" pitchFamily="34" charset="-122"/>
+                <a:cs typeface="Consolas" pitchFamily="34" charset="-120"/>
+                <a:hlinkClick r:id="rId2" invalidUrl="" action="" tgtFrame="" tooltip="" history="1" highlightClick="0" endSnd="0">
+                  <a:extLst>
+                    <a:ext uri="{A12FA001-AC4F-418D-AE19-62706E023703}">
+                      <ahyp:hlinkClr xmlns:ahyp="http://schemas.microsoft.com/office/drawing/2018/hyperlinkcolor" val="tx"/>
+                    </a:ext>
+                  </a:extLst>
+                </a:hlinkClick>
+              </a:rPr>
+              <a:t>:106</a:t>
+            </a:r>
+            <a:pPr indent="0" marL="0">
+              <a:buNone/>
+            </a:pPr>
+            <a:r>
+              <a:rPr lang="en-US" sz="900" dirty="0">
+                <a:solidFill>
+                  <a:srgbClr val="6B7280"/>
+                </a:solidFill>
+                <a:latin typeface="Consolas" pitchFamily="34" charset="0"/>
+                <a:ea typeface="Consolas" pitchFamily="34" charset="-122"/>
+                <a:cs typeface="Consolas" pitchFamily="34" charset="-120"/>
+              </a:rPr>
+              <a:t>/</a:t>
+            </a:r>
+            <a:pPr indent="0" marL="0">
+              <a:buNone/>
+            </a:pPr>
+            <a:r>
+              <a:rPr lang="en-US" sz="900" u="sng" dirty="0">
+                <a:solidFill>
+                  <a:srgbClr val="3A5BA0"/>
+                </a:solidFill>
+                <a:latin typeface="Consolas" pitchFamily="34" charset="0"/>
+                <a:ea typeface="Consolas" pitchFamily="34" charset="-122"/>
+                <a:cs typeface="Consolas" pitchFamily="34" charset="-120"/>
+                <a:hlinkClick r:id="rId3" invalidUrl="" action="" tgtFrame="" tooltip="" history="1" highlightClick="0" endSnd="0">
+                  <a:extLst>
+                    <a:ext uri="{A12FA001-AC4F-418D-AE19-62706E023703}">
+                      <ahyp:hlinkClr xmlns:ahyp="http://schemas.microsoft.com/office/drawing/2018/hyperlinkcolor" val="tx"/>
+                    </a:ext>
+                  </a:extLst>
+                </a:hlinkClick>
+              </a:rPr>
+              <a:t>:120</a:t>
+            </a:r>
+            <a:pPr indent="0" marL="0">
+              <a:buNone/>
+            </a:pPr>
+            <a:r>
+              <a:rPr lang="en-US" sz="900" dirty="0">
+                <a:solidFill>
+                  <a:srgbClr val="6B7280"/>
+                </a:solidFill>
+                <a:latin typeface="Consolas" pitchFamily="34" charset="0"/>
+                <a:ea typeface="Consolas" pitchFamily="34" charset="-122"/>
+                <a:cs typeface="Consolas" pitchFamily="34" charset="-120"/>
+              </a:rPr>
+              <a:t>/</a:t>
+            </a:r>
+            <a:pPr indent="0" marL="0">
+              <a:buNone/>
+            </a:pPr>
+            <a:r>
+              <a:rPr lang="en-US" sz="900" u="sng" dirty="0">
+                <a:solidFill>
+                  <a:srgbClr val="3A5BA0"/>
+                </a:solidFill>
+                <a:latin typeface="Consolas" pitchFamily="34" charset="0"/>
+                <a:ea typeface="Consolas" pitchFamily="34" charset="-122"/>
+                <a:cs typeface="Consolas" pitchFamily="34" charset="-120"/>
+                <a:hlinkClick r:id="rId4" invalidUrl="" action="" tgtFrame="" tooltip="" history="1" highlightClick="0" endSnd="0">
+                  <a:extLst>
+                    <a:ext uri="{A12FA001-AC4F-418D-AE19-62706E023703}">
+                      <ahyp:hlinkClr xmlns:ahyp="http://schemas.microsoft.com/office/drawing/2018/hyperlinkcolor" val="tx"/>
+                    </a:ext>
+                  </a:extLst>
+                </a:hlinkClick>
+              </a:rPr>
+              <a:t>:156</a:t>
+            </a:r>
+            <a:pPr indent="0" marL="0">
+              <a:buNone/>
+            </a:pPr>
+            <a:r>
+              <a:rPr lang="en-US" sz="900" dirty="0">
+                <a:solidFill>
+                  <a:srgbClr val="6B7280"/>
+                </a:solidFill>
+                <a:latin typeface="Consolas" pitchFamily="34" charset="0"/>
+                <a:ea typeface="Consolas" pitchFamily="34" charset="-122"/>
+                <a:cs typeface="Consolas" pitchFamily="34" charset="-120"/>
+              </a:rPr>
+              <a:t> 四關卡 · </a:t>
+            </a:r>
+            <a:pPr indent="0" marL="0">
+              <a:buNone/>
+            </a:pPr>
+            <a:r>
+              <a:rPr lang="en-US" sz="900" u="sng" dirty="0">
+                <a:solidFill>
+                  <a:srgbClr val="3A5BA0"/>
+                </a:solidFill>
+                <a:latin typeface="Consolas" pitchFamily="34" charset="0"/>
+                <a:ea typeface="Consolas" pitchFamily="34" charset="-122"/>
+                <a:cs typeface="Consolas" pitchFamily="34" charset="-120"/>
+                <a:hlinkClick r:id="rId5" invalidUrl="" action="" tgtFrame="" tooltip="" history="1" highlightClick="0" endSnd="0">
+                  <a:extLst>
+                    <a:ext uri="{A12FA001-AC4F-418D-AE19-62706E023703}">
+                      <ahyp:hlinkClr xmlns:ahyp="http://schemas.microsoft.com/office/drawing/2018/hyperlinkcolor" val="tx"/>
+                    </a:ext>
+                  </a:extLst>
+                </a:hlinkClick>
+              </a:rPr>
+              <a:t>:60</a:t>
+            </a:r>
+            <a:pPr indent="0" marL="0">
+              <a:buNone/>
+            </a:pPr>
+            <a:r>
+              <a:rPr lang="en-US" sz="900" dirty="0">
+                <a:solidFill>
+                  <a:srgbClr val="6B7280"/>
+                </a:solidFill>
+                <a:latin typeface="Consolas" pitchFamily="34" charset="0"/>
+                <a:ea typeface="Consolas" pitchFamily="34" charset="-122"/>
+                <a:cs typeface="Consolas" pitchFamily="34" charset="-120"/>
+              </a:rPr>
+              <a:t> ReadOnlyKit · </a:t>
+            </a:r>
+            <a:pPr indent="0" marL="0">
+              <a:buNone/>
+            </a:pPr>
+            <a:r>
+              <a:rPr lang="en-US" sz="900" u="sng" dirty="0">
+                <a:solidFill>
+                  <a:srgbClr val="3A5BA0"/>
+                </a:solidFill>
+                <a:latin typeface="Consolas" pitchFamily="34" charset="0"/>
+                <a:ea typeface="Consolas" pitchFamily="34" charset="-122"/>
+                <a:cs typeface="Consolas" pitchFamily="34" charset="-120"/>
+                <a:hlinkClick r:id="rId6" invalidUrl="" action="" tgtFrame="" tooltip="" history="1" highlightClick="0" endSnd="0">
+                  <a:extLst>
+                    <a:ext uri="{A12FA001-AC4F-418D-AE19-62706E023703}">
+                      <ahyp:hlinkClr xmlns:ahyp="http://schemas.microsoft.com/office/drawing/2018/hyperlinkcolor" val="tx"/>
+                    </a:ext>
+                  </a:extLst>
+                </a:hlinkClick>
+              </a:rPr>
+              <a:t>:164</a:t>
+            </a:r>
+            <a:pPr indent="0" marL="0">
+              <a:buNone/>
+            </a:pPr>
+            <a:r>
+              <a:rPr lang="en-US" sz="900" dirty="0">
+                <a:solidFill>
+                  <a:srgbClr val="6B7280"/>
+                </a:solidFill>
+                <a:latin typeface="Consolas" pitchFamily="34" charset="0"/>
+                <a:ea typeface="Consolas" pitchFamily="34" charset="-122"/>
+                <a:cs typeface="Consolas" pitchFamily="34" charset="-120"/>
+              </a:rPr>
+              <a:t> docstring ｜ </a:t>
+            </a:r>
+            <a:pPr indent="0" marL="0">
+              <a:buNone/>
+            </a:pPr>
+            <a:r>
+              <a:rPr lang="en-US" sz="900" u="sng" dirty="0">
+                <a:solidFill>
+                  <a:srgbClr val="3A5BA0"/>
+                </a:solidFill>
+                <a:latin typeface="Consolas" pitchFamily="34" charset="0"/>
+                <a:ea typeface="Consolas" pitchFamily="34" charset="-122"/>
+                <a:cs typeface="Consolas" pitchFamily="34" charset="-120"/>
+                <a:hlinkClick r:id="rId7" invalidUrl="" action="" tgtFrame="" tooltip="" history="1" highlightClick="0" endSnd="0">
+                  <a:extLst>
+                    <a:ext uri="{A12FA001-AC4F-418D-AE19-62706E023703}">
+                      <ahyp:hlinkClr xmlns:ahyp="http://schemas.microsoft.com/office/drawing/2018/hyperlinkcolor" val="tx"/>
+                    </a:ext>
+                  </a:extLst>
+                </a:hlinkClick>
+              </a:rPr>
+              <a:t>simulation_crew.py:53-62</a:t>
+            </a:r>
+            <a:pPr indent="0" marL="0">
+              <a:buNone/>
+            </a:pPr>
+            <a:r>
+              <a:rPr lang="en-US" sz="900" dirty="0">
+                <a:solidFill>
+                  <a:srgbClr val="6B7280"/>
+                </a:solidFill>
+                <a:latin typeface="Consolas" pitchFamily="34" charset="0"/>
+                <a:ea typeface="Consolas" pitchFamily="34" charset="-122"/>
+                <a:cs typeface="Consolas" pitchFamily="34" charset="-120"/>
+              </a:rPr>
+              <a:t> 裝給 analyst</a:t>
             </a:r>
             <a:endParaRPr lang="en-US" sz="900" dirty="0"/>
           </a:p>
@@ -9687,15 +10387,106 @@
               <a:buNone/>
             </a:pPr>
             <a:r>
-              <a:rPr lang="en-US" sz="900" dirty="0">
-                <a:solidFill>
-                  <a:srgbClr val="6B7280"/>
+              <a:rPr lang="en-US" sz="900" u="sng" dirty="0">
+                <a:solidFill>
+                  <a:srgbClr val="3A5BA0"/>
                 </a:solidFill>
                 <a:latin typeface="Consolas" pitchFamily="34" charset="0"/>
                 <a:ea typeface="Consolas" pitchFamily="34" charset="-122"/>
                 <a:cs typeface="Consolas" pitchFamily="34" charset="-120"/>
-              </a:rPr>
-              <a:t>evaluator.py:83-84 OPENEVOLVE_TASK_DIR · scripts/validate_holdout.py:25 切 holdout · create_sampled_dataset.py:8 disjoint</a:t>
+                <a:hlinkClick r:id="rId1" invalidUrl="" action="" tgtFrame="" tooltip="" history="1" highlightClick="0" endSnd="0">
+                  <a:extLst>
+                    <a:ext uri="{A12FA001-AC4F-418D-AE19-62706E023703}">
+                      <ahyp:hlinkClr xmlns:ahyp="http://schemas.microsoft.com/office/drawing/2018/hyperlinkcolor" val="tx"/>
+                    </a:ext>
+                  </a:extLst>
+                </a:hlinkClick>
+              </a:rPr>
+              <a:t>evaluator.py:83-84</a:t>
+            </a:r>
+            <a:pPr indent="0" marL="0">
+              <a:buNone/>
+            </a:pPr>
+            <a:r>
+              <a:rPr lang="en-US" sz="900" dirty="0">
+                <a:solidFill>
+                  <a:srgbClr val="6B7280"/>
+                </a:solidFill>
+                <a:latin typeface="Consolas" pitchFamily="34" charset="0"/>
+                <a:ea typeface="Consolas" pitchFamily="34" charset="-122"/>
+                <a:cs typeface="Consolas" pitchFamily="34" charset="-120"/>
+              </a:rPr>
+              <a:t> OPENEVOLVE_TASK_DIR · </a:t>
+            </a:r>
+            <a:pPr indent="0" marL="0">
+              <a:buNone/>
+            </a:pPr>
+            <a:r>
+              <a:rPr lang="en-US" sz="900" u="sng" dirty="0">
+                <a:solidFill>
+                  <a:srgbClr val="3A5BA0"/>
+                </a:solidFill>
+                <a:latin typeface="Consolas" pitchFamily="34" charset="0"/>
+                <a:ea typeface="Consolas" pitchFamily="34" charset="-122"/>
+                <a:cs typeface="Consolas" pitchFamily="34" charset="-120"/>
+                <a:hlinkClick r:id="rId2" invalidUrl="" action="" tgtFrame="" tooltip="" history="1" highlightClick="0" endSnd="0">
+                  <a:extLst>
+                    <a:ext uri="{A12FA001-AC4F-418D-AE19-62706E023703}">
+                      <ahyp:hlinkClr xmlns:ahyp="http://schemas.microsoft.com/office/drawing/2018/hyperlinkcolor" val="tx"/>
+                    </a:ext>
+                  </a:extLst>
+                </a:hlinkClick>
+              </a:rPr>
+              <a:t>scripts/validate_holdout.py:25</a:t>
+            </a:r>
+            <a:pPr indent="0" marL="0">
+              <a:buNone/>
+            </a:pPr>
+            <a:r>
+              <a:rPr lang="en-US" sz="900" dirty="0">
+                <a:solidFill>
+                  <a:srgbClr val="6B7280"/>
+                </a:solidFill>
+                <a:latin typeface="Consolas" pitchFamily="34" charset="0"/>
+                <a:ea typeface="Consolas" pitchFamily="34" charset="-122"/>
+                <a:cs typeface="Consolas" pitchFamily="34" charset="-120"/>
+              </a:rPr>
+              <a:t> 切 holdout · </a:t>
+            </a:r>
+            <a:pPr indent="0" marL="0">
+              <a:buNone/>
+            </a:pPr>
+            <a:r>
+              <a:rPr lang="en-US" sz="900" u="sng" dirty="0">
+                <a:solidFill>
+                  <a:srgbClr val="3A5BA0"/>
+                </a:solidFill>
+                <a:latin typeface="Consolas" pitchFamily="34" charset="0"/>
+                <a:ea typeface="Consolas" pitchFamily="34" charset="-122"/>
+                <a:cs typeface="Consolas" pitchFamily="34" charset="-120"/>
+                <a:hlinkClick r:id="rId3" invalidUrl="" action="" tgtFrame="" tooltip="" history="1" highlightClick="0" endSnd="0">
+                  <a:extLst>
+                    <a:ext uri="{A12FA001-AC4F-418D-AE19-62706E023703}">
+                      <ahyp:hlinkClr xmlns:ahyp="http://schemas.microsoft.com/office/drawing/2018/hyperlinkcolor" val="tx"/>
+                    </a:ext>
+                  </a:extLst>
+                </a:hlinkClick>
+              </a:rPr>
+              <a:t>create_sampled_dataset.py:8</a:t>
+            </a:r>
+            <a:pPr indent="0" marL="0">
+              <a:buNone/>
+            </a:pPr>
+            <a:r>
+              <a:rPr lang="en-US" sz="900" dirty="0">
+                <a:solidFill>
+                  <a:srgbClr val="6B7280"/>
+                </a:solidFill>
+                <a:latin typeface="Consolas" pitchFamily="34" charset="0"/>
+                <a:ea typeface="Consolas" pitchFamily="34" charset="-122"/>
+                <a:cs typeface="Consolas" pitchFamily="34" charset="-120"/>
+              </a:rPr>
+              <a:t> disjoint</a:t>
             </a:r>
             <a:endParaRPr lang="en-US" sz="900" dirty="0"/>
           </a:p>
@@ -10125,15 +10916,71 @@
               <a:buNone/>
             </a:pPr>
             <a:r>
-              <a:rPr lang="en-US" sz="900" dirty="0">
-                <a:solidFill>
-                  <a:srgbClr val="6B7280"/>
+              <a:rPr lang="en-US" sz="900" u="sng" dirty="0">
+                <a:solidFill>
+                  <a:srgbClr val="3A5BA0"/>
                 </a:solidFill>
                 <a:latin typeface="Consolas" pitchFamily="34" charset="0"/>
                 <a:ea typeface="Consolas" pitchFamily="34" charset="-122"/>
                 <a:cs typeface="Consolas" pitchFamily="34" charset="-120"/>
-              </a:rPr>
-              <a:t>config/openevolve_config.yaml:85-88 feature_dimensions（8×8）· openevolve_evaluator.py:47-59 _result(extra_metrics)</a:t>
+                <a:hlinkClick r:id="rId2" invalidUrl="" action="" tgtFrame="" tooltip="" history="1" highlightClick="0" endSnd="0">
+                  <a:extLst>
+                    <a:ext uri="{A12FA001-AC4F-418D-AE19-62706E023703}">
+                      <ahyp:hlinkClr xmlns:ahyp="http://schemas.microsoft.com/office/drawing/2018/hyperlinkcolor" val="tx"/>
+                    </a:ext>
+                  </a:extLst>
+                </a:hlinkClick>
+              </a:rPr>
+              <a:t>config/openevolve_config.yaml:85-88</a:t>
+            </a:r>
+            <a:pPr indent="0" marL="0">
+              <a:buNone/>
+            </a:pPr>
+            <a:r>
+              <a:rPr lang="en-US" sz="900" dirty="0">
+                <a:solidFill>
+                  <a:srgbClr val="6B7280"/>
+                </a:solidFill>
+                <a:latin typeface="Consolas" pitchFamily="34" charset="0"/>
+                <a:ea typeface="Consolas" pitchFamily="34" charset="-122"/>
+                <a:cs typeface="Consolas" pitchFamily="34" charset="-120"/>
+              </a:rPr>
+              <a:t> feature_dimensions（8×8）· </a:t>
+            </a:r>
+            <a:pPr indent="0" marL="0">
+              <a:buNone/>
+            </a:pPr>
+            <a:r>
+              <a:rPr lang="en-US" sz="900" u="sng" dirty="0">
+                <a:solidFill>
+                  <a:srgbClr val="3A5BA0"/>
+                </a:solidFill>
+                <a:latin typeface="Consolas" pitchFamily="34" charset="0"/>
+                <a:ea typeface="Consolas" pitchFamily="34" charset="-122"/>
+                <a:cs typeface="Consolas" pitchFamily="34" charset="-120"/>
+                <a:hlinkClick r:id="rId3" invalidUrl="" action="" tgtFrame="" tooltip="" history="1" highlightClick="0" endSnd="0">
+                  <a:extLst>
+                    <a:ext uri="{A12FA001-AC4F-418D-AE19-62706E023703}">
+                      <ahyp:hlinkClr xmlns:ahyp="http://schemas.microsoft.com/office/drawing/2018/hyperlinkcolor" val="tx"/>
+                    </a:ext>
+                  </a:extLst>
+                </a:hlinkClick>
+              </a:rPr>
+              <a:t>openevolve_evaluator.py:47-59</a:t>
+            </a:r>
+            <a:pPr indent="0" marL="0">
+              <a:buNone/>
+            </a:pPr>
+            <a:r>
+              <a:rPr lang="en-US" sz="900" dirty="0">
+                <a:solidFill>
+                  <a:srgbClr val="6B7280"/>
+                </a:solidFill>
+                <a:latin typeface="Consolas" pitchFamily="34" charset="0"/>
+                <a:ea typeface="Consolas" pitchFamily="34" charset="-122"/>
+                <a:cs typeface="Consolas" pitchFamily="34" charset="-120"/>
+              </a:rPr>
+              <a:t> _result(extra_metrics)</a:t>
             </a:r>
             <a:endParaRPr lang="en-US" sz="900" dirty="0"/>
           </a:p>
@@ -10709,15 +11556,127 @@
               <a:buNone/>
             </a:pPr>
             <a:r>
-              <a:rPr lang="en-US" sz="900" dirty="0">
-                <a:solidFill>
-                  <a:srgbClr val="6B7280"/>
+              <a:rPr lang="en-US" sz="900" u="sng" dirty="0">
+                <a:solidFill>
+                  <a:srgbClr val="3A5BA0"/>
                 </a:solidFill>
                 <a:latin typeface="Consolas" pitchFamily="34" charset="0"/>
                 <a:ea typeface="Consolas" pitchFamily="34" charset="-122"/>
                 <a:cs typeface="Consolas" pitchFamily="34" charset="-120"/>
-              </a:rPr>
-              <a:t>tool_loader.py:139-146 _safe_import · :164 docstring · simulation_crew.py:21-30 graceful [] · tests/test_tool_loader.py:185-203</a:t>
+                <a:hlinkClick r:id="rId1" invalidUrl="" action="" tgtFrame="" tooltip="" history="1" highlightClick="0" endSnd="0">
+                  <a:extLst>
+                    <a:ext uri="{A12FA001-AC4F-418D-AE19-62706E023703}">
+                      <ahyp:hlinkClr xmlns:ahyp="http://schemas.microsoft.com/office/drawing/2018/hyperlinkcolor" val="tx"/>
+                    </a:ext>
+                  </a:extLst>
+                </a:hlinkClick>
+              </a:rPr>
+              <a:t>tool_loader.py:139-146</a:t>
+            </a:r>
+            <a:pPr indent="0" marL="0">
+              <a:buNone/>
+            </a:pPr>
+            <a:r>
+              <a:rPr lang="en-US" sz="900" dirty="0">
+                <a:solidFill>
+                  <a:srgbClr val="6B7280"/>
+                </a:solidFill>
+                <a:latin typeface="Consolas" pitchFamily="34" charset="0"/>
+                <a:ea typeface="Consolas" pitchFamily="34" charset="-122"/>
+                <a:cs typeface="Consolas" pitchFamily="34" charset="-120"/>
+              </a:rPr>
+              <a:t> _safe_import · </a:t>
+            </a:r>
+            <a:pPr indent="0" marL="0">
+              <a:buNone/>
+            </a:pPr>
+            <a:r>
+              <a:rPr lang="en-US" sz="900" u="sng" dirty="0">
+                <a:solidFill>
+                  <a:srgbClr val="3A5BA0"/>
+                </a:solidFill>
+                <a:latin typeface="Consolas" pitchFamily="34" charset="0"/>
+                <a:ea typeface="Consolas" pitchFamily="34" charset="-122"/>
+                <a:cs typeface="Consolas" pitchFamily="34" charset="-120"/>
+                <a:hlinkClick r:id="rId2" invalidUrl="" action="" tgtFrame="" tooltip="" history="1" highlightClick="0" endSnd="0">
+                  <a:extLst>
+                    <a:ext uri="{A12FA001-AC4F-418D-AE19-62706E023703}">
+                      <ahyp:hlinkClr xmlns:ahyp="http://schemas.microsoft.com/office/drawing/2018/hyperlinkcolor" val="tx"/>
+                    </a:ext>
+                  </a:extLst>
+                </a:hlinkClick>
+              </a:rPr>
+              <a:t>:164</a:t>
+            </a:r>
+            <a:pPr indent="0" marL="0">
+              <a:buNone/>
+            </a:pPr>
+            <a:r>
+              <a:rPr lang="en-US" sz="900" dirty="0">
+                <a:solidFill>
+                  <a:srgbClr val="6B7280"/>
+                </a:solidFill>
+                <a:latin typeface="Consolas" pitchFamily="34" charset="0"/>
+                <a:ea typeface="Consolas" pitchFamily="34" charset="-122"/>
+                <a:cs typeface="Consolas" pitchFamily="34" charset="-120"/>
+              </a:rPr>
+              <a:t> docstring · </a:t>
+            </a:r>
+            <a:pPr indent="0" marL="0">
+              <a:buNone/>
+            </a:pPr>
+            <a:r>
+              <a:rPr lang="en-US" sz="900" u="sng" dirty="0">
+                <a:solidFill>
+                  <a:srgbClr val="3A5BA0"/>
+                </a:solidFill>
+                <a:latin typeface="Consolas" pitchFamily="34" charset="0"/>
+                <a:ea typeface="Consolas" pitchFamily="34" charset="-122"/>
+                <a:cs typeface="Consolas" pitchFamily="34" charset="-120"/>
+                <a:hlinkClick r:id="rId3" invalidUrl="" action="" tgtFrame="" tooltip="" history="1" highlightClick="0" endSnd="0">
+                  <a:extLst>
+                    <a:ext uri="{A12FA001-AC4F-418D-AE19-62706E023703}">
+                      <ahyp:hlinkClr xmlns:ahyp="http://schemas.microsoft.com/office/drawing/2018/hyperlinkcolor" val="tx"/>
+                    </a:ext>
+                  </a:extLst>
+                </a:hlinkClick>
+              </a:rPr>
+              <a:t>simulation_crew.py:21-30</a:t>
+            </a:r>
+            <a:pPr indent="0" marL="0">
+              <a:buNone/>
+            </a:pPr>
+            <a:r>
+              <a:rPr lang="en-US" sz="900" dirty="0">
+                <a:solidFill>
+                  <a:srgbClr val="6B7280"/>
+                </a:solidFill>
+                <a:latin typeface="Consolas" pitchFamily="34" charset="0"/>
+                <a:ea typeface="Consolas" pitchFamily="34" charset="-122"/>
+                <a:cs typeface="Consolas" pitchFamily="34" charset="-120"/>
+              </a:rPr>
+              <a:t> graceful [] · </a:t>
+            </a:r>
+            <a:pPr indent="0" marL="0">
+              <a:buNone/>
+            </a:pPr>
+            <a:r>
+              <a:rPr lang="en-US" sz="900" u="sng" dirty="0">
+                <a:solidFill>
+                  <a:srgbClr val="3A5BA0"/>
+                </a:solidFill>
+                <a:latin typeface="Consolas" pitchFamily="34" charset="0"/>
+                <a:ea typeface="Consolas" pitchFamily="34" charset="-122"/>
+                <a:cs typeface="Consolas" pitchFamily="34" charset="-120"/>
+                <a:hlinkClick r:id="rId4" invalidUrl="" action="" tgtFrame="" tooltip="" history="1" highlightClick="0" endSnd="0">
+                  <a:extLst>
+                    <a:ext uri="{A12FA001-AC4F-418D-AE19-62706E023703}">
+                      <ahyp:hlinkClr xmlns:ahyp="http://schemas.microsoft.com/office/drawing/2018/hyperlinkcolor" val="tx"/>
+                    </a:ext>
+                  </a:extLst>
+                </a:hlinkClick>
+              </a:rPr>
+              <a:t>tests/test_tool_loader.py:185-203</a:t>
             </a:r>
             <a:endParaRPr lang="en-US" sz="900" dirty="0"/>
           </a:p>
@@ -11241,7 +12200,77 @@
                 <a:ea typeface="Consolas" pitchFamily="34" charset="-122"/>
                 <a:cs typeface="Consolas" pitchFamily="34" charset="-120"/>
               </a:rPr>
-              <a:t>原則 CLAUDE.md Git 工作流程 ｜ 完整 50-iter 怎麼跑完 docs/evolution_design_notes.md §12.7(b)（nohup + caffeinate）</a:t>
+              <a:t>原則 </a:t>
+            </a:r>
+            <a:pPr indent="0" marL="0">
+              <a:buNone/>
+            </a:pPr>
+            <a:r>
+              <a:rPr lang="en-US" sz="900" u="sng" dirty="0">
+                <a:solidFill>
+                  <a:srgbClr val="3A5BA0"/>
+                </a:solidFill>
+                <a:latin typeface="Consolas" pitchFamily="34" charset="0"/>
+                <a:ea typeface="Consolas" pitchFamily="34" charset="-122"/>
+                <a:cs typeface="Consolas" pitchFamily="34" charset="-120"/>
+                <a:hlinkClick r:id="rId1" invalidUrl="" action="" tgtFrame="" tooltip="" history="1" highlightClick="0" endSnd="0">
+                  <a:extLst>
+                    <a:ext uri="{A12FA001-AC4F-418D-AE19-62706E023703}">
+                      <ahyp:hlinkClr xmlns:ahyp="http://schemas.microsoft.com/office/drawing/2018/hyperlinkcolor" val="tx"/>
+                    </a:ext>
+                  </a:extLst>
+                </a:hlinkClick>
+              </a:rPr>
+              <a:t>CLAUDE.md</a:t>
+            </a:r>
+            <a:pPr indent="0" marL="0">
+              <a:buNone/>
+            </a:pPr>
+            <a:r>
+              <a:rPr lang="en-US" sz="900" dirty="0">
+                <a:solidFill>
+                  <a:srgbClr val="6B7280"/>
+                </a:solidFill>
+                <a:latin typeface="Consolas" pitchFamily="34" charset="0"/>
+                <a:ea typeface="Consolas" pitchFamily="34" charset="-122"/>
+                <a:cs typeface="Consolas" pitchFamily="34" charset="-120"/>
+              </a:rPr>
+              <a:t> Git 工作流程 ｜ 完整 50-iter 怎麼跑完 </a:t>
+            </a:r>
+            <a:pPr indent="0" marL="0">
+              <a:buNone/>
+            </a:pPr>
+            <a:r>
+              <a:rPr lang="en-US" sz="900" u="sng" dirty="0">
+                <a:solidFill>
+                  <a:srgbClr val="3A5BA0"/>
+                </a:solidFill>
+                <a:latin typeface="Consolas" pitchFamily="34" charset="0"/>
+                <a:ea typeface="Consolas" pitchFamily="34" charset="-122"/>
+                <a:cs typeface="Consolas" pitchFamily="34" charset="-120"/>
+                <a:hlinkClick r:id="rId2" invalidUrl="" action="" tgtFrame="" tooltip="" history="1" highlightClick="0" endSnd="0">
+                  <a:extLst>
+                    <a:ext uri="{A12FA001-AC4F-418D-AE19-62706E023703}">
+                      <ahyp:hlinkClr xmlns:ahyp="http://schemas.microsoft.com/office/drawing/2018/hyperlinkcolor" val="tx"/>
+                    </a:ext>
+                  </a:extLst>
+                </a:hlinkClick>
+              </a:rPr>
+              <a:t>docs/evolution_design_notes.md</a:t>
+            </a:r>
+            <a:pPr indent="0" marL="0">
+              <a:buNone/>
+            </a:pPr>
+            <a:r>
+              <a:rPr lang="en-US" sz="900" dirty="0">
+                <a:solidFill>
+                  <a:srgbClr val="6B7280"/>
+                </a:solidFill>
+                <a:latin typeface="Consolas" pitchFamily="34" charset="0"/>
+                <a:ea typeface="Consolas" pitchFamily="34" charset="-122"/>
+                <a:cs typeface="Consolas" pitchFamily="34" charset="-120"/>
+              </a:rPr>
+              <a:t> §12.7(b)（nohup + caffeinate）</a:t>
             </a:r>
             <a:endParaRPr lang="en-US" sz="900" dirty="0"/>
           </a:p>
@@ -11979,7 +13008,42 @@
                 <a:ea typeface="Consolas" pitchFamily="34" charset="-122"/>
                 <a:cs typeface="Consolas" pitchFamily="34" charset="-120"/>
               </a:rPr>
-              <a:t>完整數據 docs/evolution_design_notes.md §12.7（完整架構 50-iter 端到端）</a:t>
+              <a:t>完整數據 </a:t>
+            </a:r>
+            <a:pPr indent="0" marL="0">
+              <a:buNone/>
+            </a:pPr>
+            <a:r>
+              <a:rPr lang="en-US" sz="900" u="sng" dirty="0">
+                <a:solidFill>
+                  <a:srgbClr val="3A5BA0"/>
+                </a:solidFill>
+                <a:latin typeface="Consolas" pitchFamily="34" charset="0"/>
+                <a:ea typeface="Consolas" pitchFamily="34" charset="-122"/>
+                <a:cs typeface="Consolas" pitchFamily="34" charset="-120"/>
+                <a:hlinkClick r:id="rId1" invalidUrl="" action="" tgtFrame="" tooltip="" history="1" highlightClick="0" endSnd="0">
+                  <a:extLst>
+                    <a:ext uri="{A12FA001-AC4F-418D-AE19-62706E023703}">
+                      <ahyp:hlinkClr xmlns:ahyp="http://schemas.microsoft.com/office/drawing/2018/hyperlinkcolor" val="tx"/>
+                    </a:ext>
+                  </a:extLst>
+                </a:hlinkClick>
+              </a:rPr>
+              <a:t>docs/evolution_design_notes.md</a:t>
+            </a:r>
+            <a:pPr indent="0" marL="0">
+              <a:buNone/>
+            </a:pPr>
+            <a:r>
+              <a:rPr lang="en-US" sz="900" dirty="0">
+                <a:solidFill>
+                  <a:srgbClr val="6B7280"/>
+                </a:solidFill>
+                <a:latin typeface="Consolas" pitchFamily="34" charset="0"/>
+                <a:ea typeface="Consolas" pitchFamily="34" charset="-122"/>
+                <a:cs typeface="Consolas" pitchFamily="34" charset="-120"/>
+              </a:rPr>
+              <a:t> §12.7（完整架構 50-iter 端到端）</a:t>
             </a:r>
             <a:endParaRPr lang="en-US" sz="900" dirty="0"/>
           </a:p>
@@ -12500,7 +13564,112 @@
                 <a:ea typeface="Consolas" pitchFamily="34" charset="-122"/>
                 <a:cs typeface="Consolas" pitchFamily="34" charset="-120"/>
               </a:rPr>
-              <a:t>三層護欄 interaction_tool_wrapper.py(L0) · retrieval_executor.py(L1) · tool_loader.py(L2) ｜ 數據 §12.7</a:t>
+              <a:t>三層護欄 </a:t>
+            </a:r>
+            <a:pPr indent="0" marL="0">
+              <a:buNone/>
+            </a:pPr>
+            <a:r>
+              <a:rPr lang="en-US" sz="900" u="sng" dirty="0">
+                <a:solidFill>
+                  <a:srgbClr val="3A5BA0"/>
+                </a:solidFill>
+                <a:latin typeface="Consolas" pitchFamily="34" charset="0"/>
+                <a:ea typeface="Consolas" pitchFamily="34" charset="-122"/>
+                <a:cs typeface="Consolas" pitchFamily="34" charset="-120"/>
+                <a:hlinkClick r:id="rId1" invalidUrl="" action="" tgtFrame="" tooltip="" history="1" highlightClick="0" endSnd="0">
+                  <a:extLst>
+                    <a:ext uri="{A12FA001-AC4F-418D-AE19-62706E023703}">
+                      <ahyp:hlinkClr xmlns:ahyp="http://schemas.microsoft.com/office/drawing/2018/hyperlinkcolor" val="tx"/>
+                    </a:ext>
+                  </a:extLst>
+                </a:hlinkClick>
+              </a:rPr>
+              <a:t>interaction_tool_wrapper.py</a:t>
+            </a:r>
+            <a:pPr indent="0" marL="0">
+              <a:buNone/>
+            </a:pPr>
+            <a:r>
+              <a:rPr lang="en-US" sz="900" dirty="0">
+                <a:solidFill>
+                  <a:srgbClr val="6B7280"/>
+                </a:solidFill>
+                <a:latin typeface="Consolas" pitchFamily="34" charset="0"/>
+                <a:ea typeface="Consolas" pitchFamily="34" charset="-122"/>
+                <a:cs typeface="Consolas" pitchFamily="34" charset="-120"/>
+              </a:rPr>
+              <a:t>(L0) · </a:t>
+            </a:r>
+            <a:pPr indent="0" marL="0">
+              <a:buNone/>
+            </a:pPr>
+            <a:r>
+              <a:rPr lang="en-US" sz="900" u="sng" dirty="0">
+                <a:solidFill>
+                  <a:srgbClr val="3A5BA0"/>
+                </a:solidFill>
+                <a:latin typeface="Consolas" pitchFamily="34" charset="0"/>
+                <a:ea typeface="Consolas" pitchFamily="34" charset="-122"/>
+                <a:cs typeface="Consolas" pitchFamily="34" charset="-120"/>
+                <a:hlinkClick r:id="rId2" invalidUrl="" action="" tgtFrame="" tooltip="" history="1" highlightClick="0" endSnd="0">
+                  <a:extLst>
+                    <a:ext uri="{A12FA001-AC4F-418D-AE19-62706E023703}">
+                      <ahyp:hlinkClr xmlns:ahyp="http://schemas.microsoft.com/office/drawing/2018/hyperlinkcolor" val="tx"/>
+                    </a:ext>
+                  </a:extLst>
+                </a:hlinkClick>
+              </a:rPr>
+              <a:t>retrieval_executor.py</a:t>
+            </a:r>
+            <a:pPr indent="0" marL="0">
+              <a:buNone/>
+            </a:pPr>
+            <a:r>
+              <a:rPr lang="en-US" sz="900" dirty="0">
+                <a:solidFill>
+                  <a:srgbClr val="6B7280"/>
+                </a:solidFill>
+                <a:latin typeface="Consolas" pitchFamily="34" charset="0"/>
+                <a:ea typeface="Consolas" pitchFamily="34" charset="-122"/>
+                <a:cs typeface="Consolas" pitchFamily="34" charset="-120"/>
+              </a:rPr>
+              <a:t>(L1) · </a:t>
+            </a:r>
+            <a:pPr indent="0" marL="0">
+              <a:buNone/>
+            </a:pPr>
+            <a:r>
+              <a:rPr lang="en-US" sz="900" u="sng" dirty="0">
+                <a:solidFill>
+                  <a:srgbClr val="3A5BA0"/>
+                </a:solidFill>
+                <a:latin typeface="Consolas" pitchFamily="34" charset="0"/>
+                <a:ea typeface="Consolas" pitchFamily="34" charset="-122"/>
+                <a:cs typeface="Consolas" pitchFamily="34" charset="-120"/>
+                <a:hlinkClick r:id="rId3" invalidUrl="" action="" tgtFrame="" tooltip="" history="1" highlightClick="0" endSnd="0">
+                  <a:extLst>
+                    <a:ext uri="{A12FA001-AC4F-418D-AE19-62706E023703}">
+                      <ahyp:hlinkClr xmlns:ahyp="http://schemas.microsoft.com/office/drawing/2018/hyperlinkcolor" val="tx"/>
+                    </a:ext>
+                  </a:extLst>
+                </a:hlinkClick>
+              </a:rPr>
+              <a:t>tool_loader.py</a:t>
+            </a:r>
+            <a:pPr indent="0" marL="0">
+              <a:buNone/>
+            </a:pPr>
+            <a:r>
+              <a:rPr lang="en-US" sz="900" dirty="0">
+                <a:solidFill>
+                  <a:srgbClr val="6B7280"/>
+                </a:solidFill>
+                <a:latin typeface="Consolas" pitchFamily="34" charset="0"/>
+                <a:ea typeface="Consolas" pitchFamily="34" charset="-122"/>
+                <a:cs typeface="Consolas" pitchFamily="34" charset="-120"/>
+              </a:rPr>
+              <a:t>(L2) ｜ 數據 §12.7</a:t>
             </a:r>
             <a:endParaRPr lang="en-US" sz="900" dirty="0"/>
           </a:p>
@@ -13567,7 +14736,42 @@
                 <a:ea typeface="Consolas" pitchFamily="34" charset="-122"/>
                 <a:cs typeface="Consolas" pitchFamily="34" charset="-120"/>
               </a:rPr>
-              <a:t>五模式完整版 docs/collaboration_workflow_outline.md（Part 3）</a:t>
+              <a:t>五模式完整版 </a:t>
+            </a:r>
+            <a:pPr indent="0" marL="0">
+              <a:buNone/>
+            </a:pPr>
+            <a:r>
+              <a:rPr lang="en-US" sz="900" u="sng" dirty="0">
+                <a:solidFill>
+                  <a:srgbClr val="3A5BA0"/>
+                </a:solidFill>
+                <a:latin typeface="Consolas" pitchFamily="34" charset="0"/>
+                <a:ea typeface="Consolas" pitchFamily="34" charset="-122"/>
+                <a:cs typeface="Consolas" pitchFamily="34" charset="-120"/>
+                <a:hlinkClick r:id="rId1" invalidUrl="" action="" tgtFrame="" tooltip="" history="1" highlightClick="0" endSnd="0">
+                  <a:extLst>
+                    <a:ext uri="{A12FA001-AC4F-418D-AE19-62706E023703}">
+                      <ahyp:hlinkClr xmlns:ahyp="http://schemas.microsoft.com/office/drawing/2018/hyperlinkcolor" val="tx"/>
+                    </a:ext>
+                  </a:extLst>
+                </a:hlinkClick>
+              </a:rPr>
+              <a:t>docs/collaboration_workflow_outline.md</a:t>
+            </a:r>
+            <a:pPr indent="0" marL="0">
+              <a:buNone/>
+            </a:pPr>
+            <a:r>
+              <a:rPr lang="en-US" sz="900" dirty="0">
+                <a:solidFill>
+                  <a:srgbClr val="6B7280"/>
+                </a:solidFill>
+                <a:latin typeface="Consolas" pitchFamily="34" charset="0"/>
+                <a:ea typeface="Consolas" pitchFamily="34" charset="-122"/>
+                <a:cs typeface="Consolas" pitchFamily="34" charset="-120"/>
+              </a:rPr>
+              <a:t>（Part 3）</a:t>
             </a:r>
             <a:endParaRPr lang="en-US" sz="900" dirty="0"/>
           </a:p>
@@ -14362,7 +15566,77 @@
                 <a:ea typeface="Consolas" pitchFamily="34" charset="-122"/>
                 <a:cs typeface="Consolas" pitchFamily="34" charset="-120"/>
               </a:rPr>
-              <a:t>進化目標檔 config/agents_evolving.yaml EVOLVE-BLOCK · iter22 數據 docs/evolution_design_notes.md §12.7(b)</a:t>
+              <a:t>進化目標檔 </a:t>
+            </a:r>
+            <a:pPr indent="0" marL="0">
+              <a:buNone/>
+            </a:pPr>
+            <a:r>
+              <a:rPr lang="en-US" sz="900" u="sng" dirty="0">
+                <a:solidFill>
+                  <a:srgbClr val="3A5BA0"/>
+                </a:solidFill>
+                <a:latin typeface="Consolas" pitchFamily="34" charset="0"/>
+                <a:ea typeface="Consolas" pitchFamily="34" charset="-122"/>
+                <a:cs typeface="Consolas" pitchFamily="34" charset="-120"/>
+                <a:hlinkClick r:id="rId1" invalidUrl="" action="" tgtFrame="" tooltip="" history="1" highlightClick="0" endSnd="0">
+                  <a:extLst>
+                    <a:ext uri="{A12FA001-AC4F-418D-AE19-62706E023703}">
+                      <ahyp:hlinkClr xmlns:ahyp="http://schemas.microsoft.com/office/drawing/2018/hyperlinkcolor" val="tx"/>
+                    </a:ext>
+                  </a:extLst>
+                </a:hlinkClick>
+              </a:rPr>
+              <a:t>config/agents_evolving.yaml</a:t>
+            </a:r>
+            <a:pPr indent="0" marL="0">
+              <a:buNone/>
+            </a:pPr>
+            <a:r>
+              <a:rPr lang="en-US" sz="900" dirty="0">
+                <a:solidFill>
+                  <a:srgbClr val="6B7280"/>
+                </a:solidFill>
+                <a:latin typeface="Consolas" pitchFamily="34" charset="0"/>
+                <a:ea typeface="Consolas" pitchFamily="34" charset="-122"/>
+                <a:cs typeface="Consolas" pitchFamily="34" charset="-120"/>
+              </a:rPr>
+              <a:t> EVOLVE-BLOCK · iter22 數據 </a:t>
+            </a:r>
+            <a:pPr indent="0" marL="0">
+              <a:buNone/>
+            </a:pPr>
+            <a:r>
+              <a:rPr lang="en-US" sz="900" u="sng" dirty="0">
+                <a:solidFill>
+                  <a:srgbClr val="3A5BA0"/>
+                </a:solidFill>
+                <a:latin typeface="Consolas" pitchFamily="34" charset="0"/>
+                <a:ea typeface="Consolas" pitchFamily="34" charset="-122"/>
+                <a:cs typeface="Consolas" pitchFamily="34" charset="-120"/>
+                <a:hlinkClick r:id="rId2" invalidUrl="" action="" tgtFrame="" tooltip="" history="1" highlightClick="0" endSnd="0">
+                  <a:extLst>
+                    <a:ext uri="{A12FA001-AC4F-418D-AE19-62706E023703}">
+                      <ahyp:hlinkClr xmlns:ahyp="http://schemas.microsoft.com/office/drawing/2018/hyperlinkcolor" val="tx"/>
+                    </a:ext>
+                  </a:extLst>
+                </a:hlinkClick>
+              </a:rPr>
+              <a:t>docs/evolution_design_notes.md</a:t>
+            </a:r>
+            <a:pPr indent="0" marL="0">
+              <a:buNone/>
+            </a:pPr>
+            <a:r>
+              <a:rPr lang="en-US" sz="900" dirty="0">
+                <a:solidFill>
+                  <a:srgbClr val="6B7280"/>
+                </a:solidFill>
+                <a:latin typeface="Consolas" pitchFamily="34" charset="0"/>
+                <a:ea typeface="Consolas" pitchFamily="34" charset="-122"/>
+                <a:cs typeface="Consolas" pitchFamily="34" charset="-120"/>
+              </a:rPr>
+              <a:t> §12.7(b)</a:t>
             </a:r>
             <a:endParaRPr lang="en-US" sz="900" dirty="0"/>
           </a:p>
@@ -15065,7 +16339,42 @@
                 <a:ea typeface="Consolas" pitchFamily="34" charset="-122"/>
                 <a:cs typeface="Consolas" pitchFamily="34" charset="-120"/>
               </a:rPr>
-              <a:t>島/遷移 config/openevolve_config.yaml:71-78（num_islands:3, migration）· 數據 design notes §12.7(b)</a:t>
+              <a:t>島/遷移 </a:t>
+            </a:r>
+            <a:pPr indent="0" marL="0">
+              <a:buNone/>
+            </a:pPr>
+            <a:r>
+              <a:rPr lang="en-US" sz="900" u="sng" dirty="0">
+                <a:solidFill>
+                  <a:srgbClr val="3A5BA0"/>
+                </a:solidFill>
+                <a:latin typeface="Consolas" pitchFamily="34" charset="0"/>
+                <a:ea typeface="Consolas" pitchFamily="34" charset="-122"/>
+                <a:cs typeface="Consolas" pitchFamily="34" charset="-120"/>
+                <a:hlinkClick r:id="rId1" invalidUrl="" action="" tgtFrame="" tooltip="" history="1" highlightClick="0" endSnd="0">
+                  <a:extLst>
+                    <a:ext uri="{A12FA001-AC4F-418D-AE19-62706E023703}">
+                      <ahyp:hlinkClr xmlns:ahyp="http://schemas.microsoft.com/office/drawing/2018/hyperlinkcolor" val="tx"/>
+                    </a:ext>
+                  </a:extLst>
+                </a:hlinkClick>
+              </a:rPr>
+              <a:t>config/openevolve_config.yaml:71-78</a:t>
+            </a:r>
+            <a:pPr indent="0" marL="0">
+              <a:buNone/>
+            </a:pPr>
+            <a:r>
+              <a:rPr lang="en-US" sz="900" dirty="0">
+                <a:solidFill>
+                  <a:srgbClr val="6B7280"/>
+                </a:solidFill>
+                <a:latin typeface="Consolas" pitchFamily="34" charset="0"/>
+                <a:ea typeface="Consolas" pitchFamily="34" charset="-122"/>
+                <a:cs typeface="Consolas" pitchFamily="34" charset="-120"/>
+              </a:rPr>
+              <a:t>（num_islands:3, migration）· 數據 design notes §12.7(b)</a:t>
             </a:r>
             <a:endParaRPr lang="en-US" sz="900" dirty="0"/>
           </a:p>
@@ -15536,7 +16845,63 @@
                 <a:ea typeface="Consolas" pitchFamily="34" charset="-122"/>
                 <a:cs typeface="Consolas" pitchFamily="34" charset="-120"/>
               </a:rPr>
-              <a:t>8/50 低分歸因 docs/evolution_design_notes.md §12.7(b) · diff_based_evolution:false 見 openevolve_config.yaml:18</a:t>
+              <a:t>8/50 低分歸因 </a:t>
+            </a:r>
+            <a:pPr indent="0" marL="0">
+              <a:buNone/>
+            </a:pPr>
+            <a:r>
+              <a:rPr lang="en-US" sz="900" u="sng" dirty="0">
+                <a:solidFill>
+                  <a:srgbClr val="3A5BA0"/>
+                </a:solidFill>
+                <a:latin typeface="Consolas" pitchFamily="34" charset="0"/>
+                <a:ea typeface="Consolas" pitchFamily="34" charset="-122"/>
+                <a:cs typeface="Consolas" pitchFamily="34" charset="-120"/>
+                <a:hlinkClick r:id="rId1" invalidUrl="" action="" tgtFrame="" tooltip="" history="1" highlightClick="0" endSnd="0">
+                  <a:extLst>
+                    <a:ext uri="{A12FA001-AC4F-418D-AE19-62706E023703}">
+                      <ahyp:hlinkClr xmlns:ahyp="http://schemas.microsoft.com/office/drawing/2018/hyperlinkcolor" val="tx"/>
+                    </a:ext>
+                  </a:extLst>
+                </a:hlinkClick>
+              </a:rPr>
+              <a:t>docs/evolution_design_notes.md</a:t>
+            </a:r>
+            <a:pPr indent="0" marL="0">
+              <a:buNone/>
+            </a:pPr>
+            <a:r>
+              <a:rPr lang="en-US" sz="900" dirty="0">
+                <a:solidFill>
+                  <a:srgbClr val="6B7280"/>
+                </a:solidFill>
+                <a:latin typeface="Consolas" pitchFamily="34" charset="0"/>
+                <a:ea typeface="Consolas" pitchFamily="34" charset="-122"/>
+                <a:cs typeface="Consolas" pitchFamily="34" charset="-120"/>
+              </a:rPr>
+              <a:t> §12.7(b) · diff_based_evolution:false 見 </a:t>
+            </a:r>
+            <a:pPr indent="0" marL="0">
+              <a:buNone/>
+            </a:pPr>
+            <a:r>
+              <a:rPr lang="en-US" sz="900" u="sng" dirty="0">
+                <a:solidFill>
+                  <a:srgbClr val="3A5BA0"/>
+                </a:solidFill>
+                <a:latin typeface="Consolas" pitchFamily="34" charset="0"/>
+                <a:ea typeface="Consolas" pitchFamily="34" charset="-122"/>
+                <a:cs typeface="Consolas" pitchFamily="34" charset="-120"/>
+                <a:hlinkClick r:id="rId2" invalidUrl="" action="" tgtFrame="" tooltip="" history="1" highlightClick="0" endSnd="0">
+                  <a:extLst>
+                    <a:ext uri="{A12FA001-AC4F-418D-AE19-62706E023703}">
+                      <ahyp:hlinkClr xmlns:ahyp="http://schemas.microsoft.com/office/drawing/2018/hyperlinkcolor" val="tx"/>
+                    </a:ext>
+                  </a:extLst>
+                </a:hlinkClick>
+              </a:rPr>
+              <a:t>openevolve_config.yaml:18</a:t>
             </a:r>
             <a:endParaRPr lang="en-US" sz="900" dirty="0"/>
           </a:p>
@@ -16217,7 +17582,77 @@
                 <a:ea typeface="Consolas" pitchFamily="34" charset="-122"/>
                 <a:cs typeface="Consolas" pitchFamily="34" charset="-120"/>
               </a:rPr>
-              <a:t>對應：我→config/*.yaml ｜ Claude→src/ + tests/ ｜ 進化→EVOLVE-BLOCK（agents_evolving.yaml / evolvable_tools.py）</a:t>
+              <a:t>對應：我→config/*.yaml ｜ Claude→src/ + tests/ ｜ 進化→EVOLVE-BLOCK（</a:t>
+            </a:r>
+            <a:pPr indent="0" marL="0">
+              <a:buNone/>
+            </a:pPr>
+            <a:r>
+              <a:rPr lang="en-US" sz="900" u="sng" dirty="0">
+                <a:solidFill>
+                  <a:srgbClr val="3A5BA0"/>
+                </a:solidFill>
+                <a:latin typeface="Consolas" pitchFamily="34" charset="0"/>
+                <a:ea typeface="Consolas" pitchFamily="34" charset="-122"/>
+                <a:cs typeface="Consolas" pitchFamily="34" charset="-120"/>
+                <a:hlinkClick r:id="rId1" invalidUrl="" action="" tgtFrame="" tooltip="" history="1" highlightClick="0" endSnd="0">
+                  <a:extLst>
+                    <a:ext uri="{A12FA001-AC4F-418D-AE19-62706E023703}">
+                      <ahyp:hlinkClr xmlns:ahyp="http://schemas.microsoft.com/office/drawing/2018/hyperlinkcolor" val="tx"/>
+                    </a:ext>
+                  </a:extLst>
+                </a:hlinkClick>
+              </a:rPr>
+              <a:t>agents_evolving.yaml</a:t>
+            </a:r>
+            <a:pPr indent="0" marL="0">
+              <a:buNone/>
+            </a:pPr>
+            <a:r>
+              <a:rPr lang="en-US" sz="900" dirty="0">
+                <a:solidFill>
+                  <a:srgbClr val="6B7280"/>
+                </a:solidFill>
+                <a:latin typeface="Consolas" pitchFamily="34" charset="0"/>
+                <a:ea typeface="Consolas" pitchFamily="34" charset="-122"/>
+                <a:cs typeface="Consolas" pitchFamily="34" charset="-120"/>
+              </a:rPr>
+              <a:t> / </a:t>
+            </a:r>
+            <a:pPr indent="0" marL="0">
+              <a:buNone/>
+            </a:pPr>
+            <a:r>
+              <a:rPr lang="en-US" sz="900" u="sng" dirty="0">
+                <a:solidFill>
+                  <a:srgbClr val="3A5BA0"/>
+                </a:solidFill>
+                <a:latin typeface="Consolas" pitchFamily="34" charset="0"/>
+                <a:ea typeface="Consolas" pitchFamily="34" charset="-122"/>
+                <a:cs typeface="Consolas" pitchFamily="34" charset="-120"/>
+                <a:hlinkClick r:id="rId2" invalidUrl="" action="" tgtFrame="" tooltip="" history="1" highlightClick="0" endSnd="0">
+                  <a:extLst>
+                    <a:ext uri="{A12FA001-AC4F-418D-AE19-62706E023703}">
+                      <ahyp:hlinkClr xmlns:ahyp="http://schemas.microsoft.com/office/drawing/2018/hyperlinkcolor" val="tx"/>
+                    </a:ext>
+                  </a:extLst>
+                </a:hlinkClick>
+              </a:rPr>
+              <a:t>evolvable_tools.py</a:t>
+            </a:r>
+            <a:pPr indent="0" marL="0">
+              <a:buNone/>
+            </a:pPr>
+            <a:r>
+              <a:rPr lang="en-US" sz="900" dirty="0">
+                <a:solidFill>
+                  <a:srgbClr val="6B7280"/>
+                </a:solidFill>
+                <a:latin typeface="Consolas" pitchFamily="34" charset="0"/>
+                <a:ea typeface="Consolas" pitchFamily="34" charset="-122"/>
+                <a:cs typeface="Consolas" pitchFamily="34" charset="-120"/>
+              </a:rPr>
+              <a:t>）</a:t>
             </a:r>
             <a:endParaRPr lang="en-US" sz="900" dirty="0"/>
           </a:p>
@@ -16959,7 +18394,42 @@
                 <a:ea typeface="Consolas" pitchFamily="34" charset="-122"/>
                 <a:cs typeface="Consolas" pitchFamily="34" charset="-120"/>
               </a:rPr>
-              <a:t>原則出處 docs/evolution_design_notes.md §3 分類學 · §4 協議/策略分離 · §12.7 數據</a:t>
+              <a:t>原則出處 </a:t>
+            </a:r>
+            <a:pPr indent="0" marL="0">
+              <a:buNone/>
+            </a:pPr>
+            <a:r>
+              <a:rPr lang="en-US" sz="900" u="sng" dirty="0">
+                <a:solidFill>
+                  <a:srgbClr val="3A5BA0"/>
+                </a:solidFill>
+                <a:latin typeface="Consolas" pitchFamily="34" charset="0"/>
+                <a:ea typeface="Consolas" pitchFamily="34" charset="-122"/>
+                <a:cs typeface="Consolas" pitchFamily="34" charset="-120"/>
+                <a:hlinkClick r:id="rId1" invalidUrl="" action="" tgtFrame="" tooltip="" history="1" highlightClick="0" endSnd="0">
+                  <a:extLst>
+                    <a:ext uri="{A12FA001-AC4F-418D-AE19-62706E023703}">
+                      <ahyp:hlinkClr xmlns:ahyp="http://schemas.microsoft.com/office/drawing/2018/hyperlinkcolor" val="tx"/>
+                    </a:ext>
+                  </a:extLst>
+                </a:hlinkClick>
+              </a:rPr>
+              <a:t>docs/evolution_design_notes.md</a:t>
+            </a:r>
+            <a:pPr indent="0" marL="0">
+              <a:buNone/>
+            </a:pPr>
+            <a:r>
+              <a:rPr lang="en-US" sz="900" dirty="0">
+                <a:solidFill>
+                  <a:srgbClr val="6B7280"/>
+                </a:solidFill>
+                <a:latin typeface="Consolas" pitchFamily="34" charset="0"/>
+                <a:ea typeface="Consolas" pitchFamily="34" charset="-122"/>
+                <a:cs typeface="Consolas" pitchFamily="34" charset="-120"/>
+              </a:rPr>
+              <a:t> §3 分類學 · §4 協議/策略分離 · §12.7 數據</a:t>
             </a:r>
             <a:endParaRPr lang="en-US" sz="900" dirty="0"/>
           </a:p>
@@ -17479,7 +18949,42 @@
                 <a:ea typeface="Consolas" pitchFamily="34" charset="-122"/>
                 <a:cs typeface="Consolas" pitchFamily="34" charset="-120"/>
               </a:rPr>
-              <a:t>技術深入 docs/evolution_design_notes.md ｜ 三份大綱皆在 docs/</a:t>
+              <a:t>技術深入 </a:t>
+            </a:r>
+            <a:pPr indent="0" marL="0">
+              <a:buNone/>
+            </a:pPr>
+            <a:r>
+              <a:rPr lang="en-US" sz="900" u="sng" dirty="0">
+                <a:solidFill>
+                  <a:srgbClr val="CADCFC"/>
+                </a:solidFill>
+                <a:latin typeface="Consolas" pitchFamily="34" charset="0"/>
+                <a:ea typeface="Consolas" pitchFamily="34" charset="-122"/>
+                <a:cs typeface="Consolas" pitchFamily="34" charset="-120"/>
+                <a:hlinkClick r:id="rId1" invalidUrl="" action="" tgtFrame="" tooltip="" history="1" highlightClick="0" endSnd="0">
+                  <a:extLst>
+                    <a:ext uri="{A12FA001-AC4F-418D-AE19-62706E023703}">
+                      <ahyp:hlinkClr xmlns:ahyp="http://schemas.microsoft.com/office/drawing/2018/hyperlinkcolor" val="tx"/>
+                    </a:ext>
+                  </a:extLst>
+                </a:hlinkClick>
+              </a:rPr>
+              <a:t>docs/evolution_design_notes.md</a:t>
+            </a:r>
+            <a:pPr indent="0" marL="0">
+              <a:buNone/>
+            </a:pPr>
+            <a:r>
+              <a:rPr lang="en-US" sz="900" dirty="0">
+                <a:solidFill>
+                  <a:srgbClr val="8FA3C8"/>
+                </a:solidFill>
+                <a:latin typeface="Consolas" pitchFamily="34" charset="0"/>
+                <a:ea typeface="Consolas" pitchFamily="34" charset="-122"/>
+                <a:cs typeface="Consolas" pitchFamily="34" charset="-120"/>
+              </a:rPr>
+              <a:t> ｜ 三份大綱皆在 docs/</a:t>
             </a:r>
             <a:endParaRPr lang="en-US" sz="900" dirty="0"/>
           </a:p>
@@ -18768,7 +20273,98 @@
                 <a:ea typeface="Consolas" pitchFamily="34" charset="-122"/>
                 <a:cs typeface="Consolas" pitchFamily="34" charset="-120"/>
               </a:rPr>
-              <a:t>外層 docs/collaboration_workflow_outline.md ｜ 內層 docs/teaching_slides_outline.md ｜ 數據 evolution_design_notes.md</a:t>
+              <a:t>外層 </a:t>
+            </a:r>
+            <a:pPr indent="0" marL="0">
+              <a:buNone/>
+            </a:pPr>
+            <a:r>
+              <a:rPr lang="en-US" sz="900" u="sng" dirty="0">
+                <a:solidFill>
+                  <a:srgbClr val="3A5BA0"/>
+                </a:solidFill>
+                <a:latin typeface="Consolas" pitchFamily="34" charset="0"/>
+                <a:ea typeface="Consolas" pitchFamily="34" charset="-122"/>
+                <a:cs typeface="Consolas" pitchFamily="34" charset="-120"/>
+                <a:hlinkClick r:id="rId1" invalidUrl="" action="" tgtFrame="" tooltip="" history="1" highlightClick="0" endSnd="0">
+                  <a:extLst>
+                    <a:ext uri="{A12FA001-AC4F-418D-AE19-62706E023703}">
+                      <ahyp:hlinkClr xmlns:ahyp="http://schemas.microsoft.com/office/drawing/2018/hyperlinkcolor" val="tx"/>
+                    </a:ext>
+                  </a:extLst>
+                </a:hlinkClick>
+              </a:rPr>
+              <a:t>docs/collaboration_workflow_outline.md</a:t>
+            </a:r>
+            <a:pPr indent="0" marL="0">
+              <a:buNone/>
+            </a:pPr>
+            <a:r>
+              <a:rPr lang="en-US" sz="900" dirty="0">
+                <a:solidFill>
+                  <a:srgbClr val="6B7280"/>
+                </a:solidFill>
+                <a:latin typeface="Consolas" pitchFamily="34" charset="0"/>
+                <a:ea typeface="Consolas" pitchFamily="34" charset="-122"/>
+                <a:cs typeface="Consolas" pitchFamily="34" charset="-120"/>
+              </a:rPr>
+              <a:t> ｜ 內層 </a:t>
+            </a:r>
+            <a:pPr indent="0" marL="0">
+              <a:buNone/>
+            </a:pPr>
+            <a:r>
+              <a:rPr lang="en-US" sz="900" u="sng" dirty="0">
+                <a:solidFill>
+                  <a:srgbClr val="3A5BA0"/>
+                </a:solidFill>
+                <a:latin typeface="Consolas" pitchFamily="34" charset="0"/>
+                <a:ea typeface="Consolas" pitchFamily="34" charset="-122"/>
+                <a:cs typeface="Consolas" pitchFamily="34" charset="-120"/>
+                <a:hlinkClick r:id="rId2" invalidUrl="" action="" tgtFrame="" tooltip="" history="1" highlightClick="0" endSnd="0">
+                  <a:extLst>
+                    <a:ext uri="{A12FA001-AC4F-418D-AE19-62706E023703}">
+                      <ahyp:hlinkClr xmlns:ahyp="http://schemas.microsoft.com/office/drawing/2018/hyperlinkcolor" val="tx"/>
+                    </a:ext>
+                  </a:extLst>
+                </a:hlinkClick>
+              </a:rPr>
+              <a:t>docs/teaching_slides_outline.md</a:t>
+            </a:r>
+            <a:pPr indent="0" marL="0">
+              <a:buNone/>
+            </a:pPr>
+            <a:r>
+              <a:rPr lang="en-US" sz="900" dirty="0">
+                <a:solidFill>
+                  <a:srgbClr val="6B7280"/>
+                </a:solidFill>
+                <a:latin typeface="Consolas" pitchFamily="34" charset="0"/>
+                <a:ea typeface="Consolas" pitchFamily="34" charset="-122"/>
+                <a:cs typeface="Consolas" pitchFamily="34" charset="-120"/>
+              </a:rPr>
+              <a:t> ｜ 數據 </a:t>
+            </a:r>
+            <a:pPr indent="0" marL="0">
+              <a:buNone/>
+            </a:pPr>
+            <a:r>
+              <a:rPr lang="en-US" sz="900" u="sng" dirty="0">
+                <a:solidFill>
+                  <a:srgbClr val="3A5BA0"/>
+                </a:solidFill>
+                <a:latin typeface="Consolas" pitchFamily="34" charset="0"/>
+                <a:ea typeface="Consolas" pitchFamily="34" charset="-122"/>
+                <a:cs typeface="Consolas" pitchFamily="34" charset="-120"/>
+                <a:hlinkClick r:id="rId3" invalidUrl="" action="" tgtFrame="" tooltip="" history="1" highlightClick="0" endSnd="0">
+                  <a:extLst>
+                    <a:ext uri="{A12FA001-AC4F-418D-AE19-62706E023703}">
+                      <ahyp:hlinkClr xmlns:ahyp="http://schemas.microsoft.com/office/drawing/2018/hyperlinkcolor" val="tx"/>
+                    </a:ext>
+                  </a:extLst>
+                </a:hlinkClick>
+              </a:rPr>
+              <a:t>evolution_design_notes.md</a:t>
             </a:r>
             <a:endParaRPr lang="en-US" sz="900" dirty="0"/>
           </a:p>
@@ -19566,7 +21162,98 @@
                 <a:ea typeface="Consolas" pitchFamily="34" charset="-122"/>
                 <a:cs typeface="Consolas" pitchFamily="34" charset="-120"/>
               </a:rPr>
-              <a:t>我+Claude 寫 config/agents.yaml（正式）· agents_evolving.yaml（種子）｜ OpenEvolve 改 evolvable_tools.py:18-58</a:t>
+              <a:t>我+Claude 寫 </a:t>
+            </a:r>
+            <a:pPr indent="0" marL="0">
+              <a:buNone/>
+            </a:pPr>
+            <a:r>
+              <a:rPr lang="en-US" sz="900" u="sng" dirty="0">
+                <a:solidFill>
+                  <a:srgbClr val="3A5BA0"/>
+                </a:solidFill>
+                <a:latin typeface="Consolas" pitchFamily="34" charset="0"/>
+                <a:ea typeface="Consolas" pitchFamily="34" charset="-122"/>
+                <a:cs typeface="Consolas" pitchFamily="34" charset="-120"/>
+                <a:hlinkClick r:id="rId1" invalidUrl="" action="" tgtFrame="" tooltip="" history="1" highlightClick="0" endSnd="0">
+                  <a:extLst>
+                    <a:ext uri="{A12FA001-AC4F-418D-AE19-62706E023703}">
+                      <ahyp:hlinkClr xmlns:ahyp="http://schemas.microsoft.com/office/drawing/2018/hyperlinkcolor" val="tx"/>
+                    </a:ext>
+                  </a:extLst>
+                </a:hlinkClick>
+              </a:rPr>
+              <a:t>config/agents.yaml</a:t>
+            </a:r>
+            <a:pPr indent="0" marL="0">
+              <a:buNone/>
+            </a:pPr>
+            <a:r>
+              <a:rPr lang="en-US" sz="900" dirty="0">
+                <a:solidFill>
+                  <a:srgbClr val="6B7280"/>
+                </a:solidFill>
+                <a:latin typeface="Consolas" pitchFamily="34" charset="0"/>
+                <a:ea typeface="Consolas" pitchFamily="34" charset="-122"/>
+                <a:cs typeface="Consolas" pitchFamily="34" charset="-120"/>
+              </a:rPr>
+              <a:t>（正式）· </a:t>
+            </a:r>
+            <a:pPr indent="0" marL="0">
+              <a:buNone/>
+            </a:pPr>
+            <a:r>
+              <a:rPr lang="en-US" sz="900" u="sng" dirty="0">
+                <a:solidFill>
+                  <a:srgbClr val="3A5BA0"/>
+                </a:solidFill>
+                <a:latin typeface="Consolas" pitchFamily="34" charset="0"/>
+                <a:ea typeface="Consolas" pitchFamily="34" charset="-122"/>
+                <a:cs typeface="Consolas" pitchFamily="34" charset="-120"/>
+                <a:hlinkClick r:id="rId2" invalidUrl="" action="" tgtFrame="" tooltip="" history="1" highlightClick="0" endSnd="0">
+                  <a:extLst>
+                    <a:ext uri="{A12FA001-AC4F-418D-AE19-62706E023703}">
+                      <ahyp:hlinkClr xmlns:ahyp="http://schemas.microsoft.com/office/drawing/2018/hyperlinkcolor" val="tx"/>
+                    </a:ext>
+                  </a:extLst>
+                </a:hlinkClick>
+              </a:rPr>
+              <a:t>agents_evolving.yaml</a:t>
+            </a:r>
+            <a:pPr indent="0" marL="0">
+              <a:buNone/>
+            </a:pPr>
+            <a:r>
+              <a:rPr lang="en-US" sz="900" dirty="0">
+                <a:solidFill>
+                  <a:srgbClr val="6B7280"/>
+                </a:solidFill>
+                <a:latin typeface="Consolas" pitchFamily="34" charset="0"/>
+                <a:ea typeface="Consolas" pitchFamily="34" charset="-122"/>
+                <a:cs typeface="Consolas" pitchFamily="34" charset="-120"/>
+              </a:rPr>
+              <a:t>（種子）｜ OpenEvolve 改 </a:t>
+            </a:r>
+            <a:pPr indent="0" marL="0">
+              <a:buNone/>
+            </a:pPr>
+            <a:r>
+              <a:rPr lang="en-US" sz="900" u="sng" dirty="0">
+                <a:solidFill>
+                  <a:srgbClr val="3A5BA0"/>
+                </a:solidFill>
+                <a:latin typeface="Consolas" pitchFamily="34" charset="0"/>
+                <a:ea typeface="Consolas" pitchFamily="34" charset="-122"/>
+                <a:cs typeface="Consolas" pitchFamily="34" charset="-120"/>
+                <a:hlinkClick r:id="rId3" invalidUrl="" action="" tgtFrame="" tooltip="" history="1" highlightClick="0" endSnd="0">
+                  <a:extLst>
+                    <a:ext uri="{A12FA001-AC4F-418D-AE19-62706E023703}">
+                      <ahyp:hlinkClr xmlns:ahyp="http://schemas.microsoft.com/office/drawing/2018/hyperlinkcolor" val="tx"/>
+                    </a:ext>
+                  </a:extLst>
+                </a:hlinkClick>
+              </a:rPr>
+              <a:t>evolvable_tools.py:18-58</a:t>
             </a:r>
             <a:endParaRPr lang="en-US" sz="900" dirty="0"/>
           </a:p>
@@ -20295,7 +21982,42 @@
                 <a:ea typeface="Consolas" pitchFamily="34" charset="-122"/>
                 <a:cs typeface="Consolas" pitchFamily="34" charset="-120"/>
               </a:rPr>
-              <a:t>我→config/*.yaml ｜ Claude→src/tools/ + src/crews/ + src/flows/ ｜ OpenEvolve→agents_evolving.yaml EVOLVE-BLOCK</a:t>
+              <a:t>我→config/*.yaml ｜ Claude→src/tools/ + src/crews/ + src/flows/ ｜ OpenEvolve→</a:t>
+            </a:r>
+            <a:pPr indent="0" marL="0">
+              <a:buNone/>
+            </a:pPr>
+            <a:r>
+              <a:rPr lang="en-US" sz="900" u="sng" dirty="0">
+                <a:solidFill>
+                  <a:srgbClr val="3A5BA0"/>
+                </a:solidFill>
+                <a:latin typeface="Consolas" pitchFamily="34" charset="0"/>
+                <a:ea typeface="Consolas" pitchFamily="34" charset="-122"/>
+                <a:cs typeface="Consolas" pitchFamily="34" charset="-120"/>
+                <a:hlinkClick r:id="rId1" invalidUrl="" action="" tgtFrame="" tooltip="" history="1" highlightClick="0" endSnd="0">
+                  <a:extLst>
+                    <a:ext uri="{A12FA001-AC4F-418D-AE19-62706E023703}">
+                      <ahyp:hlinkClr xmlns:ahyp="http://schemas.microsoft.com/office/drawing/2018/hyperlinkcolor" val="tx"/>
+                    </a:ext>
+                  </a:extLst>
+                </a:hlinkClick>
+              </a:rPr>
+              <a:t>agents_evolving.yaml</a:t>
+            </a:r>
+            <a:pPr indent="0" marL="0">
+              <a:buNone/>
+            </a:pPr>
+            <a:r>
+              <a:rPr lang="en-US" sz="900" dirty="0">
+                <a:solidFill>
+                  <a:srgbClr val="6B7280"/>
+                </a:solidFill>
+                <a:latin typeface="Consolas" pitchFamily="34" charset="0"/>
+                <a:ea typeface="Consolas" pitchFamily="34" charset="-122"/>
+                <a:cs typeface="Consolas" pitchFamily="34" charset="-120"/>
+              </a:rPr>
+              <a:t> EVOLVE-BLOCK</a:t>
             </a:r>
             <a:endParaRPr lang="en-US" sz="900" dirty="0"/>
           </a:p>
@@ -21231,7 +22953,77 @@
                 <a:ea typeface="Consolas" pitchFamily="34" charset="-122"/>
                 <a:cs typeface="Consolas" pitchFamily="34" charset="-120"/>
               </a:rPr>
-              <a:t>Claude 搭框架 src/tools/tool_loader.py（77 AST / 120 沙箱）· OpenEvolve 在 evolvable_tools.py:18-58 EVOLVE-BLOCK 內探索</a:t>
+              <a:t>Claude 搭框架 </a:t>
+            </a:r>
+            <a:pPr indent="0" marL="0">
+              <a:buNone/>
+            </a:pPr>
+            <a:r>
+              <a:rPr lang="en-US" sz="900" u="sng" dirty="0">
+                <a:solidFill>
+                  <a:srgbClr val="3A5BA0"/>
+                </a:solidFill>
+                <a:latin typeface="Consolas" pitchFamily="34" charset="0"/>
+                <a:ea typeface="Consolas" pitchFamily="34" charset="-122"/>
+                <a:cs typeface="Consolas" pitchFamily="34" charset="-120"/>
+                <a:hlinkClick r:id="rId1" invalidUrl="" action="" tgtFrame="" tooltip="" history="1" highlightClick="0" endSnd="0">
+                  <a:extLst>
+                    <a:ext uri="{A12FA001-AC4F-418D-AE19-62706E023703}">
+                      <ahyp:hlinkClr xmlns:ahyp="http://schemas.microsoft.com/office/drawing/2018/hyperlinkcolor" val="tx"/>
+                    </a:ext>
+                  </a:extLst>
+                </a:hlinkClick>
+              </a:rPr>
+              <a:t>src/tools/tool_loader.py</a:t>
+            </a:r>
+            <a:pPr indent="0" marL="0">
+              <a:buNone/>
+            </a:pPr>
+            <a:r>
+              <a:rPr lang="en-US" sz="900" dirty="0">
+                <a:solidFill>
+                  <a:srgbClr val="6B7280"/>
+                </a:solidFill>
+                <a:latin typeface="Consolas" pitchFamily="34" charset="0"/>
+                <a:ea typeface="Consolas" pitchFamily="34" charset="-122"/>
+                <a:cs typeface="Consolas" pitchFamily="34" charset="-120"/>
+              </a:rPr>
+              <a:t>（77 AST / 120 沙箱）· OpenEvolve 在 </a:t>
+            </a:r>
+            <a:pPr indent="0" marL="0">
+              <a:buNone/>
+            </a:pPr>
+            <a:r>
+              <a:rPr lang="en-US" sz="900" u="sng" dirty="0">
+                <a:solidFill>
+                  <a:srgbClr val="3A5BA0"/>
+                </a:solidFill>
+                <a:latin typeface="Consolas" pitchFamily="34" charset="0"/>
+                <a:ea typeface="Consolas" pitchFamily="34" charset="-122"/>
+                <a:cs typeface="Consolas" pitchFamily="34" charset="-120"/>
+                <a:hlinkClick r:id="rId2" invalidUrl="" action="" tgtFrame="" tooltip="" history="1" highlightClick="0" endSnd="0">
+                  <a:extLst>
+                    <a:ext uri="{A12FA001-AC4F-418D-AE19-62706E023703}">
+                      <ahyp:hlinkClr xmlns:ahyp="http://schemas.microsoft.com/office/drawing/2018/hyperlinkcolor" val="tx"/>
+                    </a:ext>
+                  </a:extLst>
+                </a:hlinkClick>
+              </a:rPr>
+              <a:t>evolvable_tools.py:18-58</a:t>
+            </a:r>
+            <a:pPr indent="0" marL="0">
+              <a:buNone/>
+            </a:pPr>
+            <a:r>
+              <a:rPr lang="en-US" sz="900" dirty="0">
+                <a:solidFill>
+                  <a:srgbClr val="6B7280"/>
+                </a:solidFill>
+                <a:latin typeface="Consolas" pitchFamily="34" charset="0"/>
+                <a:ea typeface="Consolas" pitchFamily="34" charset="-122"/>
+                <a:cs typeface="Consolas" pitchFamily="34" charset="-120"/>
+              </a:rPr>
+              <a:t> EVOLVE-BLOCK 內探索</a:t>
             </a:r>
             <a:endParaRPr lang="en-US" sz="900" dirty="0"/>
           </a:p>
@@ -22379,7 +24171,77 @@
                 <a:ea typeface="Consolas" pitchFamily="34" charset="-122"/>
                 <a:cs typeface="Consolas" pitchFamily="34" charset="-120"/>
               </a:rPr>
-              <a:t>護欄落地：retrieval_executor.py:53 normalize_policy（clamp）· tool_loader.py:77-177（AST→沙箱→包裝）</a:t>
+              <a:t>護欄落地：</a:t>
+            </a:r>
+            <a:pPr indent="0" marL="0">
+              <a:buNone/>
+            </a:pPr>
+            <a:r>
+              <a:rPr lang="en-US" sz="900" u="sng" dirty="0">
+                <a:solidFill>
+                  <a:srgbClr val="3A5BA0"/>
+                </a:solidFill>
+                <a:latin typeface="Consolas" pitchFamily="34" charset="0"/>
+                <a:ea typeface="Consolas" pitchFamily="34" charset="-122"/>
+                <a:cs typeface="Consolas" pitchFamily="34" charset="-120"/>
+                <a:hlinkClick r:id="rId1" invalidUrl="" action="" tgtFrame="" tooltip="" history="1" highlightClick="0" endSnd="0">
+                  <a:extLst>
+                    <a:ext uri="{A12FA001-AC4F-418D-AE19-62706E023703}">
+                      <ahyp:hlinkClr xmlns:ahyp="http://schemas.microsoft.com/office/drawing/2018/hyperlinkcolor" val="tx"/>
+                    </a:ext>
+                  </a:extLst>
+                </a:hlinkClick>
+              </a:rPr>
+              <a:t>retrieval_executor.py:53</a:t>
+            </a:r>
+            <a:pPr indent="0" marL="0">
+              <a:buNone/>
+            </a:pPr>
+            <a:r>
+              <a:rPr lang="en-US" sz="900" dirty="0">
+                <a:solidFill>
+                  <a:srgbClr val="6B7280"/>
+                </a:solidFill>
+                <a:latin typeface="Consolas" pitchFamily="34" charset="0"/>
+                <a:ea typeface="Consolas" pitchFamily="34" charset="-122"/>
+                <a:cs typeface="Consolas" pitchFamily="34" charset="-120"/>
+              </a:rPr>
+              <a:t> normalize_policy（clamp）· </a:t>
+            </a:r>
+            <a:pPr indent="0" marL="0">
+              <a:buNone/>
+            </a:pPr>
+            <a:r>
+              <a:rPr lang="en-US" sz="900" u="sng" dirty="0">
+                <a:solidFill>
+                  <a:srgbClr val="3A5BA0"/>
+                </a:solidFill>
+                <a:latin typeface="Consolas" pitchFamily="34" charset="0"/>
+                <a:ea typeface="Consolas" pitchFamily="34" charset="-122"/>
+                <a:cs typeface="Consolas" pitchFamily="34" charset="-120"/>
+                <a:hlinkClick r:id="rId2" invalidUrl="" action="" tgtFrame="" tooltip="" history="1" highlightClick="0" endSnd="0">
+                  <a:extLst>
+                    <a:ext uri="{A12FA001-AC4F-418D-AE19-62706E023703}">
+                      <ahyp:hlinkClr xmlns:ahyp="http://schemas.microsoft.com/office/drawing/2018/hyperlinkcolor" val="tx"/>
+                    </a:ext>
+                  </a:extLst>
+                </a:hlinkClick>
+              </a:rPr>
+              <a:t>tool_loader.py:77-177</a:t>
+            </a:r>
+            <a:pPr indent="0" marL="0">
+              <a:buNone/>
+            </a:pPr>
+            <a:r>
+              <a:rPr lang="en-US" sz="900" dirty="0">
+                <a:solidFill>
+                  <a:srgbClr val="6B7280"/>
+                </a:solidFill>
+                <a:latin typeface="Consolas" pitchFamily="34" charset="0"/>
+                <a:ea typeface="Consolas" pitchFamily="34" charset="-122"/>
+                <a:cs typeface="Consolas" pitchFamily="34" charset="-120"/>
+              </a:rPr>
+              <a:t>（AST→沙箱→包裝）</a:t>
             </a:r>
             <a:endParaRPr lang="en-US" sz="900" dirty="0"/>
           </a:p>
@@ -23252,15 +25114,127 @@
               <a:buNone/>
             </a:pPr>
             <a:r>
-              <a:rPr lang="en-US" sz="900" dirty="0">
-                <a:solidFill>
-                  <a:srgbClr val="6B7280"/>
+              <a:rPr lang="en-US" sz="900" u="sng" dirty="0">
+                <a:solidFill>
+                  <a:srgbClr val="3A5BA0"/>
                 </a:solidFill>
                 <a:latin typeface="Consolas" pitchFamily="34" charset="0"/>
                 <a:ea typeface="Consolas" pitchFamily="34" charset="-122"/>
                 <a:cs typeface="Consolas" pitchFamily="34" charset="-120"/>
-              </a:rPr>
-              <a:t>evaluator.py:96 evaluate · :106-108 fitness ｜ simulation_crew.py:42-89 三代理 ｜ openevolve_config.yaml:10-88</a:t>
+                <a:hlinkClick r:id="rId1" invalidUrl="" action="" tgtFrame="" tooltip="" history="1" highlightClick="0" endSnd="0">
+                  <a:extLst>
+                    <a:ext uri="{A12FA001-AC4F-418D-AE19-62706E023703}">
+                      <ahyp:hlinkClr xmlns:ahyp="http://schemas.microsoft.com/office/drawing/2018/hyperlinkcolor" val="tx"/>
+                    </a:ext>
+                  </a:extLst>
+                </a:hlinkClick>
+              </a:rPr>
+              <a:t>evaluator.py:96</a:t>
+            </a:r>
+            <a:pPr indent="0" marL="0">
+              <a:buNone/>
+            </a:pPr>
+            <a:r>
+              <a:rPr lang="en-US" sz="900" dirty="0">
+                <a:solidFill>
+                  <a:srgbClr val="6B7280"/>
+                </a:solidFill>
+                <a:latin typeface="Consolas" pitchFamily="34" charset="0"/>
+                <a:ea typeface="Consolas" pitchFamily="34" charset="-122"/>
+                <a:cs typeface="Consolas" pitchFamily="34" charset="-120"/>
+              </a:rPr>
+              <a:t> evaluate · </a:t>
+            </a:r>
+            <a:pPr indent="0" marL="0">
+              <a:buNone/>
+            </a:pPr>
+            <a:r>
+              <a:rPr lang="en-US" sz="900" u="sng" dirty="0">
+                <a:solidFill>
+                  <a:srgbClr val="3A5BA0"/>
+                </a:solidFill>
+                <a:latin typeface="Consolas" pitchFamily="34" charset="0"/>
+                <a:ea typeface="Consolas" pitchFamily="34" charset="-122"/>
+                <a:cs typeface="Consolas" pitchFamily="34" charset="-120"/>
+                <a:hlinkClick r:id="rId2" invalidUrl="" action="" tgtFrame="" tooltip="" history="1" highlightClick="0" endSnd="0">
+                  <a:extLst>
+                    <a:ext uri="{A12FA001-AC4F-418D-AE19-62706E023703}">
+                      <ahyp:hlinkClr xmlns:ahyp="http://schemas.microsoft.com/office/drawing/2018/hyperlinkcolor" val="tx"/>
+                    </a:ext>
+                  </a:extLst>
+                </a:hlinkClick>
+              </a:rPr>
+              <a:t>:106-108</a:t>
+            </a:r>
+            <a:pPr indent="0" marL="0">
+              <a:buNone/>
+            </a:pPr>
+            <a:r>
+              <a:rPr lang="en-US" sz="900" dirty="0">
+                <a:solidFill>
+                  <a:srgbClr val="6B7280"/>
+                </a:solidFill>
+                <a:latin typeface="Consolas" pitchFamily="34" charset="0"/>
+                <a:ea typeface="Consolas" pitchFamily="34" charset="-122"/>
+                <a:cs typeface="Consolas" pitchFamily="34" charset="-120"/>
+              </a:rPr>
+              <a:t> fitness ｜ </a:t>
+            </a:r>
+            <a:pPr indent="0" marL="0">
+              <a:buNone/>
+            </a:pPr>
+            <a:r>
+              <a:rPr lang="en-US" sz="900" u="sng" dirty="0">
+                <a:solidFill>
+                  <a:srgbClr val="3A5BA0"/>
+                </a:solidFill>
+                <a:latin typeface="Consolas" pitchFamily="34" charset="0"/>
+                <a:ea typeface="Consolas" pitchFamily="34" charset="-122"/>
+                <a:cs typeface="Consolas" pitchFamily="34" charset="-120"/>
+                <a:hlinkClick r:id="rId3" invalidUrl="" action="" tgtFrame="" tooltip="" history="1" highlightClick="0" endSnd="0">
+                  <a:extLst>
+                    <a:ext uri="{A12FA001-AC4F-418D-AE19-62706E023703}">
+                      <ahyp:hlinkClr xmlns:ahyp="http://schemas.microsoft.com/office/drawing/2018/hyperlinkcolor" val="tx"/>
+                    </a:ext>
+                  </a:extLst>
+                </a:hlinkClick>
+              </a:rPr>
+              <a:t>simulation_crew.py:42-89</a:t>
+            </a:r>
+            <a:pPr indent="0" marL="0">
+              <a:buNone/>
+            </a:pPr>
+            <a:r>
+              <a:rPr lang="en-US" sz="900" dirty="0">
+                <a:solidFill>
+                  <a:srgbClr val="6B7280"/>
+                </a:solidFill>
+                <a:latin typeface="Consolas" pitchFamily="34" charset="0"/>
+                <a:ea typeface="Consolas" pitchFamily="34" charset="-122"/>
+                <a:cs typeface="Consolas" pitchFamily="34" charset="-120"/>
+              </a:rPr>
+              <a:t> 三代理 ｜ </a:t>
+            </a:r>
+            <a:pPr indent="0" marL="0">
+              <a:buNone/>
+            </a:pPr>
+            <a:r>
+              <a:rPr lang="en-US" sz="900" u="sng" dirty="0">
+                <a:solidFill>
+                  <a:srgbClr val="3A5BA0"/>
+                </a:solidFill>
+                <a:latin typeface="Consolas" pitchFamily="34" charset="0"/>
+                <a:ea typeface="Consolas" pitchFamily="34" charset="-122"/>
+                <a:cs typeface="Consolas" pitchFamily="34" charset="-120"/>
+                <a:hlinkClick r:id="rId4" invalidUrl="" action="" tgtFrame="" tooltip="" history="1" highlightClick="0" endSnd="0">
+                  <a:extLst>
+                    <a:ext uri="{A12FA001-AC4F-418D-AE19-62706E023703}">
+                      <ahyp:hlinkClr xmlns:ahyp="http://schemas.microsoft.com/office/drawing/2018/hyperlinkcolor" val="tx"/>
+                    </a:ext>
+                  </a:extLst>
+                </a:hlinkClick>
+              </a:rPr>
+              <a:t>openevolve_config.yaml:10-88</a:t>
             </a:r>
             <a:endParaRPr lang="en-US" sz="900" dirty="0"/>
           </a:p>
@@ -23639,15 +25613,71 @@
               <a:buNone/>
             </a:pPr>
             <a:r>
-              <a:rPr lang="en-US" sz="900" dirty="0">
-                <a:solidFill>
-                  <a:srgbClr val="6B7280"/>
+              <a:rPr lang="en-US" sz="900" u="sng" dirty="0">
+                <a:solidFill>
+                  <a:srgbClr val="3A5BA0"/>
                 </a:solidFill>
                 <a:latin typeface="Consolas" pitchFamily="34" charset="0"/>
                 <a:ea typeface="Consolas" pitchFamily="34" charset="-122"/>
                 <a:cs typeface="Consolas" pitchFamily="34" charset="-120"/>
-              </a:rPr>
-              <a:t>openevolve_evaluator.py:133-137 timeout fallback · :179-184 exception fallback（都回 _result(0.0)）</a:t>
+                <a:hlinkClick r:id="rId2" invalidUrl="" action="" tgtFrame="" tooltip="" history="1" highlightClick="0" endSnd="0">
+                  <a:extLst>
+                    <a:ext uri="{A12FA001-AC4F-418D-AE19-62706E023703}">
+                      <ahyp:hlinkClr xmlns:ahyp="http://schemas.microsoft.com/office/drawing/2018/hyperlinkcolor" val="tx"/>
+                    </a:ext>
+                  </a:extLst>
+                </a:hlinkClick>
+              </a:rPr>
+              <a:t>openevolve_evaluator.py:133-137</a:t>
+            </a:r>
+            <a:pPr indent="0" marL="0">
+              <a:buNone/>
+            </a:pPr>
+            <a:r>
+              <a:rPr lang="en-US" sz="900" dirty="0">
+                <a:solidFill>
+                  <a:srgbClr val="6B7280"/>
+                </a:solidFill>
+                <a:latin typeface="Consolas" pitchFamily="34" charset="0"/>
+                <a:ea typeface="Consolas" pitchFamily="34" charset="-122"/>
+                <a:cs typeface="Consolas" pitchFamily="34" charset="-120"/>
+              </a:rPr>
+              <a:t> timeout fallback · </a:t>
+            </a:r>
+            <a:pPr indent="0" marL="0">
+              <a:buNone/>
+            </a:pPr>
+            <a:r>
+              <a:rPr lang="en-US" sz="900" u="sng" dirty="0">
+                <a:solidFill>
+                  <a:srgbClr val="3A5BA0"/>
+                </a:solidFill>
+                <a:latin typeface="Consolas" pitchFamily="34" charset="0"/>
+                <a:ea typeface="Consolas" pitchFamily="34" charset="-122"/>
+                <a:cs typeface="Consolas" pitchFamily="34" charset="-120"/>
+                <a:hlinkClick r:id="rId3" invalidUrl="" action="" tgtFrame="" tooltip="" history="1" highlightClick="0" endSnd="0">
+                  <a:extLst>
+                    <a:ext uri="{A12FA001-AC4F-418D-AE19-62706E023703}">
+                      <ahyp:hlinkClr xmlns:ahyp="http://schemas.microsoft.com/office/drawing/2018/hyperlinkcolor" val="tx"/>
+                    </a:ext>
+                  </a:extLst>
+                </a:hlinkClick>
+              </a:rPr>
+              <a:t>:179-184</a:t>
+            </a:r>
+            <a:pPr indent="0" marL="0">
+              <a:buNone/>
+            </a:pPr>
+            <a:r>
+              <a:rPr lang="en-US" sz="900" dirty="0">
+                <a:solidFill>
+                  <a:srgbClr val="6B7280"/>
+                </a:solidFill>
+                <a:latin typeface="Consolas" pitchFamily="34" charset="0"/>
+                <a:ea typeface="Consolas" pitchFamily="34" charset="-122"/>
+                <a:cs typeface="Consolas" pitchFamily="34" charset="-120"/>
+              </a:rPr>
+              <a:t> exception fallback（都回 _result(0.0)）</a:t>
             </a:r>
             <a:endParaRPr lang="en-US" sz="900" dirty="0"/>
           </a:p>

</xml_diff>

<commit_message>
docs: refine unified deck — md links + clearer failure-taxonomy slide
1. Don't hyperlink docs/*.md references that have no line number — a link
   to the top of a long design doc isn't useful. Only file:line refs
   (the .py/.yaml code) stay clickable (64 → 52 links).
2. S10 ("Claude 的「失敗分類學」") rewritten for clarity, grounded in
   evolution_design_notes.md §3:
   - added a one-line definition of what 失敗分類學 is
   - plain-language failure examples (dropped ReAct/query_type jargon)
   - a "why it works" note (graceful degradation + the fitness insight)

Co-Authored-By: Claude Opus 4.8 <noreply@anthropic.com>
</commit_message>
<xml_diff>
--- a/docs/slides/人AI進化_整合教學投影片.pptx
+++ b/docs/slides/人AI進化_整合教學投影片.pptx
@@ -4542,14 +4542,67 @@
       </p:sp>
       <p:sp>
         <p:nvSpPr>
-          <p:cNvPr id="5" name="Shape 3"/>
-          <p:cNvSpPr/>
-          <p:nvPr/>
-        </p:nvSpPr>
-        <p:spPr>
-          <a:xfrm>
-            <a:off x="548640" y="1737360"/>
-            <a:ext cx="4114800" cy="4160520"/>
+          <p:cNvPr id="5" name="Text 3"/>
+          <p:cNvSpPr/>
+          <p:nvPr/>
+        </p:nvSpPr>
+        <p:spPr>
+          <a:xfrm>
+            <a:off x="548640" y="1481328"/>
+            <a:ext cx="11109960" cy="365760"/>
+          </a:xfrm>
+          <a:prstGeom prst="rect">
+            <a:avLst/>
+          </a:prstGeom>
+          <a:noFill/>
+          <a:ln/>
+        </p:spPr>
+        <p:txBody>
+          <a:bodyPr wrap="square" lIns="0" tIns="0" rIns="0" bIns="0" rtlCol="0" anchor="ctr"/>
+          <a:lstStyle/>
+          <a:p>
+            <a:pPr indent="0" marL="0">
+              <a:buNone/>
+            </a:pPr>
+            <a:r>
+              <a:rPr lang="en-US" sz="1350" b="1" dirty="0">
+                <a:solidFill>
+                  <a:srgbClr val="1E2761"/>
+                </a:solidFill>
+                <a:latin typeface="Calibri" pitchFamily="34" charset="0"/>
+                <a:ea typeface="Calibri" pitchFamily="34" charset="-122"/>
+                <a:cs typeface="Calibri" pitchFamily="34" charset="-120"/>
+              </a:rPr>
+              <a:t>「失敗分類學」＝</a:t>
+            </a:r>
+            <a:pPr indent="0" marL="0">
+              <a:buNone/>
+            </a:pPr>
+            <a:r>
+              <a:rPr lang="en-US" sz="1350" dirty="0">
+                <a:solidFill>
+                  <a:srgbClr val="23272E"/>
+                </a:solidFill>
+                <a:latin typeface="Calibri" pitchFamily="34" charset="0"/>
+                <a:ea typeface="Calibri" pitchFamily="34" charset="-122"/>
+                <a:cs typeface="Calibri" pitchFamily="34" charset="-120"/>
+              </a:rPr>
+              <a:t>與其工具一壞就頭痛醫頭，Claude 先把「工具呼叫會怎麼壞」分門別類成 5 種失敗模式，每一層各配一種防護。</a:t>
+            </a:r>
+            <a:endParaRPr lang="en-US" sz="1350" dirty="0"/>
+          </a:p>
+        </p:txBody>
+      </p:sp>
+      <p:sp>
+        <p:nvSpPr>
+          <p:cNvPr id="6" name="Shape 4"/>
+          <p:cNvSpPr/>
+          <p:nvPr/>
+        </p:nvSpPr>
+        <p:spPr>
+          <a:xfrm>
+            <a:off x="548640" y="1938528"/>
+            <a:ext cx="4114800" cy="3840480"/>
           </a:xfrm>
           <a:prstGeom prst="rect">
             <a:avLst/>
@@ -4574,13 +4627,13 @@
       </p:sp>
       <p:sp>
         <p:nvSpPr>
-          <p:cNvPr id="6" name="Text 4"/>
-          <p:cNvSpPr/>
-          <p:nvPr/>
-        </p:nvSpPr>
-        <p:spPr>
-          <a:xfrm>
-            <a:off x="777240" y="1920240"/>
+          <p:cNvPr id="7" name="Text 5"/>
+          <p:cNvSpPr/>
+          <p:nvPr/>
+        </p:nvSpPr>
+        <p:spPr>
+          <a:xfrm>
+            <a:off x="777240" y="2103120"/>
             <a:ext cx="3657600" cy="365760"/>
           </a:xfrm>
           <a:prstGeom prst="rect">
@@ -4613,13 +4666,13 @@
       </p:sp>
       <p:sp>
         <p:nvSpPr>
-          <p:cNvPr id="7" name="Text 5"/>
-          <p:cNvSpPr/>
-          <p:nvPr/>
-        </p:nvSpPr>
-        <p:spPr>
-          <a:xfrm>
-            <a:off x="777240" y="2377440"/>
+          <p:cNvPr id="8" name="Text 6"/>
+          <p:cNvSpPr/>
+          <p:nvPr/>
+        </p:nvSpPr>
+        <p:spPr>
+          <a:xfrm>
+            <a:off x="777240" y="2542032"/>
             <a:ext cx="3657600" cy="2194560"/>
           </a:xfrm>
           <a:prstGeom prst="rect">
@@ -4647,7 +4700,7 @@
                 <a:ea typeface="Georgia" pitchFamily="34" charset="-122"/>
                 <a:cs typeface="Georgia" pitchFamily="34" charset="-120"/>
               </a:rPr>
-              <a:t>「怎麼讓 agent 安全進化、用不同工具、甚至創造新工具，而不在 tool calling 上崩潰？」</a:t>
+              <a:t>「怎麼讓 agent 安全進化、用不同工具、甚至創造新工具，而不在工具呼叫上崩潰？」</a:t>
             </a:r>
             <a:endParaRPr lang="en-US" sz="1700" dirty="0"/>
           </a:p>
@@ -4655,14 +4708,14 @@
       </p:sp>
       <p:sp>
         <p:nvSpPr>
-          <p:cNvPr id="8" name="Text 6"/>
-          <p:cNvSpPr/>
-          <p:nvPr/>
-        </p:nvSpPr>
-        <p:spPr>
-          <a:xfrm>
-            <a:off x="777240" y="5029200"/>
-            <a:ext cx="3657600" cy="731520"/>
+          <p:cNvPr id="9" name="Text 7"/>
+          <p:cNvSpPr/>
+          <p:nvPr/>
+        </p:nvSpPr>
+        <p:spPr>
+          <a:xfrm>
+            <a:off x="777240" y="5074920"/>
+            <a:ext cx="3657600" cy="640080"/>
           </a:xfrm>
           <a:prstGeom prst="rect">
             <a:avLst/>
@@ -4694,14 +4747,14 @@
       </p:sp>
       <p:sp>
         <p:nvSpPr>
-          <p:cNvPr id="9" name="Shape 7"/>
-          <p:cNvSpPr/>
-          <p:nvPr/>
-        </p:nvSpPr>
-        <p:spPr>
-          <a:xfrm>
-            <a:off x="4846320" y="1737360"/>
-            <a:ext cx="6812280" cy="603504"/>
+          <p:cNvPr id="10" name="Shape 8"/>
+          <p:cNvSpPr/>
+          <p:nvPr/>
+        </p:nvSpPr>
+        <p:spPr>
+          <a:xfrm>
+            <a:off x="4846320" y="1938528"/>
+            <a:ext cx="6812280" cy="566928"/>
           </a:xfrm>
           <a:prstGeom prst="rect">
             <a:avLst/>
@@ -4726,14 +4779,14 @@
       </p:sp>
       <p:sp>
         <p:nvSpPr>
-          <p:cNvPr id="10" name="Shape 8"/>
-          <p:cNvSpPr/>
-          <p:nvPr/>
-        </p:nvSpPr>
-        <p:spPr>
-          <a:xfrm>
-            <a:off x="4846320" y="1737360"/>
-            <a:ext cx="91440" cy="603504"/>
+          <p:cNvPr id="11" name="Shape 9"/>
+          <p:cNvSpPr/>
+          <p:nvPr/>
+        </p:nvSpPr>
+        <p:spPr>
+          <a:xfrm>
+            <a:off x="4846320" y="1938528"/>
+            <a:ext cx="91440" cy="566928"/>
           </a:xfrm>
           <a:prstGeom prst="rect">
             <a:avLst/>
@@ -4746,30 +4799,30 @@
       </p:sp>
       <p:sp>
         <p:nvSpPr>
-          <p:cNvPr id="11" name="Text 9"/>
-          <p:cNvSpPr/>
-          <p:nvPr/>
-        </p:nvSpPr>
-        <p:spPr>
-          <a:xfrm>
-            <a:off x="5029200" y="1737360"/>
-            <a:ext cx="731520" cy="603504"/>
-          </a:xfrm>
-          <a:prstGeom prst="rect">
-            <a:avLst/>
-          </a:prstGeom>
-          <a:noFill/>
-          <a:ln/>
-        </p:spPr>
-        <p:txBody>
-          <a:bodyPr wrap="square" lIns="0" tIns="0" rIns="0" bIns="0" rtlCol="0" anchor="ctr"/>
-          <a:lstStyle/>
-          <a:p>
-            <a:pPr indent="0" marL="0">
-              <a:buNone/>
-            </a:pPr>
-            <a:r>
-              <a:rPr lang="en-US" sz="1600" b="1" dirty="0">
+          <p:cNvPr id="12" name="Text 10"/>
+          <p:cNvSpPr/>
+          <p:nvPr/>
+        </p:nvSpPr>
+        <p:spPr>
+          <a:xfrm>
+            <a:off x="5029200" y="1938528"/>
+            <a:ext cx="731520" cy="566928"/>
+          </a:xfrm>
+          <a:prstGeom prst="rect">
+            <a:avLst/>
+          </a:prstGeom>
+          <a:noFill/>
+          <a:ln/>
+        </p:spPr>
+        <p:txBody>
+          <a:bodyPr wrap="square" lIns="0" tIns="0" rIns="0" bIns="0" rtlCol="0" anchor="ctr"/>
+          <a:lstStyle/>
+          <a:p>
+            <a:pPr indent="0" marL="0">
+              <a:buNone/>
+            </a:pPr>
+            <a:r>
+              <a:rPr lang="en-US" sz="1500" b="1" dirty="0">
                 <a:solidFill>
                   <a:srgbClr val="C0453B"/>
                 </a:solidFill>
@@ -4779,36 +4832,36 @@
               </a:rPr>
               <a:t>L1</a:t>
             </a:r>
-            <a:endParaRPr lang="en-US" sz="1600" dirty="0"/>
-          </a:p>
-        </p:txBody>
-      </p:sp>
-      <p:sp>
-        <p:nvSpPr>
-          <p:cNvPr id="12" name="Text 10"/>
-          <p:cNvSpPr/>
-          <p:nvPr/>
-        </p:nvSpPr>
-        <p:spPr>
-          <a:xfrm>
-            <a:off x="5806440" y="1737360"/>
-            <a:ext cx="2194560" cy="603504"/>
-          </a:xfrm>
-          <a:prstGeom prst="rect">
-            <a:avLst/>
-          </a:prstGeom>
-          <a:noFill/>
-          <a:ln/>
-        </p:spPr>
-        <p:txBody>
-          <a:bodyPr wrap="square" lIns="0" tIns="0" rIns="0" bIns="0" rtlCol="0" anchor="ctr"/>
-          <a:lstStyle/>
-          <a:p>
-            <a:pPr indent="0" marL="0">
-              <a:buNone/>
-            </a:pPr>
-            <a:r>
-              <a:rPr lang="en-US" sz="1400" b="1" dirty="0">
+            <a:endParaRPr lang="en-US" sz="1500" dirty="0"/>
+          </a:p>
+        </p:txBody>
+      </p:sp>
+      <p:sp>
+        <p:nvSpPr>
+          <p:cNvPr id="13" name="Text 11"/>
+          <p:cNvSpPr/>
+          <p:nvPr/>
+        </p:nvSpPr>
+        <p:spPr>
+          <a:xfrm>
+            <a:off x="5760720" y="1938528"/>
+            <a:ext cx="2011680" cy="566928"/>
+          </a:xfrm>
+          <a:prstGeom prst="rect">
+            <a:avLst/>
+          </a:prstGeom>
+          <a:noFill/>
+          <a:ln/>
+        </p:spPr>
+        <p:txBody>
+          <a:bodyPr wrap="square" lIns="0" tIns="0" rIns="0" bIns="0" rtlCol="0" anchor="ctr"/>
+          <a:lstStyle/>
+          <a:p>
+            <a:pPr indent="0" marL="0">
+              <a:buNone/>
+            </a:pPr>
+            <a:r>
+              <a:rPr lang="en-US" sz="1350" b="1" dirty="0">
                 <a:solidFill>
                   <a:srgbClr val="1E2761"/>
                 </a:solidFill>
@@ -4818,36 +4871,36 @@
               </a:rPr>
               <a:t>呼叫協議</a:t>
             </a:r>
-            <a:endParaRPr lang="en-US" sz="1400" dirty="0"/>
-          </a:p>
-        </p:txBody>
-      </p:sp>
-      <p:sp>
-        <p:nvSpPr>
-          <p:cNvPr id="13" name="Text 11"/>
-          <p:cNvSpPr/>
-          <p:nvPr/>
-        </p:nvSpPr>
-        <p:spPr>
-          <a:xfrm>
-            <a:off x="8046720" y="1737360"/>
-            <a:ext cx="3474720" cy="603504"/>
-          </a:xfrm>
-          <a:prstGeom prst="rect">
-            <a:avLst/>
-          </a:prstGeom>
-          <a:noFill/>
-          <a:ln/>
-        </p:spPr>
-        <p:txBody>
-          <a:bodyPr wrap="square" lIns="0" tIns="0" rIns="0" bIns="0" rtlCol="0" anchor="ctr"/>
-          <a:lstStyle/>
-          <a:p>
-            <a:pPr indent="0" marL="0">
-              <a:buNone/>
-            </a:pPr>
-            <a:r>
-              <a:rPr lang="en-US" sz="1250" dirty="0">
+            <a:endParaRPr lang="en-US" sz="1350" dirty="0"/>
+          </a:p>
+        </p:txBody>
+      </p:sp>
+      <p:sp>
+        <p:nvSpPr>
+          <p:cNvPr id="14" name="Text 12"/>
+          <p:cNvSpPr/>
+          <p:nvPr/>
+        </p:nvSpPr>
+        <p:spPr>
+          <a:xfrm>
+            <a:off x="7818120" y="1938528"/>
+            <a:ext cx="3703320" cy="566928"/>
+          </a:xfrm>
+          <a:prstGeom prst="rect">
+            <a:avLst/>
+          </a:prstGeom>
+          <a:noFill/>
+          <a:ln/>
+        </p:spPr>
+        <p:txBody>
+          <a:bodyPr wrap="square" lIns="0" tIns="0" rIns="0" bIns="0" rtlCol="0" anchor="ctr"/>
+          <a:lstStyle/>
+          <a:p>
+            <a:pPr indent="0" marL="0">
+              <a:buNone/>
+            </a:pPr>
+            <a:r>
+              <a:rPr lang="en-US" sz="1200" dirty="0">
                 <a:solidFill>
                   <a:srgbClr val="23272E"/>
                 </a:solidFill>
@@ -4855,22 +4908,22 @@
                 <a:ea typeface="Calibri" pitchFamily="34" charset="-122"/>
                 <a:cs typeface="Calibri" pitchFamily="34" charset="-120"/>
               </a:rPr>
-              <a:t>ReAct 格式被改壞</a:t>
-            </a:r>
-            <a:endParaRPr lang="en-US" sz="1250" dirty="0"/>
-          </a:p>
-        </p:txBody>
-      </p:sp>
-      <p:sp>
-        <p:nvSpPr>
-          <p:cNvPr id="14" name="Shape 12"/>
-          <p:cNvSpPr/>
-          <p:nvPr/>
-        </p:nvSpPr>
-        <p:spPr>
-          <a:xfrm>
-            <a:off x="4846320" y="2450592"/>
-            <a:ext cx="6812280" cy="603504"/>
+              <a:t>呼叫工具的文字格式被改壞</a:t>
+            </a:r>
+            <a:endParaRPr lang="en-US" sz="1200" dirty="0"/>
+          </a:p>
+        </p:txBody>
+      </p:sp>
+      <p:sp>
+        <p:nvSpPr>
+          <p:cNvPr id="15" name="Shape 13"/>
+          <p:cNvSpPr/>
+          <p:nvPr/>
+        </p:nvSpPr>
+        <p:spPr>
+          <a:xfrm>
+            <a:off x="4846320" y="2596896"/>
+            <a:ext cx="6812280" cy="566928"/>
           </a:xfrm>
           <a:prstGeom prst="rect">
             <a:avLst/>
@@ -4895,14 +4948,14 @@
       </p:sp>
       <p:sp>
         <p:nvSpPr>
-          <p:cNvPr id="15" name="Shape 13"/>
-          <p:cNvSpPr/>
-          <p:nvPr/>
-        </p:nvSpPr>
-        <p:spPr>
-          <a:xfrm>
-            <a:off x="4846320" y="2450592"/>
-            <a:ext cx="91440" cy="603504"/>
+          <p:cNvPr id="16" name="Shape 14"/>
+          <p:cNvSpPr/>
+          <p:nvPr/>
+        </p:nvSpPr>
+        <p:spPr>
+          <a:xfrm>
+            <a:off x="4846320" y="2596896"/>
+            <a:ext cx="91440" cy="566928"/>
           </a:xfrm>
           <a:prstGeom prst="rect">
             <a:avLst/>
@@ -4915,30 +4968,30 @@
       </p:sp>
       <p:sp>
         <p:nvSpPr>
-          <p:cNvPr id="16" name="Text 14"/>
-          <p:cNvSpPr/>
-          <p:nvPr/>
-        </p:nvSpPr>
-        <p:spPr>
-          <a:xfrm>
-            <a:off x="5029200" y="2450592"/>
-            <a:ext cx="731520" cy="603504"/>
-          </a:xfrm>
-          <a:prstGeom prst="rect">
-            <a:avLst/>
-          </a:prstGeom>
-          <a:noFill/>
-          <a:ln/>
-        </p:spPr>
-        <p:txBody>
-          <a:bodyPr wrap="square" lIns="0" tIns="0" rIns="0" bIns="0" rtlCol="0" anchor="ctr"/>
-          <a:lstStyle/>
-          <a:p>
-            <a:pPr indent="0" marL="0">
-              <a:buNone/>
-            </a:pPr>
-            <a:r>
-              <a:rPr lang="en-US" sz="1600" b="1" dirty="0">
+          <p:cNvPr id="17" name="Text 15"/>
+          <p:cNvSpPr/>
+          <p:nvPr/>
+        </p:nvSpPr>
+        <p:spPr>
+          <a:xfrm>
+            <a:off x="5029200" y="2596896"/>
+            <a:ext cx="731520" cy="566928"/>
+          </a:xfrm>
+          <a:prstGeom prst="rect">
+            <a:avLst/>
+          </a:prstGeom>
+          <a:noFill/>
+          <a:ln/>
+        </p:spPr>
+        <p:txBody>
+          <a:bodyPr wrap="square" lIns="0" tIns="0" rIns="0" bIns="0" rtlCol="0" anchor="ctr"/>
+          <a:lstStyle/>
+          <a:p>
+            <a:pPr indent="0" marL="0">
+              <a:buNone/>
+            </a:pPr>
+            <a:r>
+              <a:rPr lang="en-US" sz="1500" b="1" dirty="0">
                 <a:solidFill>
                   <a:srgbClr val="E8A33D"/>
                 </a:solidFill>
@@ -4948,36 +5001,36 @@
               </a:rPr>
               <a:t>L2</a:t>
             </a:r>
-            <a:endParaRPr lang="en-US" sz="1600" dirty="0"/>
-          </a:p>
-        </p:txBody>
-      </p:sp>
-      <p:sp>
-        <p:nvSpPr>
-          <p:cNvPr id="17" name="Text 15"/>
-          <p:cNvSpPr/>
-          <p:nvPr/>
-        </p:nvSpPr>
-        <p:spPr>
-          <a:xfrm>
-            <a:off x="5806440" y="2450592"/>
-            <a:ext cx="2194560" cy="603504"/>
-          </a:xfrm>
-          <a:prstGeom prst="rect">
-            <a:avLst/>
-          </a:prstGeom>
-          <a:noFill/>
-          <a:ln/>
-        </p:spPr>
-        <p:txBody>
-          <a:bodyPr wrap="square" lIns="0" tIns="0" rIns="0" bIns="0" rtlCol="0" anchor="ctr"/>
-          <a:lstStyle/>
-          <a:p>
-            <a:pPr indent="0" marL="0">
-              <a:buNone/>
-            </a:pPr>
-            <a:r>
-              <a:rPr lang="en-US" sz="1400" b="1" dirty="0">
+            <a:endParaRPr lang="en-US" sz="1500" dirty="0"/>
+          </a:p>
+        </p:txBody>
+      </p:sp>
+      <p:sp>
+        <p:nvSpPr>
+          <p:cNvPr id="18" name="Text 16"/>
+          <p:cNvSpPr/>
+          <p:nvPr/>
+        </p:nvSpPr>
+        <p:spPr>
+          <a:xfrm>
+            <a:off x="5760720" y="2596896"/>
+            <a:ext cx="2011680" cy="566928"/>
+          </a:xfrm>
+          <a:prstGeom prst="rect">
+            <a:avLst/>
+          </a:prstGeom>
+          <a:noFill/>
+          <a:ln/>
+        </p:spPr>
+        <p:txBody>
+          <a:bodyPr wrap="square" lIns="0" tIns="0" rIns="0" bIns="0" rtlCol="0" anchor="ctr"/>
+          <a:lstStyle/>
+          <a:p>
+            <a:pPr indent="0" marL="0">
+              <a:buNone/>
+            </a:pPr>
+            <a:r>
+              <a:rPr lang="en-US" sz="1350" b="1" dirty="0">
                 <a:solidFill>
                   <a:srgbClr val="1E2761"/>
                 </a:solidFill>
@@ -4987,36 +5040,36 @@
               </a:rPr>
               <a:t>參數正確性</a:t>
             </a:r>
-            <a:endParaRPr lang="en-US" sz="1400" dirty="0"/>
-          </a:p>
-        </p:txBody>
-      </p:sp>
-      <p:sp>
-        <p:nvSpPr>
-          <p:cNvPr id="18" name="Text 16"/>
-          <p:cNvSpPr/>
-          <p:nvPr/>
-        </p:nvSpPr>
-        <p:spPr>
-          <a:xfrm>
-            <a:off x="8046720" y="2450592"/>
-            <a:ext cx="3474720" cy="603504"/>
-          </a:xfrm>
-          <a:prstGeom prst="rect">
-            <a:avLst/>
-          </a:prstGeom>
-          <a:noFill/>
-          <a:ln/>
-        </p:spPr>
-        <p:txBody>
-          <a:bodyPr wrap="square" lIns="0" tIns="0" rIns="0" bIns="0" rtlCol="0" anchor="ctr"/>
-          <a:lstStyle/>
-          <a:p>
-            <a:pPr indent="0" marL="0">
-              <a:buNone/>
-            </a:pPr>
-            <a:r>
-              <a:rPr lang="en-US" sz="1250" dirty="0">
+            <a:endParaRPr lang="en-US" sz="1350" dirty="0"/>
+          </a:p>
+        </p:txBody>
+      </p:sp>
+      <p:sp>
+        <p:nvSpPr>
+          <p:cNvPr id="19" name="Text 17"/>
+          <p:cNvSpPr/>
+          <p:nvPr/>
+        </p:nvSpPr>
+        <p:spPr>
+          <a:xfrm>
+            <a:off x="7818120" y="2596896"/>
+            <a:ext cx="3703320" cy="566928"/>
+          </a:xfrm>
+          <a:prstGeom prst="rect">
+            <a:avLst/>
+          </a:prstGeom>
+          <a:noFill/>
+          <a:ln/>
+        </p:spPr>
+        <p:txBody>
+          <a:bodyPr wrap="square" lIns="0" tIns="0" rIns="0" bIns="0" rtlCol="0" anchor="ctr"/>
+          <a:lstStyle/>
+          <a:p>
+            <a:pPr indent="0" marL="0">
+              <a:buNone/>
+            </a:pPr>
+            <a:r>
+              <a:rPr lang="en-US" sz="1200" dirty="0">
                 <a:solidFill>
                   <a:srgbClr val="23272E"/>
                 </a:solidFill>
@@ -5024,22 +5077,22 @@
                 <a:ea typeface="Calibri" pitchFamily="34" charset="-122"/>
                 <a:cs typeface="Calibri" pitchFamily="34" charset="-120"/>
               </a:rPr>
-              <a:t>query_type 亂掰</a:t>
-            </a:r>
-            <a:endParaRPr lang="en-US" sz="1250" dirty="0"/>
-          </a:p>
-        </p:txBody>
-      </p:sp>
-      <p:sp>
-        <p:nvSpPr>
-          <p:cNvPr id="19" name="Shape 17"/>
-          <p:cNvSpPr/>
-          <p:nvPr/>
-        </p:nvSpPr>
-        <p:spPr>
-          <a:xfrm>
-            <a:off x="4846320" y="3163824"/>
-            <a:ext cx="6812280" cy="603504"/>
+              <a:t>參數（query_type）亂填</a:t>
+            </a:r>
+            <a:endParaRPr lang="en-US" sz="1200" dirty="0"/>
+          </a:p>
+        </p:txBody>
+      </p:sp>
+      <p:sp>
+        <p:nvSpPr>
+          <p:cNvPr id="20" name="Shape 18"/>
+          <p:cNvSpPr/>
+          <p:nvPr/>
+        </p:nvSpPr>
+        <p:spPr>
+          <a:xfrm>
+            <a:off x="4846320" y="3255264"/>
+            <a:ext cx="6812280" cy="566928"/>
           </a:xfrm>
           <a:prstGeom prst="rect">
             <a:avLst/>
@@ -5064,14 +5117,14 @@
       </p:sp>
       <p:sp>
         <p:nvSpPr>
-          <p:cNvPr id="20" name="Shape 18"/>
-          <p:cNvSpPr/>
-          <p:nvPr/>
-        </p:nvSpPr>
-        <p:spPr>
-          <a:xfrm>
-            <a:off x="4846320" y="3163824"/>
-            <a:ext cx="91440" cy="603504"/>
+          <p:cNvPr id="21" name="Shape 19"/>
+          <p:cNvSpPr/>
+          <p:nvPr/>
+        </p:nvSpPr>
+        <p:spPr>
+          <a:xfrm>
+            <a:off x="4846320" y="3255264"/>
+            <a:ext cx="91440" cy="566928"/>
           </a:xfrm>
           <a:prstGeom prst="rect">
             <a:avLst/>
@@ -5084,30 +5137,30 @@
       </p:sp>
       <p:sp>
         <p:nvSpPr>
-          <p:cNvPr id="21" name="Text 19"/>
-          <p:cNvSpPr/>
-          <p:nvPr/>
-        </p:nvSpPr>
-        <p:spPr>
-          <a:xfrm>
-            <a:off x="5029200" y="3163824"/>
-            <a:ext cx="731520" cy="603504"/>
-          </a:xfrm>
-          <a:prstGeom prst="rect">
-            <a:avLst/>
-          </a:prstGeom>
-          <a:noFill/>
-          <a:ln/>
-        </p:spPr>
-        <p:txBody>
-          <a:bodyPr wrap="square" lIns="0" tIns="0" rIns="0" bIns="0" rtlCol="0" anchor="ctr"/>
-          <a:lstStyle/>
-          <a:p>
-            <a:pPr indent="0" marL="0">
-              <a:buNone/>
-            </a:pPr>
-            <a:r>
-              <a:rPr lang="en-US" sz="1600" b="1" dirty="0">
+          <p:cNvPr id="22" name="Text 20"/>
+          <p:cNvSpPr/>
+          <p:nvPr/>
+        </p:nvSpPr>
+        <p:spPr>
+          <a:xfrm>
+            <a:off x="5029200" y="3255264"/>
+            <a:ext cx="731520" cy="566928"/>
+          </a:xfrm>
+          <a:prstGeom prst="rect">
+            <a:avLst/>
+          </a:prstGeom>
+          <a:noFill/>
+          <a:ln/>
+        </p:spPr>
+        <p:txBody>
+          <a:bodyPr wrap="square" lIns="0" tIns="0" rIns="0" bIns="0" rtlCol="0" anchor="ctr"/>
+          <a:lstStyle/>
+          <a:p>
+            <a:pPr indent="0" marL="0">
+              <a:buNone/>
+            </a:pPr>
+            <a:r>
+              <a:rPr lang="en-US" sz="1500" b="1" dirty="0">
                 <a:solidFill>
                   <a:srgbClr val="E8A33D"/>
                 </a:solidFill>
@@ -5117,36 +5170,36 @@
               </a:rPr>
               <a:t>L3</a:t>
             </a:r>
-            <a:endParaRPr lang="en-US" sz="1600" dirty="0"/>
-          </a:p>
-        </p:txBody>
-      </p:sp>
-      <p:sp>
-        <p:nvSpPr>
-          <p:cNvPr id="22" name="Text 20"/>
-          <p:cNvSpPr/>
-          <p:nvPr/>
-        </p:nvSpPr>
-        <p:spPr>
-          <a:xfrm>
-            <a:off x="5806440" y="3163824"/>
-            <a:ext cx="2194560" cy="603504"/>
-          </a:xfrm>
-          <a:prstGeom prst="rect">
-            <a:avLst/>
-          </a:prstGeom>
-          <a:noFill/>
-          <a:ln/>
-        </p:spPr>
-        <p:txBody>
-          <a:bodyPr wrap="square" lIns="0" tIns="0" rIns="0" bIns="0" rtlCol="0" anchor="ctr"/>
-          <a:lstStyle/>
-          <a:p>
-            <a:pPr indent="0" marL="0">
-              <a:buNone/>
-            </a:pPr>
-            <a:r>
-              <a:rPr lang="en-US" sz="1400" b="1" dirty="0">
+            <a:endParaRPr lang="en-US" sz="1500" dirty="0"/>
+          </a:p>
+        </p:txBody>
+      </p:sp>
+      <p:sp>
+        <p:nvSpPr>
+          <p:cNvPr id="23" name="Text 21"/>
+          <p:cNvSpPr/>
+          <p:nvPr/>
+        </p:nvSpPr>
+        <p:spPr>
+          <a:xfrm>
+            <a:off x="5760720" y="3255264"/>
+            <a:ext cx="2011680" cy="566928"/>
+          </a:xfrm>
+          <a:prstGeom prst="rect">
+            <a:avLst/>
+          </a:prstGeom>
+          <a:noFill/>
+          <a:ln/>
+        </p:spPr>
+        <p:txBody>
+          <a:bodyPr wrap="square" lIns="0" tIns="0" rIns="0" bIns="0" rtlCol="0" anchor="ctr"/>
+          <a:lstStyle/>
+          <a:p>
+            <a:pPr indent="0" marL="0">
+              <a:buNone/>
+            </a:pPr>
+            <a:r>
+              <a:rPr lang="en-US" sz="1350" b="1" dirty="0">
                 <a:solidFill>
                   <a:srgbClr val="1E2761"/>
                 </a:solidFill>
@@ -5156,36 +5209,36 @@
               </a:rPr>
               <a:t>呼叫策略</a:t>
             </a:r>
-            <a:endParaRPr lang="en-US" sz="1400" dirty="0"/>
-          </a:p>
-        </p:txBody>
-      </p:sp>
-      <p:sp>
-        <p:nvSpPr>
-          <p:cNvPr id="23" name="Text 21"/>
-          <p:cNvSpPr/>
-          <p:nvPr/>
-        </p:nvSpPr>
-        <p:spPr>
-          <a:xfrm>
-            <a:off x="8046720" y="3163824"/>
-            <a:ext cx="3474720" cy="603504"/>
-          </a:xfrm>
-          <a:prstGeom prst="rect">
-            <a:avLst/>
-          </a:prstGeom>
-          <a:noFill/>
-          <a:ln/>
-        </p:spPr>
-        <p:txBody>
-          <a:bodyPr wrap="square" lIns="0" tIns="0" rIns="0" bIns="0" rtlCol="0" anchor="ctr"/>
-          <a:lstStyle/>
-          <a:p>
-            <a:pPr indent="0" marL="0">
-              <a:buNone/>
-            </a:pPr>
-            <a:r>
-              <a:rPr lang="en-US" sz="1250" dirty="0">
+            <a:endParaRPr lang="en-US" sz="1350" dirty="0"/>
+          </a:p>
+        </p:txBody>
+      </p:sp>
+      <p:sp>
+        <p:nvSpPr>
+          <p:cNvPr id="24" name="Text 22"/>
+          <p:cNvSpPr/>
+          <p:nvPr/>
+        </p:nvSpPr>
+        <p:spPr>
+          <a:xfrm>
+            <a:off x="7818120" y="3255264"/>
+            <a:ext cx="3703320" cy="566928"/>
+          </a:xfrm>
+          <a:prstGeom prst="rect">
+            <a:avLst/>
+          </a:prstGeom>
+          <a:noFill/>
+          <a:ln/>
+        </p:spPr>
+        <p:txBody>
+          <a:bodyPr wrap="square" lIns="0" tIns="0" rIns="0" bIns="0" rtlCol="0" anchor="ctr"/>
+          <a:lstStyle/>
+          <a:p>
+            <a:pPr indent="0" marL="0">
+              <a:buNone/>
+            </a:pPr>
+            <a:r>
+              <a:rPr lang="en-US" sz="1200" dirty="0">
                 <a:solidFill>
                   <a:srgbClr val="23272E"/>
                 </a:solidFill>
@@ -5195,20 +5248,20 @@
               </a:rPr>
               <a:t>「不查了，直接猜」</a:t>
             </a:r>
-            <a:endParaRPr lang="en-US" sz="1250" dirty="0"/>
-          </a:p>
-        </p:txBody>
-      </p:sp>
-      <p:sp>
-        <p:nvSpPr>
-          <p:cNvPr id="24" name="Shape 22"/>
-          <p:cNvSpPr/>
-          <p:nvPr/>
-        </p:nvSpPr>
-        <p:spPr>
-          <a:xfrm>
-            <a:off x="4846320" y="3877056"/>
-            <a:ext cx="6812280" cy="603504"/>
+            <a:endParaRPr lang="en-US" sz="1200" dirty="0"/>
+          </a:p>
+        </p:txBody>
+      </p:sp>
+      <p:sp>
+        <p:nvSpPr>
+          <p:cNvPr id="25" name="Shape 23"/>
+          <p:cNvSpPr/>
+          <p:nvPr/>
+        </p:nvSpPr>
+        <p:spPr>
+          <a:xfrm>
+            <a:off x="4846320" y="3913632"/>
+            <a:ext cx="6812280" cy="566928"/>
           </a:xfrm>
           <a:prstGeom prst="rect">
             <a:avLst/>
@@ -5233,14 +5286,14 @@
       </p:sp>
       <p:sp>
         <p:nvSpPr>
-          <p:cNvPr id="25" name="Shape 23"/>
-          <p:cNvSpPr/>
-          <p:nvPr/>
-        </p:nvSpPr>
-        <p:spPr>
-          <a:xfrm>
-            <a:off x="4846320" y="3877056"/>
-            <a:ext cx="91440" cy="603504"/>
+          <p:cNvPr id="26" name="Shape 24"/>
+          <p:cNvSpPr/>
+          <p:nvPr/>
+        </p:nvSpPr>
+        <p:spPr>
+          <a:xfrm>
+            <a:off x="4846320" y="3913632"/>
+            <a:ext cx="91440" cy="566928"/>
           </a:xfrm>
           <a:prstGeom prst="rect">
             <a:avLst/>
@@ -5253,30 +5306,30 @@
       </p:sp>
       <p:sp>
         <p:nvSpPr>
-          <p:cNvPr id="26" name="Text 24"/>
-          <p:cNvSpPr/>
-          <p:nvPr/>
-        </p:nvSpPr>
-        <p:spPr>
-          <a:xfrm>
-            <a:off x="5029200" y="3877056"/>
-            <a:ext cx="731520" cy="603504"/>
-          </a:xfrm>
-          <a:prstGeom prst="rect">
-            <a:avLst/>
-          </a:prstGeom>
-          <a:noFill/>
-          <a:ln/>
-        </p:spPr>
-        <p:txBody>
-          <a:bodyPr wrap="square" lIns="0" tIns="0" rIns="0" bIns="0" rtlCol="0" anchor="ctr"/>
-          <a:lstStyle/>
-          <a:p>
-            <a:pPr indent="0" marL="0">
-              <a:buNone/>
-            </a:pPr>
-            <a:r>
-              <a:rPr lang="en-US" sz="1600" b="1" dirty="0">
+          <p:cNvPr id="27" name="Text 25"/>
+          <p:cNvSpPr/>
+          <p:nvPr/>
+        </p:nvSpPr>
+        <p:spPr>
+          <a:xfrm>
+            <a:off x="5029200" y="3913632"/>
+            <a:ext cx="731520" cy="566928"/>
+          </a:xfrm>
+          <a:prstGeom prst="rect">
+            <a:avLst/>
+          </a:prstGeom>
+          <a:noFill/>
+          <a:ln/>
+        </p:spPr>
+        <p:txBody>
+          <a:bodyPr wrap="square" lIns="0" tIns="0" rIns="0" bIns="0" rtlCol="0" anchor="ctr"/>
+          <a:lstStyle/>
+          <a:p>
+            <a:pPr indent="0" marL="0">
+              <a:buNone/>
+            </a:pPr>
+            <a:r>
+              <a:rPr lang="en-US" sz="1500" b="1" dirty="0">
                 <a:solidFill>
                   <a:srgbClr val="3A5BA0"/>
                 </a:solidFill>
@@ -5286,36 +5339,36 @@
               </a:rPr>
               <a:t>L4</a:t>
             </a:r>
-            <a:endParaRPr lang="en-US" sz="1600" dirty="0"/>
-          </a:p>
-        </p:txBody>
-      </p:sp>
-      <p:sp>
-        <p:nvSpPr>
-          <p:cNvPr id="27" name="Text 25"/>
-          <p:cNvSpPr/>
-          <p:nvPr/>
-        </p:nvSpPr>
-        <p:spPr>
-          <a:xfrm>
-            <a:off x="5806440" y="3877056"/>
-            <a:ext cx="2194560" cy="603504"/>
-          </a:xfrm>
-          <a:prstGeom prst="rect">
-            <a:avLst/>
-          </a:prstGeom>
-          <a:noFill/>
-          <a:ln/>
-        </p:spPr>
-        <p:txBody>
-          <a:bodyPr wrap="square" lIns="0" tIns="0" rIns="0" bIns="0" rtlCol="0" anchor="ctr"/>
-          <a:lstStyle/>
-          <a:p>
-            <a:pPr indent="0" marL="0">
-              <a:buNone/>
-            </a:pPr>
-            <a:r>
-              <a:rPr lang="en-US" sz="1400" b="1" dirty="0">
+            <a:endParaRPr lang="en-US" sz="1500" dirty="0"/>
+          </a:p>
+        </p:txBody>
+      </p:sp>
+      <p:sp>
+        <p:nvSpPr>
+          <p:cNvPr id="28" name="Text 26"/>
+          <p:cNvSpPr/>
+          <p:nvPr/>
+        </p:nvSpPr>
+        <p:spPr>
+          <a:xfrm>
+            <a:off x="5760720" y="3913632"/>
+            <a:ext cx="2011680" cy="566928"/>
+          </a:xfrm>
+          <a:prstGeom prst="rect">
+            <a:avLst/>
+          </a:prstGeom>
+          <a:noFill/>
+          <a:ln/>
+        </p:spPr>
+        <p:txBody>
+          <a:bodyPr wrap="square" lIns="0" tIns="0" rIns="0" bIns="0" rtlCol="0" anchor="ctr"/>
+          <a:lstStyle/>
+          <a:p>
+            <a:pPr indent="0" marL="0">
+              <a:buNone/>
+            </a:pPr>
+            <a:r>
+              <a:rPr lang="en-US" sz="1350" b="1" dirty="0">
                 <a:solidFill>
                   <a:srgbClr val="1E2761"/>
                 </a:solidFill>
@@ -5325,36 +5378,36 @@
               </a:rPr>
               <a:t>結果消化</a:t>
             </a:r>
-            <a:endParaRPr lang="en-US" sz="1400" dirty="0"/>
-          </a:p>
-        </p:txBody>
-      </p:sp>
-      <p:sp>
-        <p:nvSpPr>
-          <p:cNvPr id="28" name="Text 26"/>
-          <p:cNvSpPr/>
-          <p:nvPr/>
-        </p:nvSpPr>
-        <p:spPr>
-          <a:xfrm>
-            <a:off x="8046720" y="3877056"/>
-            <a:ext cx="3474720" cy="603504"/>
-          </a:xfrm>
-          <a:prstGeom prst="rect">
-            <a:avLst/>
-          </a:prstGeom>
-          <a:noFill/>
-          <a:ln/>
-        </p:spPr>
-        <p:txBody>
-          <a:bodyPr wrap="square" lIns="0" tIns="0" rIns="0" bIns="0" rtlCol="0" anchor="ctr"/>
-          <a:lstStyle/>
-          <a:p>
-            <a:pPr indent="0" marL="0">
-              <a:buNone/>
-            </a:pPr>
-            <a:r>
-              <a:rPr lang="en-US" sz="1250" dirty="0">
+            <a:endParaRPr lang="en-US" sz="1350" dirty="0"/>
+          </a:p>
+        </p:txBody>
+      </p:sp>
+      <p:sp>
+        <p:nvSpPr>
+          <p:cNvPr id="29" name="Text 27"/>
+          <p:cNvSpPr/>
+          <p:nvPr/>
+        </p:nvSpPr>
+        <p:spPr>
+          <a:xfrm>
+            <a:off x="7818120" y="3913632"/>
+            <a:ext cx="3703320" cy="566928"/>
+          </a:xfrm>
+          <a:prstGeom prst="rect">
+            <a:avLst/>
+          </a:prstGeom>
+          <a:noFill/>
+          <a:ln/>
+        </p:spPr>
+        <p:txBody>
+          <a:bodyPr wrap="square" lIns="0" tIns="0" rIns="0" bIns="0" rtlCol="0" anchor="ctr"/>
+          <a:lstStyle/>
+          <a:p>
+            <a:pPr indent="0" marL="0">
+              <a:buNone/>
+            </a:pPr>
+            <a:r>
+              <a:rPr lang="en-US" sz="1200" dirty="0">
                 <a:solidFill>
                   <a:srgbClr val="23272E"/>
                 </a:solidFill>
@@ -5362,22 +5415,22 @@
                 <a:ea typeface="Calibri" pitchFamily="34" charset="-122"/>
                 <a:cs typeface="Calibri" pitchFamily="34" charset="-120"/>
               </a:rPr>
-              <a:t>上千筆 review 怎麼取樣</a:t>
-            </a:r>
-            <a:endParaRPr lang="en-US" sz="1250" dirty="0"/>
-          </a:p>
-        </p:txBody>
-      </p:sp>
-      <p:sp>
-        <p:nvSpPr>
-          <p:cNvPr id="29" name="Shape 27"/>
-          <p:cNvSpPr/>
-          <p:nvPr/>
-        </p:nvSpPr>
-        <p:spPr>
-          <a:xfrm>
-            <a:off x="4846320" y="4590288"/>
-            <a:ext cx="6812280" cy="603504"/>
+              <a:t>上千筆 review 不知怎麼取樣</a:t>
+            </a:r>
+            <a:endParaRPr lang="en-US" sz="1200" dirty="0"/>
+          </a:p>
+        </p:txBody>
+      </p:sp>
+      <p:sp>
+        <p:nvSpPr>
+          <p:cNvPr id="30" name="Shape 28"/>
+          <p:cNvSpPr/>
+          <p:nvPr/>
+        </p:nvSpPr>
+        <p:spPr>
+          <a:xfrm>
+            <a:off x="4846320" y="4572000"/>
+            <a:ext cx="6812280" cy="566928"/>
           </a:xfrm>
           <a:prstGeom prst="rect">
             <a:avLst/>
@@ -5402,14 +5455,14 @@
       </p:sp>
       <p:sp>
         <p:nvSpPr>
-          <p:cNvPr id="30" name="Shape 28"/>
-          <p:cNvSpPr/>
-          <p:nvPr/>
-        </p:nvSpPr>
-        <p:spPr>
-          <a:xfrm>
-            <a:off x="4846320" y="4590288"/>
-            <a:ext cx="91440" cy="603504"/>
+          <p:cNvPr id="31" name="Shape 29"/>
+          <p:cNvSpPr/>
+          <p:nvPr/>
+        </p:nvSpPr>
+        <p:spPr>
+          <a:xfrm>
+            <a:off x="4846320" y="4572000"/>
+            <a:ext cx="91440" cy="566928"/>
           </a:xfrm>
           <a:prstGeom prst="rect">
             <a:avLst/>
@@ -5422,30 +5475,30 @@
       </p:sp>
       <p:sp>
         <p:nvSpPr>
-          <p:cNvPr id="31" name="Text 29"/>
-          <p:cNvSpPr/>
-          <p:nvPr/>
-        </p:nvSpPr>
-        <p:spPr>
-          <a:xfrm>
-            <a:off x="5029200" y="4590288"/>
-            <a:ext cx="731520" cy="603504"/>
-          </a:xfrm>
-          <a:prstGeom prst="rect">
-            <a:avLst/>
-          </a:prstGeom>
-          <a:noFill/>
-          <a:ln/>
-        </p:spPr>
-        <p:txBody>
-          <a:bodyPr wrap="square" lIns="0" tIns="0" rIns="0" bIns="0" rtlCol="0" anchor="ctr"/>
-          <a:lstStyle/>
-          <a:p>
-            <a:pPr indent="0" marL="0">
-              <a:buNone/>
-            </a:pPr>
-            <a:r>
-              <a:rPr lang="en-US" sz="1600" b="1" dirty="0">
+          <p:cNvPr id="32" name="Text 30"/>
+          <p:cNvSpPr/>
+          <p:nvPr/>
+        </p:nvSpPr>
+        <p:spPr>
+          <a:xfrm>
+            <a:off x="5029200" y="4572000"/>
+            <a:ext cx="731520" cy="566928"/>
+          </a:xfrm>
+          <a:prstGeom prst="rect">
+            <a:avLst/>
+          </a:prstGeom>
+          <a:noFill/>
+          <a:ln/>
+        </p:spPr>
+        <p:txBody>
+          <a:bodyPr wrap="square" lIns="0" tIns="0" rIns="0" bIns="0" rtlCol="0" anchor="ctr"/>
+          <a:lstStyle/>
+          <a:p>
+            <a:pPr indent="0" marL="0">
+              <a:buNone/>
+            </a:pPr>
+            <a:r>
+              <a:rPr lang="en-US" sz="1500" b="1" dirty="0">
                 <a:solidFill>
                   <a:srgbClr val="3A5BA0"/>
                 </a:solidFill>
@@ -5455,36 +5508,36 @@
               </a:rPr>
               <a:t>L5</a:t>
             </a:r>
-            <a:endParaRPr lang="en-US" sz="1600" dirty="0"/>
-          </a:p>
-        </p:txBody>
-      </p:sp>
-      <p:sp>
-        <p:nvSpPr>
-          <p:cNvPr id="32" name="Text 30"/>
-          <p:cNvSpPr/>
-          <p:nvPr/>
-        </p:nvSpPr>
-        <p:spPr>
-          <a:xfrm>
-            <a:off x="5806440" y="4590288"/>
-            <a:ext cx="2194560" cy="603504"/>
-          </a:xfrm>
-          <a:prstGeom prst="rect">
-            <a:avLst/>
-          </a:prstGeom>
-          <a:noFill/>
-          <a:ln/>
-        </p:spPr>
-        <p:txBody>
-          <a:bodyPr wrap="square" lIns="0" tIns="0" rIns="0" bIns="0" rtlCol="0" anchor="ctr"/>
-          <a:lstStyle/>
-          <a:p>
-            <a:pPr indent="0" marL="0">
-              <a:buNone/>
-            </a:pPr>
-            <a:r>
-              <a:rPr lang="en-US" sz="1400" b="1" dirty="0">
+            <a:endParaRPr lang="en-US" sz="1500" dirty="0"/>
+          </a:p>
+        </p:txBody>
+      </p:sp>
+      <p:sp>
+        <p:nvSpPr>
+          <p:cNvPr id="33" name="Text 31"/>
+          <p:cNvSpPr/>
+          <p:nvPr/>
+        </p:nvSpPr>
+        <p:spPr>
+          <a:xfrm>
+            <a:off x="5760720" y="4572000"/>
+            <a:ext cx="2011680" cy="566928"/>
+          </a:xfrm>
+          <a:prstGeom prst="rect">
+            <a:avLst/>
+          </a:prstGeom>
+          <a:noFill/>
+          <a:ln/>
+        </p:spPr>
+        <p:txBody>
+          <a:bodyPr wrap="square" lIns="0" tIns="0" rIns="0" bIns="0" rtlCol="0" anchor="ctr"/>
+          <a:lstStyle/>
+          <a:p>
+            <a:pPr indent="0" marL="0">
+              <a:buNone/>
+            </a:pPr>
+            <a:r>
+              <a:rPr lang="en-US" sz="1350" b="1" dirty="0">
                 <a:solidFill>
                   <a:srgbClr val="1E2761"/>
                 </a:solidFill>
@@ -5494,36 +5547,36 @@
               </a:rPr>
               <a:t>下游契約</a:t>
             </a:r>
-            <a:endParaRPr lang="en-US" sz="1400" dirty="0"/>
-          </a:p>
-        </p:txBody>
-      </p:sp>
-      <p:sp>
-        <p:nvSpPr>
-          <p:cNvPr id="33" name="Text 31"/>
-          <p:cNvSpPr/>
-          <p:nvPr/>
-        </p:nvSpPr>
-        <p:spPr>
-          <a:xfrm>
-            <a:off x="8046720" y="4590288"/>
-            <a:ext cx="3474720" cy="603504"/>
-          </a:xfrm>
-          <a:prstGeom prst="rect">
-            <a:avLst/>
-          </a:prstGeom>
-          <a:noFill/>
-          <a:ln/>
-        </p:spPr>
-        <p:txBody>
-          <a:bodyPr wrap="square" lIns="0" tIns="0" rIns="0" bIns="0" rtlCol="0" anchor="ctr"/>
-          <a:lstStyle/>
-          <a:p>
-            <a:pPr indent="0" marL="0">
-              <a:buNone/>
-            </a:pPr>
-            <a:r>
-              <a:rPr lang="en-US" sz="1250" dirty="0">
+            <a:endParaRPr lang="en-US" sz="1350" dirty="0"/>
+          </a:p>
+        </p:txBody>
+      </p:sp>
+      <p:sp>
+        <p:nvSpPr>
+          <p:cNvPr id="34" name="Text 32"/>
+          <p:cNvSpPr/>
+          <p:nvPr/>
+        </p:nvSpPr>
+        <p:spPr>
+          <a:xfrm>
+            <a:off x="7818120" y="4572000"/>
+            <a:ext cx="3703320" cy="566928"/>
+          </a:xfrm>
+          <a:prstGeom prst="rect">
+            <a:avLst/>
+          </a:prstGeom>
+          <a:noFill/>
+          <a:ln/>
+        </p:spPr>
+        <p:txBody>
+          <a:bodyPr wrap="square" lIns="0" tIns="0" rIns="0" bIns="0" rtlCol="0" anchor="ctr"/>
+          <a:lstStyle/>
+          <a:p>
+            <a:pPr indent="0" marL="0">
+              <a:buNone/>
+            </a:pPr>
+            <a:r>
+              <a:rPr lang="en-US" sz="1200" dirty="0">
                 <a:solidFill>
                   <a:srgbClr val="23272E"/>
                 </a:solidFill>
@@ -5531,21 +5584,21 @@
                 <a:ea typeface="Calibri" pitchFamily="34" charset="-122"/>
                 <a:cs typeface="Calibri" pitchFamily="34" charset="-120"/>
               </a:rPr>
-              <a:t>summary 結構爛掉</a:t>
-            </a:r>
-            <a:endParaRPr lang="en-US" sz="1250" dirty="0"/>
-          </a:p>
-        </p:txBody>
-      </p:sp>
-      <p:sp>
-        <p:nvSpPr>
-          <p:cNvPr id="34" name="Text 32"/>
-          <p:cNvSpPr/>
-          <p:nvPr/>
-        </p:nvSpPr>
-        <p:spPr>
-          <a:xfrm>
-            <a:off x="4846320" y="5394960"/>
+              <a:t>傳給下一棒的摘要爛掉</a:t>
+            </a:r>
+            <a:endParaRPr lang="en-US" sz="1200" dirty="0"/>
+          </a:p>
+        </p:txBody>
+      </p:sp>
+      <p:sp>
+        <p:nvSpPr>
+          <p:cNvPr id="35" name="Text 33"/>
+          <p:cNvSpPr/>
+          <p:nvPr/>
+        </p:nvSpPr>
+        <p:spPr>
+          <a:xfrm>
+            <a:off x="4846320" y="5285232"/>
             <a:ext cx="6812280" cy="685800"/>
           </a:xfrm>
           <a:prstGeom prst="rect">
@@ -5573,7 +5626,7 @@
                 <a:ea typeface="Calibri" pitchFamily="34" charset="-122"/>
                 <a:cs typeface="Calibri" pitchFamily="34" charset="-120"/>
               </a:rPr>
-              <a:t>Claude 沒直接 try/except，而是先把「工具呼叫會怎麼壞」拆成 5 層——這套分法就叫「失敗分類學」。金句：fitness 只告訴你「壞了」，不告訴你「哪裡壞了」。</a:t>
+              <a:t>好處：進化改壞其中任何一層，最壞只是退化、不是整個崩潰。關鍵洞察——fitness 只告訴你「壞了」，不告訴你「哪裡壞了」；分層才能對症下藥。</a:t>
             </a:r>
             <a:endParaRPr lang="en-US" sz="1150" dirty="0"/>
           </a:p>
@@ -5581,7 +5634,7 @@
       </p:sp>
       <p:sp>
         <p:nvSpPr>
-          <p:cNvPr id="35" name="Text 33"/>
+          <p:cNvPr id="36" name="Text 34"/>
           <p:cNvSpPr/>
           <p:nvPr/>
         </p:nvSpPr>
@@ -5632,20 +5685,13 @@
               <a:buNone/>
             </a:pPr>
             <a:r>
-              <a:rPr lang="en-US" sz="900" u="sng" dirty="0">
-                <a:solidFill>
-                  <a:srgbClr val="3A5BA0"/>
+              <a:rPr lang="en-US" sz="900" dirty="0">
+                <a:solidFill>
+                  <a:srgbClr val="6B7280"/>
                 </a:solidFill>
                 <a:latin typeface="Consolas" pitchFamily="34" charset="0"/>
                 <a:ea typeface="Consolas" pitchFamily="34" charset="-122"/>
                 <a:cs typeface="Consolas" pitchFamily="34" charset="-120"/>
-                <a:hlinkClick r:id="rId1" invalidUrl="" action="" tgtFrame="" tooltip="" history="1" highlightClick="0" endSnd="0">
-                  <a:extLst>
-                    <a:ext uri="{A12FA001-AC4F-418D-AE19-62706E023703}">
-                      <ahyp:hlinkClr xmlns:ahyp="http://schemas.microsoft.com/office/drawing/2018/hyperlinkcolor" val="tx"/>
-                    </a:ext>
-                  </a:extLst>
-                </a:hlinkClick>
               </a:rPr>
               <a:t>docs/evolution_design_notes.md</a:t>
             </a:r>
@@ -12206,20 +12252,13 @@
               <a:buNone/>
             </a:pPr>
             <a:r>
-              <a:rPr lang="en-US" sz="900" u="sng" dirty="0">
-                <a:solidFill>
-                  <a:srgbClr val="3A5BA0"/>
+              <a:rPr lang="en-US" sz="900" dirty="0">
+                <a:solidFill>
+                  <a:srgbClr val="6B7280"/>
                 </a:solidFill>
                 <a:latin typeface="Consolas" pitchFamily="34" charset="0"/>
                 <a:ea typeface="Consolas" pitchFamily="34" charset="-122"/>
                 <a:cs typeface="Consolas" pitchFamily="34" charset="-120"/>
-                <a:hlinkClick r:id="rId1" invalidUrl="" action="" tgtFrame="" tooltip="" history="1" highlightClick="0" endSnd="0">
-                  <a:extLst>
-                    <a:ext uri="{A12FA001-AC4F-418D-AE19-62706E023703}">
-                      <ahyp:hlinkClr xmlns:ahyp="http://schemas.microsoft.com/office/drawing/2018/hyperlinkcolor" val="tx"/>
-                    </a:ext>
-                  </a:extLst>
-                </a:hlinkClick>
               </a:rPr>
               <a:t>CLAUDE.md</a:t>
             </a:r>
@@ -12241,20 +12280,13 @@
               <a:buNone/>
             </a:pPr>
             <a:r>
-              <a:rPr lang="en-US" sz="900" u="sng" dirty="0">
-                <a:solidFill>
-                  <a:srgbClr val="3A5BA0"/>
+              <a:rPr lang="en-US" sz="900" dirty="0">
+                <a:solidFill>
+                  <a:srgbClr val="6B7280"/>
                 </a:solidFill>
                 <a:latin typeface="Consolas" pitchFamily="34" charset="0"/>
                 <a:ea typeface="Consolas" pitchFamily="34" charset="-122"/>
                 <a:cs typeface="Consolas" pitchFamily="34" charset="-120"/>
-                <a:hlinkClick r:id="rId2" invalidUrl="" action="" tgtFrame="" tooltip="" history="1" highlightClick="0" endSnd="0">
-                  <a:extLst>
-                    <a:ext uri="{A12FA001-AC4F-418D-AE19-62706E023703}">
-                      <ahyp:hlinkClr xmlns:ahyp="http://schemas.microsoft.com/office/drawing/2018/hyperlinkcolor" val="tx"/>
-                    </a:ext>
-                  </a:extLst>
-                </a:hlinkClick>
               </a:rPr>
               <a:t>docs/evolution_design_notes.md</a:t>
             </a:r>
@@ -13014,20 +13046,13 @@
               <a:buNone/>
             </a:pPr>
             <a:r>
-              <a:rPr lang="en-US" sz="900" u="sng" dirty="0">
-                <a:solidFill>
-                  <a:srgbClr val="3A5BA0"/>
+              <a:rPr lang="en-US" sz="900" dirty="0">
+                <a:solidFill>
+                  <a:srgbClr val="6B7280"/>
                 </a:solidFill>
                 <a:latin typeface="Consolas" pitchFamily="34" charset="0"/>
                 <a:ea typeface="Consolas" pitchFamily="34" charset="-122"/>
                 <a:cs typeface="Consolas" pitchFamily="34" charset="-120"/>
-                <a:hlinkClick r:id="rId1" invalidUrl="" action="" tgtFrame="" tooltip="" history="1" highlightClick="0" endSnd="0">
-                  <a:extLst>
-                    <a:ext uri="{A12FA001-AC4F-418D-AE19-62706E023703}">
-                      <ahyp:hlinkClr xmlns:ahyp="http://schemas.microsoft.com/office/drawing/2018/hyperlinkcolor" val="tx"/>
-                    </a:ext>
-                  </a:extLst>
-                </a:hlinkClick>
               </a:rPr>
               <a:t>docs/evolution_design_notes.md</a:t>
             </a:r>
@@ -14742,20 +14767,13 @@
               <a:buNone/>
             </a:pPr>
             <a:r>
-              <a:rPr lang="en-US" sz="900" u="sng" dirty="0">
-                <a:solidFill>
-                  <a:srgbClr val="3A5BA0"/>
+              <a:rPr lang="en-US" sz="900" dirty="0">
+                <a:solidFill>
+                  <a:srgbClr val="6B7280"/>
                 </a:solidFill>
                 <a:latin typeface="Consolas" pitchFamily="34" charset="0"/>
                 <a:ea typeface="Consolas" pitchFamily="34" charset="-122"/>
                 <a:cs typeface="Consolas" pitchFamily="34" charset="-120"/>
-                <a:hlinkClick r:id="rId1" invalidUrl="" action="" tgtFrame="" tooltip="" history="1" highlightClick="0" endSnd="0">
-                  <a:extLst>
-                    <a:ext uri="{A12FA001-AC4F-418D-AE19-62706E023703}">
-                      <ahyp:hlinkClr xmlns:ahyp="http://schemas.microsoft.com/office/drawing/2018/hyperlinkcolor" val="tx"/>
-                    </a:ext>
-                  </a:extLst>
-                </a:hlinkClick>
               </a:rPr>
               <a:t>docs/collaboration_workflow_outline.md</a:t>
             </a:r>
@@ -15607,20 +15625,13 @@
               <a:buNone/>
             </a:pPr>
             <a:r>
-              <a:rPr lang="en-US" sz="900" u="sng" dirty="0">
-                <a:solidFill>
-                  <a:srgbClr val="3A5BA0"/>
+              <a:rPr lang="en-US" sz="900" dirty="0">
+                <a:solidFill>
+                  <a:srgbClr val="6B7280"/>
                 </a:solidFill>
                 <a:latin typeface="Consolas" pitchFamily="34" charset="0"/>
                 <a:ea typeface="Consolas" pitchFamily="34" charset="-122"/>
                 <a:cs typeface="Consolas" pitchFamily="34" charset="-120"/>
-                <a:hlinkClick r:id="rId2" invalidUrl="" action="" tgtFrame="" tooltip="" history="1" highlightClick="0" endSnd="0">
-                  <a:extLst>
-                    <a:ext uri="{A12FA001-AC4F-418D-AE19-62706E023703}">
-                      <ahyp:hlinkClr xmlns:ahyp="http://schemas.microsoft.com/office/drawing/2018/hyperlinkcolor" val="tx"/>
-                    </a:ext>
-                  </a:extLst>
-                </a:hlinkClick>
               </a:rPr>
               <a:t>docs/evolution_design_notes.md</a:t>
             </a:r>
@@ -16851,6 +16862,34 @@
               <a:buNone/>
             </a:pPr>
             <a:r>
+              <a:rPr lang="en-US" sz="900" dirty="0">
+                <a:solidFill>
+                  <a:srgbClr val="6B7280"/>
+                </a:solidFill>
+                <a:latin typeface="Consolas" pitchFamily="34" charset="0"/>
+                <a:ea typeface="Consolas" pitchFamily="34" charset="-122"/>
+                <a:cs typeface="Consolas" pitchFamily="34" charset="-120"/>
+              </a:rPr>
+              <a:t>docs/evolution_design_notes.md</a:t>
+            </a:r>
+            <a:pPr indent="0" marL="0">
+              <a:buNone/>
+            </a:pPr>
+            <a:r>
+              <a:rPr lang="en-US" sz="900" dirty="0">
+                <a:solidFill>
+                  <a:srgbClr val="6B7280"/>
+                </a:solidFill>
+                <a:latin typeface="Consolas" pitchFamily="34" charset="0"/>
+                <a:ea typeface="Consolas" pitchFamily="34" charset="-122"/>
+                <a:cs typeface="Consolas" pitchFamily="34" charset="-120"/>
+              </a:rPr>
+              <a:t> §12.7(b) · diff_based_evolution:false 見 </a:t>
+            </a:r>
+            <a:pPr indent="0" marL="0">
+              <a:buNone/>
+            </a:pPr>
+            <a:r>
               <a:rPr lang="en-US" sz="900" u="sng" dirty="0">
                 <a:solidFill>
                   <a:srgbClr val="3A5BA0"/>
@@ -16859,41 +16898,6 @@
                 <a:ea typeface="Consolas" pitchFamily="34" charset="-122"/>
                 <a:cs typeface="Consolas" pitchFamily="34" charset="-120"/>
                 <a:hlinkClick r:id="rId1" invalidUrl="" action="" tgtFrame="" tooltip="" history="1" highlightClick="0" endSnd="0">
-                  <a:extLst>
-                    <a:ext uri="{A12FA001-AC4F-418D-AE19-62706E023703}">
-                      <ahyp:hlinkClr xmlns:ahyp="http://schemas.microsoft.com/office/drawing/2018/hyperlinkcolor" val="tx"/>
-                    </a:ext>
-                  </a:extLst>
-                </a:hlinkClick>
-              </a:rPr>
-              <a:t>docs/evolution_design_notes.md</a:t>
-            </a:r>
-            <a:pPr indent="0" marL="0">
-              <a:buNone/>
-            </a:pPr>
-            <a:r>
-              <a:rPr lang="en-US" sz="900" dirty="0">
-                <a:solidFill>
-                  <a:srgbClr val="6B7280"/>
-                </a:solidFill>
-                <a:latin typeface="Consolas" pitchFamily="34" charset="0"/>
-                <a:ea typeface="Consolas" pitchFamily="34" charset="-122"/>
-                <a:cs typeface="Consolas" pitchFamily="34" charset="-120"/>
-              </a:rPr>
-              <a:t> §12.7(b) · diff_based_evolution:false 見 </a:t>
-            </a:r>
-            <a:pPr indent="0" marL="0">
-              <a:buNone/>
-            </a:pPr>
-            <a:r>
-              <a:rPr lang="en-US" sz="900" u="sng" dirty="0">
-                <a:solidFill>
-                  <a:srgbClr val="3A5BA0"/>
-                </a:solidFill>
-                <a:latin typeface="Consolas" pitchFamily="34" charset="0"/>
-                <a:ea typeface="Consolas" pitchFamily="34" charset="-122"/>
-                <a:cs typeface="Consolas" pitchFamily="34" charset="-120"/>
-                <a:hlinkClick r:id="rId2" invalidUrl="" action="" tgtFrame="" tooltip="" history="1" highlightClick="0" endSnd="0">
                   <a:extLst>
                     <a:ext uri="{A12FA001-AC4F-418D-AE19-62706E023703}">
                       <ahyp:hlinkClr xmlns:ahyp="http://schemas.microsoft.com/office/drawing/2018/hyperlinkcolor" val="tx"/>
@@ -18400,20 +18404,13 @@
               <a:buNone/>
             </a:pPr>
             <a:r>
-              <a:rPr lang="en-US" sz="900" u="sng" dirty="0">
-                <a:solidFill>
-                  <a:srgbClr val="3A5BA0"/>
+              <a:rPr lang="en-US" sz="900" dirty="0">
+                <a:solidFill>
+                  <a:srgbClr val="6B7280"/>
                 </a:solidFill>
                 <a:latin typeface="Consolas" pitchFamily="34" charset="0"/>
                 <a:ea typeface="Consolas" pitchFamily="34" charset="-122"/>
                 <a:cs typeface="Consolas" pitchFamily="34" charset="-120"/>
-                <a:hlinkClick r:id="rId1" invalidUrl="" action="" tgtFrame="" tooltip="" history="1" highlightClick="0" endSnd="0">
-                  <a:extLst>
-                    <a:ext uri="{A12FA001-AC4F-418D-AE19-62706E023703}">
-                      <ahyp:hlinkClr xmlns:ahyp="http://schemas.microsoft.com/office/drawing/2018/hyperlinkcolor" val="tx"/>
-                    </a:ext>
-                  </a:extLst>
-                </a:hlinkClick>
               </a:rPr>
               <a:t>docs/evolution_design_notes.md</a:t>
             </a:r>
@@ -18955,20 +18952,13 @@
               <a:buNone/>
             </a:pPr>
             <a:r>
-              <a:rPr lang="en-US" sz="900" u="sng" dirty="0">
-                <a:solidFill>
-                  <a:srgbClr val="CADCFC"/>
+              <a:rPr lang="en-US" sz="900" dirty="0">
+                <a:solidFill>
+                  <a:srgbClr val="8FA3C8"/>
                 </a:solidFill>
                 <a:latin typeface="Consolas" pitchFamily="34" charset="0"/>
                 <a:ea typeface="Consolas" pitchFamily="34" charset="-122"/>
                 <a:cs typeface="Consolas" pitchFamily="34" charset="-120"/>
-                <a:hlinkClick r:id="rId1" invalidUrl="" action="" tgtFrame="" tooltip="" history="1" highlightClick="0" endSnd="0">
-                  <a:extLst>
-                    <a:ext uri="{A12FA001-AC4F-418D-AE19-62706E023703}">
-                      <ahyp:hlinkClr xmlns:ahyp="http://schemas.microsoft.com/office/drawing/2018/hyperlinkcolor" val="tx"/>
-                    </a:ext>
-                  </a:extLst>
-                </a:hlinkClick>
               </a:rPr>
               <a:t>docs/evolution_design_notes.md</a:t>
             </a:r>
@@ -20279,20 +20269,13 @@
               <a:buNone/>
             </a:pPr>
             <a:r>
-              <a:rPr lang="en-US" sz="900" u="sng" dirty="0">
-                <a:solidFill>
-                  <a:srgbClr val="3A5BA0"/>
+              <a:rPr lang="en-US" sz="900" dirty="0">
+                <a:solidFill>
+                  <a:srgbClr val="6B7280"/>
                 </a:solidFill>
                 <a:latin typeface="Consolas" pitchFamily="34" charset="0"/>
                 <a:ea typeface="Consolas" pitchFamily="34" charset="-122"/>
                 <a:cs typeface="Consolas" pitchFamily="34" charset="-120"/>
-                <a:hlinkClick r:id="rId1" invalidUrl="" action="" tgtFrame="" tooltip="" history="1" highlightClick="0" endSnd="0">
-                  <a:extLst>
-                    <a:ext uri="{A12FA001-AC4F-418D-AE19-62706E023703}">
-                      <ahyp:hlinkClr xmlns:ahyp="http://schemas.microsoft.com/office/drawing/2018/hyperlinkcolor" val="tx"/>
-                    </a:ext>
-                  </a:extLst>
-                </a:hlinkClick>
               </a:rPr>
               <a:t>docs/collaboration_workflow_outline.md</a:t>
             </a:r>
@@ -20314,20 +20297,13 @@
               <a:buNone/>
             </a:pPr>
             <a:r>
-              <a:rPr lang="en-US" sz="900" u="sng" dirty="0">
-                <a:solidFill>
-                  <a:srgbClr val="3A5BA0"/>
+              <a:rPr lang="en-US" sz="900" dirty="0">
+                <a:solidFill>
+                  <a:srgbClr val="6B7280"/>
                 </a:solidFill>
                 <a:latin typeface="Consolas" pitchFamily="34" charset="0"/>
                 <a:ea typeface="Consolas" pitchFamily="34" charset="-122"/>
                 <a:cs typeface="Consolas" pitchFamily="34" charset="-120"/>
-                <a:hlinkClick r:id="rId2" invalidUrl="" action="" tgtFrame="" tooltip="" history="1" highlightClick="0" endSnd="0">
-                  <a:extLst>
-                    <a:ext uri="{A12FA001-AC4F-418D-AE19-62706E023703}">
-                      <ahyp:hlinkClr xmlns:ahyp="http://schemas.microsoft.com/office/drawing/2018/hyperlinkcolor" val="tx"/>
-                    </a:ext>
-                  </a:extLst>
-                </a:hlinkClick>
               </a:rPr>
               <a:t>docs/teaching_slides_outline.md</a:t>
             </a:r>
@@ -20349,20 +20325,13 @@
               <a:buNone/>
             </a:pPr>
             <a:r>
-              <a:rPr lang="en-US" sz="900" u="sng" dirty="0">
-                <a:solidFill>
-                  <a:srgbClr val="3A5BA0"/>
+              <a:rPr lang="en-US" sz="900" dirty="0">
+                <a:solidFill>
+                  <a:srgbClr val="6B7280"/>
                 </a:solidFill>
                 <a:latin typeface="Consolas" pitchFamily="34" charset="0"/>
                 <a:ea typeface="Consolas" pitchFamily="34" charset="-122"/>
                 <a:cs typeface="Consolas" pitchFamily="34" charset="-120"/>
-                <a:hlinkClick r:id="rId3" invalidUrl="" action="" tgtFrame="" tooltip="" history="1" highlightClick="0" endSnd="0">
-                  <a:extLst>
-                    <a:ext uri="{A12FA001-AC4F-418D-AE19-62706E023703}">
-                      <ahyp:hlinkClr xmlns:ahyp="http://schemas.microsoft.com/office/drawing/2018/hyperlinkcolor" val="tx"/>
-                    </a:ext>
-                  </a:extLst>
-                </a:hlinkClick>
               </a:rPr>
               <a:t>evolution_design_notes.md</a:t>
             </a:r>

</xml_diff>

<commit_message>
docs: remove all .md footnotes from the unified deck footers
The ‹code› footer is meant to point at code; references to docs/*.md and
CLAUDE.md (which can't deep-link to a precise location) are now removed
entirely — text and all, not just unlinked.

- 6 doc-only footers dropped (S2, S3, S19, S21, S26, S27)
- 5 mixed footers keep their code refs, .md segment stripped
  (S10, S20, S22, S23, S24)
- 21 of 27 slides keep a code footer; 52 live links, all .py/.yaml

Co-Authored-By: Claude Opus 4.8 <noreply@anthropic.com>
</commit_message>
<xml_diff>
--- a/docs/slides/人AI進化_整合教學投影片.pptx
+++ b/docs/slides/人AI進化_整合教學投影片.pptx
@@ -5679,35 +5679,7 @@
                 <a:ea typeface="Consolas" pitchFamily="34" charset="-122"/>
                 <a:cs typeface="Consolas" pitchFamily="34" charset="-120"/>
               </a:rPr>
-              <a:t>5 層分類學 </a:t>
-            </a:r>
-            <a:pPr indent="0" marL="0">
-              <a:buNone/>
-            </a:pPr>
-            <a:r>
-              <a:rPr lang="en-US" sz="900" dirty="0">
-                <a:solidFill>
-                  <a:srgbClr val="6B7280"/>
-                </a:solidFill>
-                <a:latin typeface="Consolas" pitchFamily="34" charset="0"/>
-                <a:ea typeface="Consolas" pitchFamily="34" charset="-122"/>
-                <a:cs typeface="Consolas" pitchFamily="34" charset="-120"/>
-              </a:rPr>
-              <a:t>docs/evolution_design_notes.md</a:t>
-            </a:r>
-            <a:pPr indent="0" marL="0">
-              <a:buNone/>
-            </a:pPr>
-            <a:r>
-              <a:rPr lang="en-US" sz="900" dirty="0">
-                <a:solidFill>
-                  <a:srgbClr val="6B7280"/>
-                </a:solidFill>
-                <a:latin typeface="Consolas" pitchFamily="34" charset="0"/>
-                <a:ea typeface="Consolas" pitchFamily="34" charset="-122"/>
-                <a:cs typeface="Consolas" pitchFamily="34" charset="-120"/>
-              </a:rPr>
-              <a:t> §3 ｜ 落地 src/tools/{interaction_tool_wrapper,retrieval_executor,tool_loader}.py</a:t>
+              <a:t>落地 src/tools/{interaction_tool_wrapper,retrieval_executor,tool_loader}.py</a:t>
             </a:r>
             <a:endParaRPr lang="en-US" sz="900" dirty="0"/>
           </a:p>
@@ -12199,115 +12171,6 @@
           </a:p>
         </p:txBody>
       </p:sp>
-      <p:sp>
-        <p:nvSpPr>
-          <p:cNvPr id="12" name="Text 10"/>
-          <p:cNvSpPr/>
-          <p:nvPr/>
-        </p:nvSpPr>
-        <p:spPr>
-          <a:xfrm>
-            <a:off x="502920" y="6583680"/>
-            <a:ext cx="11338560" cy="201168"/>
-          </a:xfrm>
-          <a:prstGeom prst="rect">
-            <a:avLst/>
-          </a:prstGeom>
-          <a:noFill/>
-          <a:ln/>
-        </p:spPr>
-        <p:txBody>
-          <a:bodyPr wrap="square" lIns="0" tIns="0" rIns="0" bIns="0" rtlCol="0" anchor="ctr"/>
-          <a:lstStyle/>
-          <a:p>
-            <a:pPr indent="0" marL="0">
-              <a:buNone/>
-            </a:pPr>
-            <a:r>
-              <a:rPr lang="en-US" sz="900" b="1" dirty="0">
-                <a:solidFill>
-                  <a:srgbClr val="E8A33D"/>
-                </a:solidFill>
-                <a:latin typeface="Consolas" pitchFamily="34" charset="0"/>
-                <a:ea typeface="Consolas" pitchFamily="34" charset="-122"/>
-                <a:cs typeface="Consolas" pitchFamily="34" charset="-120"/>
-              </a:rPr>
-              <a:t>‹code›  </a:t>
-            </a:r>
-            <a:pPr indent="0" marL="0">
-              <a:buNone/>
-            </a:pPr>
-            <a:r>
-              <a:rPr lang="en-US" sz="900" dirty="0">
-                <a:solidFill>
-                  <a:srgbClr val="6B7280"/>
-                </a:solidFill>
-                <a:latin typeface="Consolas" pitchFamily="34" charset="0"/>
-                <a:ea typeface="Consolas" pitchFamily="34" charset="-122"/>
-                <a:cs typeface="Consolas" pitchFamily="34" charset="-120"/>
-              </a:rPr>
-              <a:t>原則 </a:t>
-            </a:r>
-            <a:pPr indent="0" marL="0">
-              <a:buNone/>
-            </a:pPr>
-            <a:r>
-              <a:rPr lang="en-US" sz="900" dirty="0">
-                <a:solidFill>
-                  <a:srgbClr val="6B7280"/>
-                </a:solidFill>
-                <a:latin typeface="Consolas" pitchFamily="34" charset="0"/>
-                <a:ea typeface="Consolas" pitchFamily="34" charset="-122"/>
-                <a:cs typeface="Consolas" pitchFamily="34" charset="-120"/>
-              </a:rPr>
-              <a:t>CLAUDE.md</a:t>
-            </a:r>
-            <a:pPr indent="0" marL="0">
-              <a:buNone/>
-            </a:pPr>
-            <a:r>
-              <a:rPr lang="en-US" sz="900" dirty="0">
-                <a:solidFill>
-                  <a:srgbClr val="6B7280"/>
-                </a:solidFill>
-                <a:latin typeface="Consolas" pitchFamily="34" charset="0"/>
-                <a:ea typeface="Consolas" pitchFamily="34" charset="-122"/>
-                <a:cs typeface="Consolas" pitchFamily="34" charset="-120"/>
-              </a:rPr>
-              <a:t> Git 工作流程 ｜ 完整 50-iter 怎麼跑完 </a:t>
-            </a:r>
-            <a:pPr indent="0" marL="0">
-              <a:buNone/>
-            </a:pPr>
-            <a:r>
-              <a:rPr lang="en-US" sz="900" dirty="0">
-                <a:solidFill>
-                  <a:srgbClr val="6B7280"/>
-                </a:solidFill>
-                <a:latin typeface="Consolas" pitchFamily="34" charset="0"/>
-                <a:ea typeface="Consolas" pitchFamily="34" charset="-122"/>
-                <a:cs typeface="Consolas" pitchFamily="34" charset="-120"/>
-              </a:rPr>
-              <a:t>docs/evolution_design_notes.md</a:t>
-            </a:r>
-            <a:pPr indent="0" marL="0">
-              <a:buNone/>
-            </a:pPr>
-            <a:r>
-              <a:rPr lang="en-US" sz="900" dirty="0">
-                <a:solidFill>
-                  <a:srgbClr val="6B7280"/>
-                </a:solidFill>
-                <a:latin typeface="Consolas" pitchFamily="34" charset="0"/>
-                <a:ea typeface="Consolas" pitchFamily="34" charset="-122"/>
-                <a:cs typeface="Consolas" pitchFamily="34" charset="-120"/>
-              </a:rPr>
-              <a:t> §12.7(b)（nohup + caffeinate）</a:t>
-            </a:r>
-            <a:endParaRPr lang="en-US" sz="900" dirty="0"/>
-          </a:p>
-        </p:txBody>
-      </p:sp>
     </p:spTree>
   </p:cSld>
   <p:clrMapOvr>
@@ -12993,87 +12856,6 @@
           </a:p>
         </p:txBody>
       </p:sp>
-      <p:sp>
-        <p:nvSpPr>
-          <p:cNvPr id="21" name="Text 19"/>
-          <p:cNvSpPr/>
-          <p:nvPr/>
-        </p:nvSpPr>
-        <p:spPr>
-          <a:xfrm>
-            <a:off x="502920" y="6583680"/>
-            <a:ext cx="11338560" cy="201168"/>
-          </a:xfrm>
-          <a:prstGeom prst="rect">
-            <a:avLst/>
-          </a:prstGeom>
-          <a:noFill/>
-          <a:ln/>
-        </p:spPr>
-        <p:txBody>
-          <a:bodyPr wrap="square" lIns="0" tIns="0" rIns="0" bIns="0" rtlCol="0" anchor="ctr"/>
-          <a:lstStyle/>
-          <a:p>
-            <a:pPr indent="0" marL="0">
-              <a:buNone/>
-            </a:pPr>
-            <a:r>
-              <a:rPr lang="en-US" sz="900" b="1" dirty="0">
-                <a:solidFill>
-                  <a:srgbClr val="E8A33D"/>
-                </a:solidFill>
-                <a:latin typeface="Consolas" pitchFamily="34" charset="0"/>
-                <a:ea typeface="Consolas" pitchFamily="34" charset="-122"/>
-                <a:cs typeface="Consolas" pitchFamily="34" charset="-120"/>
-              </a:rPr>
-              <a:t>‹code›  </a:t>
-            </a:r>
-            <a:pPr indent="0" marL="0">
-              <a:buNone/>
-            </a:pPr>
-            <a:r>
-              <a:rPr lang="en-US" sz="900" dirty="0">
-                <a:solidFill>
-                  <a:srgbClr val="6B7280"/>
-                </a:solidFill>
-                <a:latin typeface="Consolas" pitchFamily="34" charset="0"/>
-                <a:ea typeface="Consolas" pitchFamily="34" charset="-122"/>
-                <a:cs typeface="Consolas" pitchFamily="34" charset="-120"/>
-              </a:rPr>
-              <a:t>完整數據 </a:t>
-            </a:r>
-            <a:pPr indent="0" marL="0">
-              <a:buNone/>
-            </a:pPr>
-            <a:r>
-              <a:rPr lang="en-US" sz="900" dirty="0">
-                <a:solidFill>
-                  <a:srgbClr val="6B7280"/>
-                </a:solidFill>
-                <a:latin typeface="Consolas" pitchFamily="34" charset="0"/>
-                <a:ea typeface="Consolas" pitchFamily="34" charset="-122"/>
-                <a:cs typeface="Consolas" pitchFamily="34" charset="-120"/>
-              </a:rPr>
-              <a:t>docs/evolution_design_notes.md</a:t>
-            </a:r>
-            <a:pPr indent="0" marL="0">
-              <a:buNone/>
-            </a:pPr>
-            <a:r>
-              <a:rPr lang="en-US" sz="900" dirty="0">
-                <a:solidFill>
-                  <a:srgbClr val="6B7280"/>
-                </a:solidFill>
-                <a:latin typeface="Consolas" pitchFamily="34" charset="0"/>
-                <a:ea typeface="Consolas" pitchFamily="34" charset="-122"/>
-                <a:cs typeface="Consolas" pitchFamily="34" charset="-120"/>
-              </a:rPr>
-              <a:t> §12.7（完整架構 50-iter 端到端）</a:t>
-            </a:r>
-            <a:endParaRPr lang="en-US" sz="900" dirty="0"/>
-          </a:p>
-        </p:txBody>
-      </p:sp>
     </p:spTree>
   </p:cSld>
   <p:clrMapOvr>
@@ -13694,7 +13476,7 @@
                 <a:ea typeface="Consolas" pitchFamily="34" charset="-122"/>
                 <a:cs typeface="Consolas" pitchFamily="34" charset="-120"/>
               </a:rPr>
-              <a:t>(L2) ｜ 數據 §12.7</a:t>
+              <a:t>(L2)</a:t>
             </a:r>
             <a:endParaRPr lang="en-US" sz="900" dirty="0"/>
           </a:p>
@@ -14714,87 +14496,6 @@
           </a:p>
         </p:txBody>
       </p:sp>
-      <p:sp>
-        <p:nvSpPr>
-          <p:cNvPr id="31" name="Text 29"/>
-          <p:cNvSpPr/>
-          <p:nvPr/>
-        </p:nvSpPr>
-        <p:spPr>
-          <a:xfrm>
-            <a:off x="502920" y="6583680"/>
-            <a:ext cx="11338560" cy="201168"/>
-          </a:xfrm>
-          <a:prstGeom prst="rect">
-            <a:avLst/>
-          </a:prstGeom>
-          <a:noFill/>
-          <a:ln/>
-        </p:spPr>
-        <p:txBody>
-          <a:bodyPr wrap="square" lIns="0" tIns="0" rIns="0" bIns="0" rtlCol="0" anchor="ctr"/>
-          <a:lstStyle/>
-          <a:p>
-            <a:pPr indent="0" marL="0">
-              <a:buNone/>
-            </a:pPr>
-            <a:r>
-              <a:rPr lang="en-US" sz="900" b="1" dirty="0">
-                <a:solidFill>
-                  <a:srgbClr val="E8A33D"/>
-                </a:solidFill>
-                <a:latin typeface="Consolas" pitchFamily="34" charset="0"/>
-                <a:ea typeface="Consolas" pitchFamily="34" charset="-122"/>
-                <a:cs typeface="Consolas" pitchFamily="34" charset="-120"/>
-              </a:rPr>
-              <a:t>‹code›  </a:t>
-            </a:r>
-            <a:pPr indent="0" marL="0">
-              <a:buNone/>
-            </a:pPr>
-            <a:r>
-              <a:rPr lang="en-US" sz="900" dirty="0">
-                <a:solidFill>
-                  <a:srgbClr val="6B7280"/>
-                </a:solidFill>
-                <a:latin typeface="Consolas" pitchFamily="34" charset="0"/>
-                <a:ea typeface="Consolas" pitchFamily="34" charset="-122"/>
-                <a:cs typeface="Consolas" pitchFamily="34" charset="-120"/>
-              </a:rPr>
-              <a:t>五模式完整版 </a:t>
-            </a:r>
-            <a:pPr indent="0" marL="0">
-              <a:buNone/>
-            </a:pPr>
-            <a:r>
-              <a:rPr lang="en-US" sz="900" dirty="0">
-                <a:solidFill>
-                  <a:srgbClr val="6B7280"/>
-                </a:solidFill>
-                <a:latin typeface="Consolas" pitchFamily="34" charset="0"/>
-                <a:ea typeface="Consolas" pitchFamily="34" charset="-122"/>
-                <a:cs typeface="Consolas" pitchFamily="34" charset="-120"/>
-              </a:rPr>
-              <a:t>docs/collaboration_workflow_outline.md</a:t>
-            </a:r>
-            <a:pPr indent="0" marL="0">
-              <a:buNone/>
-            </a:pPr>
-            <a:r>
-              <a:rPr lang="en-US" sz="900" dirty="0">
-                <a:solidFill>
-                  <a:srgbClr val="6B7280"/>
-                </a:solidFill>
-                <a:latin typeface="Consolas" pitchFamily="34" charset="0"/>
-                <a:ea typeface="Consolas" pitchFamily="34" charset="-122"/>
-                <a:cs typeface="Consolas" pitchFamily="34" charset="-120"/>
-              </a:rPr>
-              <a:t>（Part 3）</a:t>
-            </a:r>
-            <a:endParaRPr lang="en-US" sz="900" dirty="0"/>
-          </a:p>
-        </p:txBody>
-      </p:sp>
     </p:spTree>
   </p:cSld>
   <p:clrMapOvr>
@@ -15619,35 +15320,7 @@
                 <a:ea typeface="Consolas" pitchFamily="34" charset="-122"/>
                 <a:cs typeface="Consolas" pitchFamily="34" charset="-120"/>
               </a:rPr>
-              <a:t> EVOLVE-BLOCK · iter22 數據 </a:t>
-            </a:r>
-            <a:pPr indent="0" marL="0">
-              <a:buNone/>
-            </a:pPr>
-            <a:r>
-              <a:rPr lang="en-US" sz="900" dirty="0">
-                <a:solidFill>
-                  <a:srgbClr val="6B7280"/>
-                </a:solidFill>
-                <a:latin typeface="Consolas" pitchFamily="34" charset="0"/>
-                <a:ea typeface="Consolas" pitchFamily="34" charset="-122"/>
-                <a:cs typeface="Consolas" pitchFamily="34" charset="-120"/>
-              </a:rPr>
-              <a:t>docs/evolution_design_notes.md</a:t>
-            </a:r>
-            <a:pPr indent="0" marL="0">
-              <a:buNone/>
-            </a:pPr>
-            <a:r>
-              <a:rPr lang="en-US" sz="900" dirty="0">
-                <a:solidFill>
-                  <a:srgbClr val="6B7280"/>
-                </a:solidFill>
-                <a:latin typeface="Consolas" pitchFamily="34" charset="0"/>
-                <a:ea typeface="Consolas" pitchFamily="34" charset="-122"/>
-                <a:cs typeface="Consolas" pitchFamily="34" charset="-120"/>
-              </a:rPr>
-              <a:t> §12.7(b)</a:t>
+              <a:t> EVOLVE-BLOCK</a:t>
             </a:r>
             <a:endParaRPr lang="en-US" sz="900" dirty="0"/>
           </a:p>
@@ -16385,7 +16058,7 @@
                 <a:ea typeface="Consolas" pitchFamily="34" charset="-122"/>
                 <a:cs typeface="Consolas" pitchFamily="34" charset="-120"/>
               </a:rPr>
-              <a:t>（num_islands:3, migration）· 數據 design notes §12.7(b)</a:t>
+              <a:t>（num_islands:3, migration）</a:t>
             </a:r>
             <a:endParaRPr lang="en-US" sz="900" dirty="0"/>
           </a:p>
@@ -16856,35 +16529,7 @@
                 <a:ea typeface="Consolas" pitchFamily="34" charset="-122"/>
                 <a:cs typeface="Consolas" pitchFamily="34" charset="-120"/>
               </a:rPr>
-              <a:t>8/50 低分歸因 </a:t>
-            </a:r>
-            <a:pPr indent="0" marL="0">
-              <a:buNone/>
-            </a:pPr>
-            <a:r>
-              <a:rPr lang="en-US" sz="900" dirty="0">
-                <a:solidFill>
-                  <a:srgbClr val="6B7280"/>
-                </a:solidFill>
-                <a:latin typeface="Consolas" pitchFamily="34" charset="0"/>
-                <a:ea typeface="Consolas" pitchFamily="34" charset="-122"/>
-                <a:cs typeface="Consolas" pitchFamily="34" charset="-120"/>
-              </a:rPr>
-              <a:t>docs/evolution_design_notes.md</a:t>
-            </a:r>
-            <a:pPr indent="0" marL="0">
-              <a:buNone/>
-            </a:pPr>
-            <a:r>
-              <a:rPr lang="en-US" sz="900" dirty="0">
-                <a:solidFill>
-                  <a:srgbClr val="6B7280"/>
-                </a:solidFill>
-                <a:latin typeface="Consolas" pitchFamily="34" charset="0"/>
-                <a:ea typeface="Consolas" pitchFamily="34" charset="-122"/>
-                <a:cs typeface="Consolas" pitchFamily="34" charset="-120"/>
-              </a:rPr>
-              <a:t> §12.7(b) · diff_based_evolution:false 見 </a:t>
+              <a:t>diff_based_evolution:false（full-rewrite 風險）見 </a:t>
             </a:r>
             <a:pPr indent="0" marL="0">
               <a:buNone/>
@@ -18351,87 +17996,6 @@
           </a:p>
         </p:txBody>
       </p:sp>
-      <p:sp>
-        <p:nvSpPr>
-          <p:cNvPr id="22" name="Text 20"/>
-          <p:cNvSpPr/>
-          <p:nvPr/>
-        </p:nvSpPr>
-        <p:spPr>
-          <a:xfrm>
-            <a:off x="502920" y="6583680"/>
-            <a:ext cx="11338560" cy="201168"/>
-          </a:xfrm>
-          <a:prstGeom prst="rect">
-            <a:avLst/>
-          </a:prstGeom>
-          <a:noFill/>
-          <a:ln/>
-        </p:spPr>
-        <p:txBody>
-          <a:bodyPr wrap="square" lIns="0" tIns="0" rIns="0" bIns="0" rtlCol="0" anchor="ctr"/>
-          <a:lstStyle/>
-          <a:p>
-            <a:pPr indent="0" marL="0">
-              <a:buNone/>
-            </a:pPr>
-            <a:r>
-              <a:rPr lang="en-US" sz="900" b="1" dirty="0">
-                <a:solidFill>
-                  <a:srgbClr val="E8A33D"/>
-                </a:solidFill>
-                <a:latin typeface="Consolas" pitchFamily="34" charset="0"/>
-                <a:ea typeface="Consolas" pitchFamily="34" charset="-122"/>
-                <a:cs typeface="Consolas" pitchFamily="34" charset="-120"/>
-              </a:rPr>
-              <a:t>‹code›  </a:t>
-            </a:r>
-            <a:pPr indent="0" marL="0">
-              <a:buNone/>
-            </a:pPr>
-            <a:r>
-              <a:rPr lang="en-US" sz="900" dirty="0">
-                <a:solidFill>
-                  <a:srgbClr val="6B7280"/>
-                </a:solidFill>
-                <a:latin typeface="Consolas" pitchFamily="34" charset="0"/>
-                <a:ea typeface="Consolas" pitchFamily="34" charset="-122"/>
-                <a:cs typeface="Consolas" pitchFamily="34" charset="-120"/>
-              </a:rPr>
-              <a:t>原則出處 </a:t>
-            </a:r>
-            <a:pPr indent="0" marL="0">
-              <a:buNone/>
-            </a:pPr>
-            <a:r>
-              <a:rPr lang="en-US" sz="900" dirty="0">
-                <a:solidFill>
-                  <a:srgbClr val="6B7280"/>
-                </a:solidFill>
-                <a:latin typeface="Consolas" pitchFamily="34" charset="0"/>
-                <a:ea typeface="Consolas" pitchFamily="34" charset="-122"/>
-                <a:cs typeface="Consolas" pitchFamily="34" charset="-120"/>
-              </a:rPr>
-              <a:t>docs/evolution_design_notes.md</a:t>
-            </a:r>
-            <a:pPr indent="0" marL="0">
-              <a:buNone/>
-            </a:pPr>
-            <a:r>
-              <a:rPr lang="en-US" sz="900" dirty="0">
-                <a:solidFill>
-                  <a:srgbClr val="6B7280"/>
-                </a:solidFill>
-                <a:latin typeface="Consolas" pitchFamily="34" charset="0"/>
-                <a:ea typeface="Consolas" pitchFamily="34" charset="-122"/>
-                <a:cs typeface="Consolas" pitchFamily="34" charset="-120"/>
-              </a:rPr>
-              <a:t> §3 分類學 · §4 協議/策略分離 · §12.7 數據</a:t>
-            </a:r>
-            <a:endParaRPr lang="en-US" sz="900" dirty="0"/>
-          </a:p>
-        </p:txBody>
-      </p:sp>
     </p:spTree>
   </p:cSld>
   <p:clrMapOvr>
@@ -18899,87 +18463,6 @@
           </a:p>
         </p:txBody>
       </p:sp>
-      <p:sp>
-        <p:nvSpPr>
-          <p:cNvPr id="14" name="Text 12"/>
-          <p:cNvSpPr/>
-          <p:nvPr/>
-        </p:nvSpPr>
-        <p:spPr>
-          <a:xfrm>
-            <a:off x="502920" y="6583680"/>
-            <a:ext cx="11338560" cy="201168"/>
-          </a:xfrm>
-          <a:prstGeom prst="rect">
-            <a:avLst/>
-          </a:prstGeom>
-          <a:noFill/>
-          <a:ln/>
-        </p:spPr>
-        <p:txBody>
-          <a:bodyPr wrap="square" lIns="0" tIns="0" rIns="0" bIns="0" rtlCol="0" anchor="ctr"/>
-          <a:lstStyle/>
-          <a:p>
-            <a:pPr indent="0" marL="0">
-              <a:buNone/>
-            </a:pPr>
-            <a:r>
-              <a:rPr lang="en-US" sz="900" b="1" dirty="0">
-                <a:solidFill>
-                  <a:srgbClr val="E8A33D"/>
-                </a:solidFill>
-                <a:latin typeface="Consolas" pitchFamily="34" charset="0"/>
-                <a:ea typeface="Consolas" pitchFamily="34" charset="-122"/>
-                <a:cs typeface="Consolas" pitchFamily="34" charset="-120"/>
-              </a:rPr>
-              <a:t>‹code›  </a:t>
-            </a:r>
-            <a:pPr indent="0" marL="0">
-              <a:buNone/>
-            </a:pPr>
-            <a:r>
-              <a:rPr lang="en-US" sz="900" dirty="0">
-                <a:solidFill>
-                  <a:srgbClr val="8FA3C8"/>
-                </a:solidFill>
-                <a:latin typeface="Consolas" pitchFamily="34" charset="0"/>
-                <a:ea typeface="Consolas" pitchFamily="34" charset="-122"/>
-                <a:cs typeface="Consolas" pitchFamily="34" charset="-120"/>
-              </a:rPr>
-              <a:t>技術深入 </a:t>
-            </a:r>
-            <a:pPr indent="0" marL="0">
-              <a:buNone/>
-            </a:pPr>
-            <a:r>
-              <a:rPr lang="en-US" sz="900" dirty="0">
-                <a:solidFill>
-                  <a:srgbClr val="8FA3C8"/>
-                </a:solidFill>
-                <a:latin typeface="Consolas" pitchFamily="34" charset="0"/>
-                <a:ea typeface="Consolas" pitchFamily="34" charset="-122"/>
-                <a:cs typeface="Consolas" pitchFamily="34" charset="-120"/>
-              </a:rPr>
-              <a:t>docs/evolution_design_notes.md</a:t>
-            </a:r>
-            <a:pPr indent="0" marL="0">
-              <a:buNone/>
-            </a:pPr>
-            <a:r>
-              <a:rPr lang="en-US" sz="900" dirty="0">
-                <a:solidFill>
-                  <a:srgbClr val="8FA3C8"/>
-                </a:solidFill>
-                <a:latin typeface="Consolas" pitchFamily="34" charset="0"/>
-                <a:ea typeface="Consolas" pitchFamily="34" charset="-122"/>
-                <a:cs typeface="Consolas" pitchFamily="34" charset="-120"/>
-              </a:rPr>
-              <a:t> ｜ 三份大綱皆在 docs/</a:t>
-            </a:r>
-            <a:endParaRPr lang="en-US" sz="900" dirty="0"/>
-          </a:p>
-        </p:txBody>
-      </p:sp>
     </p:spTree>
   </p:cSld>
   <p:clrMapOvr>
@@ -20213,129 +19696,6 @@
               <a:t>主線：協作故事是外層，技術分類學是嵌入其中的實戰案例。</a:t>
             </a:r>
             <a:endParaRPr lang="en-US" sz="1300" dirty="0"/>
-          </a:p>
-        </p:txBody>
-      </p:sp>
-      <p:sp>
-        <p:nvSpPr>
-          <p:cNvPr id="37" name="Text 35"/>
-          <p:cNvSpPr/>
-          <p:nvPr/>
-        </p:nvSpPr>
-        <p:spPr>
-          <a:xfrm>
-            <a:off x="502920" y="6583680"/>
-            <a:ext cx="11338560" cy="201168"/>
-          </a:xfrm>
-          <a:prstGeom prst="rect">
-            <a:avLst/>
-          </a:prstGeom>
-          <a:noFill/>
-          <a:ln/>
-        </p:spPr>
-        <p:txBody>
-          <a:bodyPr wrap="square" lIns="0" tIns="0" rIns="0" bIns="0" rtlCol="0" anchor="ctr"/>
-          <a:lstStyle/>
-          <a:p>
-            <a:pPr indent="0" marL="0">
-              <a:buNone/>
-            </a:pPr>
-            <a:r>
-              <a:rPr lang="en-US" sz="900" b="1" dirty="0">
-                <a:solidFill>
-                  <a:srgbClr val="E8A33D"/>
-                </a:solidFill>
-                <a:latin typeface="Consolas" pitchFamily="34" charset="0"/>
-                <a:ea typeface="Consolas" pitchFamily="34" charset="-122"/>
-                <a:cs typeface="Consolas" pitchFamily="34" charset="-120"/>
-              </a:rPr>
-              <a:t>‹code›  </a:t>
-            </a:r>
-            <a:pPr indent="0" marL="0">
-              <a:buNone/>
-            </a:pPr>
-            <a:r>
-              <a:rPr lang="en-US" sz="900" dirty="0">
-                <a:solidFill>
-                  <a:srgbClr val="6B7280"/>
-                </a:solidFill>
-                <a:latin typeface="Consolas" pitchFamily="34" charset="0"/>
-                <a:ea typeface="Consolas" pitchFamily="34" charset="-122"/>
-                <a:cs typeface="Consolas" pitchFamily="34" charset="-120"/>
-              </a:rPr>
-              <a:t>外層 </a:t>
-            </a:r>
-            <a:pPr indent="0" marL="0">
-              <a:buNone/>
-            </a:pPr>
-            <a:r>
-              <a:rPr lang="en-US" sz="900" dirty="0">
-                <a:solidFill>
-                  <a:srgbClr val="6B7280"/>
-                </a:solidFill>
-                <a:latin typeface="Consolas" pitchFamily="34" charset="0"/>
-                <a:ea typeface="Consolas" pitchFamily="34" charset="-122"/>
-                <a:cs typeface="Consolas" pitchFamily="34" charset="-120"/>
-              </a:rPr>
-              <a:t>docs/collaboration_workflow_outline.md</a:t>
-            </a:r>
-            <a:pPr indent="0" marL="0">
-              <a:buNone/>
-            </a:pPr>
-            <a:r>
-              <a:rPr lang="en-US" sz="900" dirty="0">
-                <a:solidFill>
-                  <a:srgbClr val="6B7280"/>
-                </a:solidFill>
-                <a:latin typeface="Consolas" pitchFamily="34" charset="0"/>
-                <a:ea typeface="Consolas" pitchFamily="34" charset="-122"/>
-                <a:cs typeface="Consolas" pitchFamily="34" charset="-120"/>
-              </a:rPr>
-              <a:t> ｜ 內層 </a:t>
-            </a:r>
-            <a:pPr indent="0" marL="0">
-              <a:buNone/>
-            </a:pPr>
-            <a:r>
-              <a:rPr lang="en-US" sz="900" dirty="0">
-                <a:solidFill>
-                  <a:srgbClr val="6B7280"/>
-                </a:solidFill>
-                <a:latin typeface="Consolas" pitchFamily="34" charset="0"/>
-                <a:ea typeface="Consolas" pitchFamily="34" charset="-122"/>
-                <a:cs typeface="Consolas" pitchFamily="34" charset="-120"/>
-              </a:rPr>
-              <a:t>docs/teaching_slides_outline.md</a:t>
-            </a:r>
-            <a:pPr indent="0" marL="0">
-              <a:buNone/>
-            </a:pPr>
-            <a:r>
-              <a:rPr lang="en-US" sz="900" dirty="0">
-                <a:solidFill>
-                  <a:srgbClr val="6B7280"/>
-                </a:solidFill>
-                <a:latin typeface="Consolas" pitchFamily="34" charset="0"/>
-                <a:ea typeface="Consolas" pitchFamily="34" charset="-122"/>
-                <a:cs typeface="Consolas" pitchFamily="34" charset="-120"/>
-              </a:rPr>
-              <a:t> ｜ 數據 </a:t>
-            </a:r>
-            <a:pPr indent="0" marL="0">
-              <a:buNone/>
-            </a:pPr>
-            <a:r>
-              <a:rPr lang="en-US" sz="900" dirty="0">
-                <a:solidFill>
-                  <a:srgbClr val="6B7280"/>
-                </a:solidFill>
-                <a:latin typeface="Consolas" pitchFamily="34" charset="0"/>
-                <a:ea typeface="Consolas" pitchFamily="34" charset="-122"/>
-                <a:cs typeface="Consolas" pitchFamily="34" charset="-120"/>
-              </a:rPr>
-              <a:t>evolution_design_notes.md</a:t>
-            </a:r>
-            <a:endParaRPr lang="en-US" sz="900" dirty="0"/>
           </a:p>
         </p:txBody>
       </p:sp>

</xml_diff>

<commit_message>
docs: add S23b "how to break out of the local optimum" (unified deck)
New slide after the iter22 post-mortem listing the three improvement
levers we discussed, each tied to a cause:
- 加大 TASKS (weak fitness signal)
- 島嶼種子多樣化 + 抑制 migration (three-island convergence)
- 啟動工具進化 + n_tools 維度 (search space exhausted)
plus a "ready-made safety net" band (holdout + MAP-Elites diversity).
Deck is now 28 slides. Footer links to the 3 relevant code locations.

Co-Authored-By: Claude Opus 4.8 <noreply@anthropic.com>
</commit_message>
<xml_diff>
--- a/docs/slides/人AI進化_整合教學投影片.pptx
+++ b/docs/slides/人AI進化_整合教學投影片.pptx
@@ -32,9 +32,10 @@
     <p:sldId id="280" r:id="rId26"/>
     <p:sldId id="281" r:id="rId27"/>
     <p:sldId id="282" r:id="rId28"/>
+    <p:sldId id="283" r:id="rId29"/>
   </p:sldIdLst>
   <p:notesMasterIdLst>
-    <p:notesMasterId r:id="rId29"/>
+    <p:notesMasterId r:id="rId30"/>
   </p:notesMasterIdLst>
   <p:sldSz cx="12192000" cy="6858000"/>
   <p:notesSz cx="6858000" cy="12192000"/>
@@ -2864,6 +2865,94 @@
             <a:fld id="{F7021451-1387-4CA6-816F-3879F97B5CBC}" type="slidenum">
               <a:rPr lang="en-US"/>
               <a:t>27</a:t>
+            </a:fld>
+            <a:endParaRPr lang="en-US"/>
+          </a:p>
+        </p:txBody>
+      </p:sp>
+    </p:spTree>
+    <p:extLst>
+      <p:ext uri="{BB962C8B-B14F-4D97-AF65-F5344CB8AC3E}">
+        <p14:creationId xmlns:p14="http://schemas.microsoft.com/office/powerpoint/2010/main" val="1024086991"/>
+      </p:ext>
+    </p:extLst>
+  </p:cSld>
+  <p:clrMapOvr>
+    <a:masterClrMapping/>
+  </p:clrMapOvr>
+</p:notes>
+</file>
+
+<file path=ppt/notesSlides/notesSlide28.xml><?xml version="1.0" encoding="utf-8"?>
+<p:notes xmlns:a="http://schemas.openxmlformats.org/drawingml/2006/main" xmlns:r="http://schemas.openxmlformats.org/officeDocument/2006/relationships" xmlns:p="http://schemas.openxmlformats.org/presentationml/2006/main">
+  <p:cSld>
+    <p:spTree>
+      <p:nvGrpSpPr>
+        <p:cNvPr id="1" name=""/>
+        <p:cNvGrpSpPr/>
+        <p:nvPr/>
+      </p:nvGrpSpPr>
+      <p:grpSpPr>
+        <a:xfrm>
+          <a:off x="0" y="0"/>
+          <a:ext cx="0" cy="0"/>
+          <a:chOff x="0" y="0"/>
+          <a:chExt cx="0" cy="0"/>
+        </a:xfrm>
+      </p:grpSpPr>
+      <p:sp>
+        <p:nvSpPr>
+          <p:cNvPr id="2" name="Slide Image Placeholder 1"/>
+          <p:cNvSpPr>
+            <a:spLocks noGrp="1" noRot="1" noChangeAspect="1"/>
+          </p:cNvSpPr>
+          <p:nvPr>
+            <p:ph type="sldImg"/>
+          </p:nvPr>
+        </p:nvSpPr>
+        <p:spPr/>
+      </p:sp>
+      <p:sp>
+        <p:nvSpPr>
+          <p:cNvPr id="3" name="Notes Placeholder 2"/>
+          <p:cNvSpPr>
+            <a:spLocks noGrp="1"/>
+          </p:cNvSpPr>
+          <p:nvPr>
+            <p:ph type="body" idx="1"/>
+          </p:nvPr>
+        </p:nvSpPr>
+        <p:spPr/>
+        <p:txBody>
+          <a:bodyPr/>
+          <a:lstStyle/>
+          <a:p>
+            <a:r>
+              <a:rPr lang="en-US" dirty="0"/>
+              <a:t/>
+            </a:r>
+            <a:endParaRPr lang="en-US" dirty="0"/>
+          </a:p>
+        </p:txBody>
+      </p:sp>
+      <p:sp>
+        <p:nvSpPr>
+          <p:cNvPr id="4" name="Slide Number Placeholder 3"/>
+          <p:cNvSpPr>
+            <a:spLocks noGrp="1"/>
+          </p:cNvSpPr>
+          <p:nvPr>
+            <p:ph type="sldNum" sz="quarter" idx="10"/>
+          </p:nvPr>
+        </p:nvSpPr>
+        <p:spPr/>
+        <p:txBody>
+          <a:bodyPr/>
+          <a:lstStyle/>
+          <a:p>
+            <a:fld id="{F7021451-1387-4CA6-816F-3879F97B5CBC}" type="slidenum">
+              <a:rPr lang="en-US"/>
+              <a:t>28</a:t>
             </a:fld>
             <a:endParaRPr lang="en-US"/>
           </a:p>
@@ -16188,7 +16277,7 @@
                 <a:ea typeface="Georgia" pitchFamily="34" charset="-122"/>
                 <a:cs typeface="Georgia" pitchFamily="34" charset="-120"/>
               </a:rPr>
-              <a:t>連「失敗」也是協作的洞察</a:t>
+              <a:t>那要怎麼跳出局部最優？</a:t>
             </a:r>
             <a:endParaRPr lang="en-US" sz="2800" dirty="0"/>
           </a:p>
@@ -16202,34 +16291,34 @@
         </p:nvSpPr>
         <p:spPr>
           <a:xfrm>
-            <a:off x="548640" y="1920240"/>
-            <a:ext cx="10972800" cy="457200"/>
-          </a:xfrm>
-          <a:prstGeom prst="rect">
-            <a:avLst/>
-          </a:prstGeom>
-          <a:noFill/>
-          <a:ln/>
-        </p:spPr>
-        <p:txBody>
-          <a:bodyPr wrap="square" lIns="0" tIns="0" rIns="0" bIns="0" rtlCol="0" anchor="ctr"/>
-          <a:lstStyle/>
-          <a:p>
-            <a:pPr indent="0" marL="0">
-              <a:buNone/>
-            </a:pPr>
-            <a:r>
-              <a:rPr lang="en-US" sz="1800" dirty="0">
-                <a:solidFill>
-                  <a:srgbClr val="23272E"/>
+            <a:off x="548640" y="1481328"/>
+            <a:ext cx="11109960" cy="365760"/>
+          </a:xfrm>
+          <a:prstGeom prst="rect">
+            <a:avLst/>
+          </a:prstGeom>
+          <a:noFill/>
+          <a:ln/>
+        </p:spPr>
+        <p:txBody>
+          <a:bodyPr wrap="square" lIns="0" tIns="0" rIns="0" bIns="0" rtlCol="0" anchor="ctr"/>
+          <a:lstStyle/>
+          <a:p>
+            <a:pPr indent="0" marL="0">
+              <a:buNone/>
+            </a:pPr>
+            <a:r>
+              <a:rPr lang="en-US" sz="1350" dirty="0">
+                <a:solidFill>
+                  <a:srgbClr val="3A5BA0"/>
                 </a:solidFill>
                 <a:latin typeface="Calibri" pitchFamily="34" charset="0"/>
                 <a:ea typeface="Calibri" pitchFamily="34" charset="-122"/>
                 <a:cs typeface="Calibri" pitchFamily="34" charset="-120"/>
               </a:rPr>
-              <a:t>8 次低分崩潰 → 我請 Claude 爬梳資料歸因：</a:t>
-            </a:r>
-            <a:endParaRPr lang="en-US" sz="1800" dirty="0"/>
+              <a:t>跳出不是「再多跑幾代」（那只會把公式越加越複雜）——而是同時動三個旋鈕：</a:t>
+            </a:r>
+            <a:endParaRPr lang="en-US" sz="1350" dirty="0"/>
           </a:p>
         </p:txBody>
       </p:sp>
@@ -16241,14 +16330,14 @@
         </p:nvSpPr>
         <p:spPr>
           <a:xfrm>
-            <a:off x="548640" y="2743200"/>
-            <a:ext cx="5440680" cy="2194560"/>
+            <a:off x="548640" y="1965960"/>
+            <a:ext cx="3520440" cy="2834640"/>
           </a:xfrm>
           <a:prstGeom prst="rect">
             <a:avLst/>
           </a:prstGeom>
           <a:solidFill>
-            <a:srgbClr val="F7E9E7"/>
+            <a:srgbClr val="FFFFFF"/>
           </a:solidFill>
           <a:ln w="12700">
             <a:solidFill>
@@ -16267,93 +16356,258 @@
       </p:sp>
       <p:sp>
         <p:nvSpPr>
-          <p:cNvPr id="7" name="Text 5"/>
-          <p:cNvSpPr/>
-          <p:nvPr/>
-        </p:nvSpPr>
-        <p:spPr>
-          <a:xfrm>
-            <a:off x="822960" y="3017520"/>
-            <a:ext cx="4937760" cy="1737360"/>
-          </a:xfrm>
-          <a:prstGeom prst="rect">
-            <a:avLst/>
-          </a:prstGeom>
-          <a:noFill/>
-          <a:ln/>
-        </p:spPr>
-        <p:txBody>
-          <a:bodyPr wrap="square" lIns="0" tIns="0" rIns="0" bIns="0" rtlCol="0" anchor="ctr"/>
-          <a:lstStyle/>
-          <a:p>
-            <a:pPr indent="0" marL="0">
-              <a:lnSpc>
-                <a:spcPts val="3000"/>
-              </a:lnSpc>
-              <a:buNone/>
-            </a:pPr>
-            <a:r>
-              <a:rPr lang="en-US" sz="4400" b="1" dirty="0">
-                <a:solidFill>
-                  <a:srgbClr val="C0453B"/>
+          <p:cNvPr id="7" name="Shape 5"/>
+          <p:cNvSpPr/>
+          <p:nvPr/>
+        </p:nvSpPr>
+        <p:spPr>
+          <a:xfrm>
+            <a:off x="548640" y="1965960"/>
+            <a:ext cx="3520440" cy="109728"/>
+          </a:xfrm>
+          <a:prstGeom prst="rect">
+            <a:avLst/>
+          </a:prstGeom>
+          <a:solidFill>
+            <a:srgbClr val="1E2761"/>
+          </a:solidFill>
+          <a:ln/>
+        </p:spPr>
+      </p:sp>
+      <p:sp>
+        <p:nvSpPr>
+          <p:cNvPr id="8" name="Shape 6"/>
+          <p:cNvSpPr/>
+          <p:nvPr/>
+        </p:nvSpPr>
+        <p:spPr>
+          <a:xfrm>
+            <a:off x="749808" y="2194560"/>
+            <a:ext cx="457200" cy="457200"/>
+          </a:xfrm>
+          <a:prstGeom prst="ellipse">
+            <a:avLst/>
+          </a:prstGeom>
+          <a:solidFill>
+            <a:srgbClr val="E8A33D"/>
+          </a:solidFill>
+          <a:ln/>
+        </p:spPr>
+      </p:sp>
+      <p:sp>
+        <p:nvSpPr>
+          <p:cNvPr id="9" name="Text 7"/>
+          <p:cNvSpPr/>
+          <p:nvPr/>
+        </p:nvSpPr>
+        <p:spPr>
+          <a:xfrm>
+            <a:off x="749808" y="2194560"/>
+            <a:ext cx="457200" cy="457200"/>
+          </a:xfrm>
+          <a:prstGeom prst="rect">
+            <a:avLst/>
+          </a:prstGeom>
+          <a:noFill/>
+          <a:ln/>
+        </p:spPr>
+        <p:txBody>
+          <a:bodyPr wrap="square" lIns="0" tIns="0" rIns="0" bIns="0" rtlCol="0" anchor="ctr"/>
+          <a:lstStyle/>
+          <a:p>
+            <a:pPr algn="ctr" indent="0" marL="0">
+              <a:buNone/>
+            </a:pPr>
+            <a:r>
+              <a:rPr lang="en-US" sz="1800" b="1" dirty="0">
+                <a:solidFill>
+                  <a:srgbClr val="1E2761"/>
                 </a:solidFill>
                 <a:latin typeface="Georgia" pitchFamily="34" charset="0"/>
                 <a:ea typeface="Georgia" pitchFamily="34" charset="-122"/>
                 <a:cs typeface="Georgia" pitchFamily="34" charset="-120"/>
               </a:rPr>
-              <a:t>5 次</a:t>
-            </a:r>
-            <a:endParaRPr lang="en-US" sz="4400" dirty="0"/>
-          </a:p>
+              <a:t>①</a:t>
+            </a:r>
+            <a:endParaRPr lang="en-US" sz="1800" dirty="0"/>
+          </a:p>
+        </p:txBody>
+      </p:sp>
+      <p:sp>
+        <p:nvSpPr>
+          <p:cNvPr id="10" name="Text 8"/>
+          <p:cNvSpPr/>
+          <p:nvPr/>
+        </p:nvSpPr>
+        <p:spPr>
+          <a:xfrm>
+            <a:off x="1325880" y="2212848"/>
+            <a:ext cx="2606040" cy="457200"/>
+          </a:xfrm>
+          <a:prstGeom prst="rect">
+            <a:avLst/>
+          </a:prstGeom>
+          <a:noFill/>
+          <a:ln/>
+        </p:spPr>
+        <p:txBody>
+          <a:bodyPr wrap="square" lIns="0" tIns="0" rIns="0" bIns="0" rtlCol="0" anchor="ctr"/>
+          <a:lstStyle/>
+          <a:p>
+            <a:pPr indent="0" marL="0">
+              <a:buNone/>
+            </a:pPr>
+            <a:r>
+              <a:rPr lang="en-US" sz="1600" b="1" dirty="0">
+                <a:solidFill>
+                  <a:srgbClr val="1E2761"/>
+                </a:solidFill>
+                <a:latin typeface="Georgia" pitchFamily="34" charset="0"/>
+                <a:ea typeface="Georgia" pitchFamily="34" charset="-122"/>
+                <a:cs typeface="Georgia" pitchFamily="34" charset="-120"/>
+              </a:rPr>
+              <a:t>加大 TASKS</a:t>
+            </a:r>
+            <a:endParaRPr lang="en-US" sz="1600" dirty="0"/>
+          </a:p>
+        </p:txBody>
+      </p:sp>
+      <p:sp>
+        <p:nvSpPr>
+          <p:cNvPr id="11" name="Text 9"/>
+          <p:cNvSpPr/>
+          <p:nvPr/>
+        </p:nvSpPr>
+        <p:spPr>
+          <a:xfrm>
+            <a:off x="777240" y="2788920"/>
+            <a:ext cx="3108960" cy="365760"/>
+          </a:xfrm>
+          <a:prstGeom prst="rect">
+            <a:avLst/>
+          </a:prstGeom>
+          <a:noFill/>
+          <a:ln/>
+        </p:spPr>
+        <p:txBody>
+          <a:bodyPr wrap="square" lIns="0" tIns="0" rIns="0" bIns="0" rtlCol="0" anchor="ctr"/>
+          <a:lstStyle/>
+          <a:p>
+            <a:pPr indent="0" marL="0">
+              <a:buNone/>
+            </a:pPr>
+            <a:r>
+              <a:rPr lang="en-US" sz="1250" i="1" dirty="0">
+                <a:solidFill>
+                  <a:srgbClr val="C0453B"/>
+                </a:solidFill>
+                <a:latin typeface="Calibri" pitchFamily="34" charset="0"/>
+                <a:ea typeface="Calibri" pitchFamily="34" charset="-122"/>
+                <a:cs typeface="Calibri" pitchFamily="34" charset="-120"/>
+              </a:rPr>
+              <a:t>對治：fitness 訊號太弱</a:t>
+            </a:r>
+            <a:endParaRPr lang="en-US" sz="1250" dirty="0"/>
+          </a:p>
+        </p:txBody>
+      </p:sp>
+      <p:sp>
+        <p:nvSpPr>
+          <p:cNvPr id="12" name="Text 10"/>
+          <p:cNvSpPr/>
+          <p:nvPr/>
+        </p:nvSpPr>
+        <p:spPr>
+          <a:xfrm>
+            <a:off x="777240" y="3246120"/>
+            <a:ext cx="3108960" cy="1371600"/>
+          </a:xfrm>
+          <a:prstGeom prst="rect">
+            <a:avLst/>
+          </a:prstGeom>
+          <a:noFill/>
+          <a:ln/>
+        </p:spPr>
+        <p:txBody>
+          <a:bodyPr wrap="square" lIns="0" tIns="0" rIns="0" bIns="0" rtlCol="0" anchor="ctr"/>
+          <a:lstStyle/>
           <a:p>
             <a:pPr indent="0" marL="0">
               <a:lnSpc>
-                <a:spcPts val="3000"/>
+                <a:spcPts val="2000"/>
               </a:lnSpc>
               <a:buNone/>
             </a:pPr>
             <a:r>
-              <a:rPr lang="en-US" sz="4400" dirty="0">
+              <a:rPr lang="en-US" sz="1350" dirty="0">
                 <a:solidFill>
                   <a:srgbClr val="23272E"/>
                 </a:solidFill>
-              </a:rPr>
-              <a:t>YAML 語法壞掉</a:t>
-            </a:r>
-            <a:pPr indent="0" marL="0">
-              <a:lnSpc>
-                <a:spcPts val="3000"/>
-              </a:lnSpc>
-              <a:buNone/>
-            </a:pPr>
-            <a:r>
-              <a:rPr lang="en-US" sz="1200" dirty="0">
+                <a:latin typeface="Calibri" pitchFamily="34" charset="0"/>
+                <a:ea typeface="Calibri" pitchFamily="34" charset="-122"/>
+                <a:cs typeface="Calibri" pitchFamily="34" charset="-120"/>
+              </a:rPr>
+              <a:t>每次 evaluate 用更多 task、擴大 train 樣本（資料源有 198 筆，目前只用 5）</a:t>
+            </a:r>
+            <a:endParaRPr lang="en-US" sz="1350" dirty="0"/>
+          </a:p>
+        </p:txBody>
+      </p:sp>
+      <p:sp>
+        <p:nvSpPr>
+          <p:cNvPr id="13" name="Text 11"/>
+          <p:cNvSpPr/>
+          <p:nvPr/>
+        </p:nvSpPr>
+        <p:spPr>
+          <a:xfrm>
+            <a:off x="777240" y="4434840"/>
+            <a:ext cx="3108960" cy="274320"/>
+          </a:xfrm>
+          <a:prstGeom prst="rect">
+            <a:avLst/>
+          </a:prstGeom>
+          <a:noFill/>
+          <a:ln/>
+        </p:spPr>
+        <p:txBody>
+          <a:bodyPr wrap="square" lIns="0" tIns="0" rIns="0" bIns="0" rtlCol="0" anchor="ctr"/>
+          <a:lstStyle/>
+          <a:p>
+            <a:pPr indent="0" marL="0">
+              <a:buNone/>
+            </a:pPr>
+            <a:r>
+              <a:rPr lang="en-US" sz="1100" dirty="0">
                 <a:solidFill>
                   <a:srgbClr val="6B7280"/>
                 </a:solidFill>
-              </a:rPr>
-              <a:t>（full-rewrite 風險，繞過 clamp）</a:t>
-            </a:r>
-            <a:endParaRPr lang="en-US" sz="4400" dirty="0"/>
-          </a:p>
-        </p:txBody>
-      </p:sp>
-      <p:sp>
-        <p:nvSpPr>
-          <p:cNvPr id="8" name="Shape 6"/>
-          <p:cNvSpPr/>
-          <p:nvPr/>
-        </p:nvSpPr>
-        <p:spPr>
-          <a:xfrm>
-            <a:off x="6217920" y="2743200"/>
-            <a:ext cx="5440680" cy="2194560"/>
+                <a:latin typeface="Consolas" pitchFamily="34" charset="0"/>
+                <a:ea typeface="Consolas" pitchFamily="34" charset="-122"/>
+                <a:cs typeface="Consolas" pitchFamily="34" charset="-120"/>
+              </a:rPr>
+              <a:t>狀態：待辦</a:t>
+            </a:r>
+            <a:endParaRPr lang="en-US" sz="1100" dirty="0"/>
+          </a:p>
+        </p:txBody>
+      </p:sp>
+      <p:sp>
+        <p:nvSpPr>
+          <p:cNvPr id="14" name="Shape 12"/>
+          <p:cNvSpPr/>
+          <p:nvPr/>
+        </p:nvSpPr>
+        <p:spPr>
+          <a:xfrm>
+            <a:off x="4370832" y="1965960"/>
+            <a:ext cx="3520440" cy="2834640"/>
           </a:xfrm>
           <a:prstGeom prst="rect">
             <a:avLst/>
           </a:prstGeom>
           <a:solidFill>
-            <a:srgbClr val="FBF1E0"/>
+            <a:srgbClr val="FFFFFF"/>
           </a:solidFill>
           <a:ln w="12700">
             <a:solidFill>
@@ -16372,103 +16626,109 @@
       </p:sp>
       <p:sp>
         <p:nvSpPr>
-          <p:cNvPr id="9" name="Text 7"/>
-          <p:cNvSpPr/>
-          <p:nvPr/>
-        </p:nvSpPr>
-        <p:spPr>
-          <a:xfrm>
-            <a:off x="6492240" y="3017520"/>
-            <a:ext cx="4937760" cy="1737360"/>
-          </a:xfrm>
-          <a:prstGeom prst="rect">
-            <a:avLst/>
-          </a:prstGeom>
-          <a:noFill/>
-          <a:ln/>
-        </p:spPr>
-        <p:txBody>
-          <a:bodyPr wrap="square" lIns="0" tIns="0" rIns="0" bIns="0" rtlCol="0" anchor="ctr"/>
-          <a:lstStyle/>
-          <a:p>
-            <a:pPr indent="0" marL="0">
-              <a:lnSpc>
-                <a:spcPts val="3000"/>
-              </a:lnSpc>
-              <a:buNone/>
-            </a:pPr>
-            <a:r>
-              <a:rPr lang="en-US" sz="4400" b="1" dirty="0">
-                <a:solidFill>
-                  <a:srgbClr val="B5791F"/>
+          <p:cNvPr id="15" name="Shape 13"/>
+          <p:cNvSpPr/>
+          <p:nvPr/>
+        </p:nvSpPr>
+        <p:spPr>
+          <a:xfrm>
+            <a:off x="4370832" y="1965960"/>
+            <a:ext cx="3520440" cy="109728"/>
+          </a:xfrm>
+          <a:prstGeom prst="rect">
+            <a:avLst/>
+          </a:prstGeom>
+          <a:solidFill>
+            <a:srgbClr val="1E2761"/>
+          </a:solidFill>
+          <a:ln/>
+        </p:spPr>
+      </p:sp>
+      <p:sp>
+        <p:nvSpPr>
+          <p:cNvPr id="16" name="Shape 14"/>
+          <p:cNvSpPr/>
+          <p:nvPr/>
+        </p:nvSpPr>
+        <p:spPr>
+          <a:xfrm>
+            <a:off x="4572000" y="2194560"/>
+            <a:ext cx="457200" cy="457200"/>
+          </a:xfrm>
+          <a:prstGeom prst="ellipse">
+            <a:avLst/>
+          </a:prstGeom>
+          <a:solidFill>
+            <a:srgbClr val="E8A33D"/>
+          </a:solidFill>
+          <a:ln/>
+        </p:spPr>
+      </p:sp>
+      <p:sp>
+        <p:nvSpPr>
+          <p:cNvPr id="17" name="Text 15"/>
+          <p:cNvSpPr/>
+          <p:nvPr/>
+        </p:nvSpPr>
+        <p:spPr>
+          <a:xfrm>
+            <a:off x="4572000" y="2194560"/>
+            <a:ext cx="457200" cy="457200"/>
+          </a:xfrm>
+          <a:prstGeom prst="rect">
+            <a:avLst/>
+          </a:prstGeom>
+          <a:noFill/>
+          <a:ln/>
+        </p:spPr>
+        <p:txBody>
+          <a:bodyPr wrap="square" lIns="0" tIns="0" rIns="0" bIns="0" rtlCol="0" anchor="ctr"/>
+          <a:lstStyle/>
+          <a:p>
+            <a:pPr algn="ctr" indent="0" marL="0">
+              <a:buNone/>
+            </a:pPr>
+            <a:r>
+              <a:rPr lang="en-US" sz="1800" b="1" dirty="0">
+                <a:solidFill>
+                  <a:srgbClr val="1E2761"/>
                 </a:solidFill>
                 <a:latin typeface="Georgia" pitchFamily="34" charset="0"/>
                 <a:ea typeface="Georgia" pitchFamily="34" charset="-122"/>
                 <a:cs typeface="Georgia" pitchFamily="34" charset="-120"/>
               </a:rPr>
-              <a:t>3 次</a:t>
-            </a:r>
-            <a:endParaRPr lang="en-US" sz="4400" dirty="0"/>
-          </a:p>
-          <a:p>
-            <a:pPr indent="0" marL="0">
-              <a:lnSpc>
-                <a:spcPts val="3000"/>
-              </a:lnSpc>
-              <a:buNone/>
-            </a:pPr>
-            <a:r>
-              <a:rPr lang="en-US" sz="4400" dirty="0">
-                <a:solidFill>
-                  <a:srgbClr val="23272E"/>
-                </a:solidFill>
-              </a:rPr>
-              <a:t>rate limit 429</a:t>
-            </a:r>
-            <a:pPr indent="0" marL="0">
-              <a:lnSpc>
-                <a:spcPts val="3000"/>
-              </a:lnSpc>
-              <a:buNone/>
-            </a:pPr>
-            <a:r>
-              <a:rPr lang="en-US" sz="1200" dirty="0">
-                <a:solidFill>
-                  <a:srgbClr val="6B7280"/>
-                </a:solidFill>
-              </a:rPr>
-              <a:t>（NVIDIA NIM 限流）</a:t>
-            </a:r>
-            <a:endParaRPr lang="en-US" sz="4400" dirty="0"/>
-          </a:p>
-        </p:txBody>
-      </p:sp>
-      <p:sp>
-        <p:nvSpPr>
-          <p:cNvPr id="10" name="Text 8"/>
-          <p:cNvSpPr/>
-          <p:nvPr/>
-        </p:nvSpPr>
-        <p:spPr>
-          <a:xfrm>
-            <a:off x="548640" y="5394960"/>
-            <a:ext cx="11109960" cy="548640"/>
-          </a:xfrm>
-          <a:prstGeom prst="rect">
-            <a:avLst/>
-          </a:prstGeom>
-          <a:noFill/>
-          <a:ln/>
-        </p:spPr>
-        <p:txBody>
-          <a:bodyPr wrap="square" lIns="0" tIns="0" rIns="0" bIns="0" rtlCol="0" anchor="ctr"/>
-          <a:lstStyle/>
-          <a:p>
-            <a:pPr algn="ctr" indent="0" marL="0">
-              <a:buNone/>
-            </a:pPr>
-            <a:r>
-              <a:rPr lang="en-US" sz="1700" i="1" dirty="0">
+              <a:t>②</a:t>
+            </a:r>
+            <a:endParaRPr lang="en-US" sz="1800" dirty="0"/>
+          </a:p>
+        </p:txBody>
+      </p:sp>
+      <p:sp>
+        <p:nvSpPr>
+          <p:cNvPr id="18" name="Text 16"/>
+          <p:cNvSpPr/>
+          <p:nvPr/>
+        </p:nvSpPr>
+        <p:spPr>
+          <a:xfrm>
+            <a:off x="5148072" y="2212848"/>
+            <a:ext cx="2606040" cy="457200"/>
+          </a:xfrm>
+          <a:prstGeom prst="rect">
+            <a:avLst/>
+          </a:prstGeom>
+          <a:noFill/>
+          <a:ln/>
+        </p:spPr>
+        <p:txBody>
+          <a:bodyPr wrap="square" lIns="0" tIns="0" rIns="0" bIns="0" rtlCol="0" anchor="ctr"/>
+          <a:lstStyle/>
+          <a:p>
+            <a:pPr indent="0" marL="0">
+              <a:buNone/>
+            </a:pPr>
+            <a:r>
+              <a:rPr lang="en-US" sz="1600" b="1" dirty="0">
                 <a:solidFill>
                   <a:srgbClr val="1E2761"/>
                 </a:solidFill>
@@ -16476,52 +16736,389 @@
                 <a:ea typeface="Georgia" pitchFamily="34" charset="-122"/>
                 <a:cs typeface="Georgia" pitchFamily="34" charset="-120"/>
               </a:rPr>
-              <a:t>協作不只產出成功，也共同理解失敗——成功與失敗，都是我們三層一起讀懂的。</a:t>
-            </a:r>
-            <a:endParaRPr lang="en-US" sz="1700" dirty="0"/>
-          </a:p>
-        </p:txBody>
-      </p:sp>
-      <p:sp>
-        <p:nvSpPr>
-          <p:cNvPr id="11" name="Text 9"/>
-          <p:cNvSpPr/>
-          <p:nvPr/>
-        </p:nvSpPr>
-        <p:spPr>
-          <a:xfrm>
-            <a:off x="502920" y="6583680"/>
-            <a:ext cx="11338560" cy="201168"/>
-          </a:xfrm>
-          <a:prstGeom prst="rect">
-            <a:avLst/>
-          </a:prstGeom>
-          <a:noFill/>
-          <a:ln/>
-        </p:spPr>
-        <p:txBody>
-          <a:bodyPr wrap="square" lIns="0" tIns="0" rIns="0" bIns="0" rtlCol="0" anchor="ctr"/>
-          <a:lstStyle/>
-          <a:p>
-            <a:pPr indent="0" marL="0">
-              <a:buNone/>
-            </a:pPr>
-            <a:r>
-              <a:rPr lang="en-US" sz="900" b="1" dirty="0">
-                <a:solidFill>
-                  <a:srgbClr val="E8A33D"/>
+              <a:t>島嶼種子多樣化</a:t>
+            </a:r>
+            <a:endParaRPr lang="en-US" sz="1600" dirty="0"/>
+          </a:p>
+        </p:txBody>
+      </p:sp>
+      <p:sp>
+        <p:nvSpPr>
+          <p:cNvPr id="19" name="Text 17"/>
+          <p:cNvSpPr/>
+          <p:nvPr/>
+        </p:nvSpPr>
+        <p:spPr>
+          <a:xfrm>
+            <a:off x="4599432" y="2788920"/>
+            <a:ext cx="3108960" cy="365760"/>
+          </a:xfrm>
+          <a:prstGeom prst="rect">
+            <a:avLst/>
+          </a:prstGeom>
+          <a:noFill/>
+          <a:ln/>
+        </p:spPr>
+        <p:txBody>
+          <a:bodyPr wrap="square" lIns="0" tIns="0" rIns="0" bIns="0" rtlCol="0" anchor="ctr"/>
+          <a:lstStyle/>
+          <a:p>
+            <a:pPr indent="0" marL="0">
+              <a:buNone/>
+            </a:pPr>
+            <a:r>
+              <a:rPr lang="en-US" sz="1250" i="1" dirty="0">
+                <a:solidFill>
+                  <a:srgbClr val="C0453B"/>
+                </a:solidFill>
+                <a:latin typeface="Calibri" pitchFamily="34" charset="0"/>
+                <a:ea typeface="Calibri" pitchFamily="34" charset="-122"/>
+                <a:cs typeface="Calibri" pitchFamily="34" charset="-120"/>
+              </a:rPr>
+              <a:t>對治：三島趨同</a:t>
+            </a:r>
+            <a:endParaRPr lang="en-US" sz="1250" dirty="0"/>
+          </a:p>
+        </p:txBody>
+      </p:sp>
+      <p:sp>
+        <p:nvSpPr>
+          <p:cNvPr id="20" name="Text 18"/>
+          <p:cNvSpPr/>
+          <p:nvPr/>
+        </p:nvSpPr>
+        <p:spPr>
+          <a:xfrm>
+            <a:off x="4599432" y="3246120"/>
+            <a:ext cx="3108960" cy="1371600"/>
+          </a:xfrm>
+          <a:prstGeom prst="rect">
+            <a:avLst/>
+          </a:prstGeom>
+          <a:noFill/>
+          <a:ln/>
+        </p:spPr>
+        <p:txBody>
+          <a:bodyPr wrap="square" lIns="0" tIns="0" rIns="0" bIns="0" rtlCol="0" anchor="ctr"/>
+          <a:lstStyle/>
+          <a:p>
+            <a:pPr indent="0" marL="0">
+              <a:lnSpc>
+                <a:spcPts val="2000"/>
+              </a:lnSpc>
+              <a:buNone/>
+            </a:pPr>
+            <a:r>
+              <a:rPr lang="en-US" sz="1350" dirty="0">
+                <a:solidFill>
+                  <a:srgbClr val="23272E"/>
+                </a:solidFill>
+                <a:latin typeface="Calibri" pitchFamily="34" charset="0"/>
+                <a:ea typeface="Calibri" pitchFamily="34" charset="-122"/>
+                <a:cs typeface="Calibri" pitchFamily="34" charset="-120"/>
+              </a:rPr>
+              <a:t>不同設計哲學各 seed 一島；migration_interval 調長、migration_rate 調低</a:t>
+            </a:r>
+            <a:endParaRPr lang="en-US" sz="1350" dirty="0"/>
+          </a:p>
+        </p:txBody>
+      </p:sp>
+      <p:sp>
+        <p:nvSpPr>
+          <p:cNvPr id="21" name="Text 19"/>
+          <p:cNvSpPr/>
+          <p:nvPr/>
+        </p:nvSpPr>
+        <p:spPr>
+          <a:xfrm>
+            <a:off x="4599432" y="4434840"/>
+            <a:ext cx="3108960" cy="274320"/>
+          </a:xfrm>
+          <a:prstGeom prst="rect">
+            <a:avLst/>
+          </a:prstGeom>
+          <a:noFill/>
+          <a:ln/>
+        </p:spPr>
+        <p:txBody>
+          <a:bodyPr wrap="square" lIns="0" tIns="0" rIns="0" bIns="0" rtlCol="0" anchor="ctr"/>
+          <a:lstStyle/>
+          <a:p>
+            <a:pPr indent="0" marL="0">
+              <a:buNone/>
+            </a:pPr>
+            <a:r>
+              <a:rPr lang="en-US" sz="1100" dirty="0">
+                <a:solidFill>
+                  <a:srgbClr val="6B7280"/>
                 </a:solidFill>
                 <a:latin typeface="Consolas" pitchFamily="34" charset="0"/>
                 <a:ea typeface="Consolas" pitchFamily="34" charset="-122"/>
                 <a:cs typeface="Consolas" pitchFamily="34" charset="-120"/>
               </a:rPr>
-              <a:t>‹code›  </a:t>
-            </a:r>
-            <a:pPr indent="0" marL="0">
-              <a:buNone/>
-            </a:pPr>
-            <a:r>
-              <a:rPr lang="en-US" sz="900" dirty="0">
+              <a:t>狀態：待辦</a:t>
+            </a:r>
+            <a:endParaRPr lang="en-US" sz="1100" dirty="0"/>
+          </a:p>
+        </p:txBody>
+      </p:sp>
+      <p:sp>
+        <p:nvSpPr>
+          <p:cNvPr id="22" name="Shape 20"/>
+          <p:cNvSpPr/>
+          <p:nvPr/>
+        </p:nvSpPr>
+        <p:spPr>
+          <a:xfrm>
+            <a:off x="8193024" y="1965960"/>
+            <a:ext cx="3520440" cy="2834640"/>
+          </a:xfrm>
+          <a:prstGeom prst="rect">
+            <a:avLst/>
+          </a:prstGeom>
+          <a:solidFill>
+            <a:srgbClr val="FFFFFF"/>
+          </a:solidFill>
+          <a:ln w="12700">
+            <a:solidFill>
+              <a:srgbClr val="E2E8F0"/>
+            </a:solidFill>
+            <a:prstDash val="solid"/>
+          </a:ln>
+          <a:effectLst>
+            <a:outerShdw sx="100000" sy="100000" kx="0" ky="0" algn="bl" rotWithShape="0" blurRad="88900" dist="38100" dir="8100000">
+              <a:srgbClr val="000000">
+                <a:alpha val="12000"/>
+              </a:srgbClr>
+            </a:outerShdw>
+          </a:effectLst>
+        </p:spPr>
+      </p:sp>
+      <p:sp>
+        <p:nvSpPr>
+          <p:cNvPr id="23" name="Shape 21"/>
+          <p:cNvSpPr/>
+          <p:nvPr/>
+        </p:nvSpPr>
+        <p:spPr>
+          <a:xfrm>
+            <a:off x="8193024" y="1965960"/>
+            <a:ext cx="3520440" cy="109728"/>
+          </a:xfrm>
+          <a:prstGeom prst="rect">
+            <a:avLst/>
+          </a:prstGeom>
+          <a:solidFill>
+            <a:srgbClr val="1E2761"/>
+          </a:solidFill>
+          <a:ln/>
+        </p:spPr>
+      </p:sp>
+      <p:sp>
+        <p:nvSpPr>
+          <p:cNvPr id="24" name="Shape 22"/>
+          <p:cNvSpPr/>
+          <p:nvPr/>
+        </p:nvSpPr>
+        <p:spPr>
+          <a:xfrm>
+            <a:off x="8394192" y="2194560"/>
+            <a:ext cx="457200" cy="457200"/>
+          </a:xfrm>
+          <a:prstGeom prst="ellipse">
+            <a:avLst/>
+          </a:prstGeom>
+          <a:solidFill>
+            <a:srgbClr val="E8A33D"/>
+          </a:solidFill>
+          <a:ln/>
+        </p:spPr>
+      </p:sp>
+      <p:sp>
+        <p:nvSpPr>
+          <p:cNvPr id="25" name="Text 23"/>
+          <p:cNvSpPr/>
+          <p:nvPr/>
+        </p:nvSpPr>
+        <p:spPr>
+          <a:xfrm>
+            <a:off x="8394192" y="2194560"/>
+            <a:ext cx="457200" cy="457200"/>
+          </a:xfrm>
+          <a:prstGeom prst="rect">
+            <a:avLst/>
+          </a:prstGeom>
+          <a:noFill/>
+          <a:ln/>
+        </p:spPr>
+        <p:txBody>
+          <a:bodyPr wrap="square" lIns="0" tIns="0" rIns="0" bIns="0" rtlCol="0" anchor="ctr"/>
+          <a:lstStyle/>
+          <a:p>
+            <a:pPr algn="ctr" indent="0" marL="0">
+              <a:buNone/>
+            </a:pPr>
+            <a:r>
+              <a:rPr lang="en-US" sz="1800" b="1" dirty="0">
+                <a:solidFill>
+                  <a:srgbClr val="1E2761"/>
+                </a:solidFill>
+                <a:latin typeface="Georgia" pitchFamily="34" charset="0"/>
+                <a:ea typeface="Georgia" pitchFamily="34" charset="-122"/>
+                <a:cs typeface="Georgia" pitchFamily="34" charset="-120"/>
+              </a:rPr>
+              <a:t>③</a:t>
+            </a:r>
+            <a:endParaRPr lang="en-US" sz="1800" dirty="0"/>
+          </a:p>
+        </p:txBody>
+      </p:sp>
+      <p:sp>
+        <p:nvSpPr>
+          <p:cNvPr id="26" name="Text 24"/>
+          <p:cNvSpPr/>
+          <p:nvPr/>
+        </p:nvSpPr>
+        <p:spPr>
+          <a:xfrm>
+            <a:off x="8970264" y="2212848"/>
+            <a:ext cx="2606040" cy="457200"/>
+          </a:xfrm>
+          <a:prstGeom prst="rect">
+            <a:avLst/>
+          </a:prstGeom>
+          <a:noFill/>
+          <a:ln/>
+        </p:spPr>
+        <p:txBody>
+          <a:bodyPr wrap="square" lIns="0" tIns="0" rIns="0" bIns="0" rtlCol="0" anchor="ctr"/>
+          <a:lstStyle/>
+          <a:p>
+            <a:pPr indent="0" marL="0">
+              <a:buNone/>
+            </a:pPr>
+            <a:r>
+              <a:rPr lang="en-US" sz="1600" b="1" dirty="0">
+                <a:solidFill>
+                  <a:srgbClr val="1E2761"/>
+                </a:solidFill>
+                <a:latin typeface="Georgia" pitchFamily="34" charset="0"/>
+                <a:ea typeface="Georgia" pitchFamily="34" charset="-122"/>
+                <a:cs typeface="Georgia" pitchFamily="34" charset="-120"/>
+              </a:rPr>
+              <a:t>啟動工具進化</a:t>
+            </a:r>
+            <a:endParaRPr lang="en-US" sz="1600" dirty="0"/>
+          </a:p>
+        </p:txBody>
+      </p:sp>
+      <p:sp>
+        <p:nvSpPr>
+          <p:cNvPr id="27" name="Text 25"/>
+          <p:cNvSpPr/>
+          <p:nvPr/>
+        </p:nvSpPr>
+        <p:spPr>
+          <a:xfrm>
+            <a:off x="8421624" y="2788920"/>
+            <a:ext cx="3108960" cy="365760"/>
+          </a:xfrm>
+          <a:prstGeom prst="rect">
+            <a:avLst/>
+          </a:prstGeom>
+          <a:noFill/>
+          <a:ln/>
+        </p:spPr>
+        <p:txBody>
+          <a:bodyPr wrap="square" lIns="0" tIns="0" rIns="0" bIns="0" rtlCol="0" anchor="ctr"/>
+          <a:lstStyle/>
+          <a:p>
+            <a:pPr indent="0" marL="0">
+              <a:buNone/>
+            </a:pPr>
+            <a:r>
+              <a:rPr lang="en-US" sz="1250" i="1" dirty="0">
+                <a:solidFill>
+                  <a:srgbClr val="C0453B"/>
+                </a:solidFill>
+                <a:latin typeface="Calibri" pitchFamily="34" charset="0"/>
+                <a:ea typeface="Calibri" pitchFamily="34" charset="-122"/>
+                <a:cs typeface="Calibri" pitchFamily="34" charset="-120"/>
+              </a:rPr>
+              <a:t>對治：搜尋空間用盡</a:t>
+            </a:r>
+            <a:endParaRPr lang="en-US" sz="1250" dirty="0"/>
+          </a:p>
+        </p:txBody>
+      </p:sp>
+      <p:sp>
+        <p:nvSpPr>
+          <p:cNvPr id="28" name="Text 26"/>
+          <p:cNvSpPr/>
+          <p:nvPr/>
+        </p:nvSpPr>
+        <p:spPr>
+          <a:xfrm>
+            <a:off x="8421624" y="3246120"/>
+            <a:ext cx="3108960" cy="1371600"/>
+          </a:xfrm>
+          <a:prstGeom prst="rect">
+            <a:avLst/>
+          </a:prstGeom>
+          <a:noFill/>
+          <a:ln/>
+        </p:spPr>
+        <p:txBody>
+          <a:bodyPr wrap="square" lIns="0" tIns="0" rIns="0" bIns="0" rtlCol="0" anchor="ctr"/>
+          <a:lstStyle/>
+          <a:p>
+            <a:pPr indent="0" marL="0">
+              <a:lnSpc>
+                <a:spcPts val="2000"/>
+              </a:lnSpc>
+              <a:buNone/>
+            </a:pPr>
+            <a:r>
+              <a:rPr lang="en-US" sz="1350" dirty="0">
+                <a:solidFill>
+                  <a:srgbClr val="23272E"/>
+                </a:solidFill>
+                <a:latin typeface="Calibri" pitchFamily="34" charset="0"/>
+                <a:ea typeface="Calibri" pitchFamily="34" charset="-122"/>
+                <a:cs typeface="Calibri" pitchFamily="34" charset="-120"/>
+              </a:rPr>
+              <a:t>讓 evolvable_tools.py 真正進化（＋ n_tools 維度）——給搜尋空間新原料</a:t>
+            </a:r>
+            <a:endParaRPr lang="en-US" sz="1350" dirty="0"/>
+          </a:p>
+        </p:txBody>
+      </p:sp>
+      <p:sp>
+        <p:nvSpPr>
+          <p:cNvPr id="29" name="Text 27"/>
+          <p:cNvSpPr/>
+          <p:nvPr/>
+        </p:nvSpPr>
+        <p:spPr>
+          <a:xfrm>
+            <a:off x="8421624" y="4434840"/>
+            <a:ext cx="3108960" cy="274320"/>
+          </a:xfrm>
+          <a:prstGeom prst="rect">
+            <a:avLst/>
+          </a:prstGeom>
+          <a:noFill/>
+          <a:ln/>
+        </p:spPr>
+        <p:txBody>
+          <a:bodyPr wrap="square" lIns="0" tIns="0" rIns="0" bIns="0" rtlCol="0" anchor="ctr"/>
+          <a:lstStyle/>
+          <a:p>
+            <a:pPr indent="0" marL="0">
+              <a:buNone/>
+            </a:pPr>
+            <a:r>
+              <a:rPr lang="en-US" sz="1100" dirty="0">
                 <a:solidFill>
                   <a:srgbClr val="6B7280"/>
                 </a:solidFill>
@@ -16529,7 +17126,168 @@
                 <a:ea typeface="Consolas" pitchFamily="34" charset="-122"/>
                 <a:cs typeface="Consolas" pitchFamily="34" charset="-120"/>
               </a:rPr>
-              <a:t>diff_based_evolution:false（full-rewrite 風險）見 </a:t>
+              <a:t>狀態：待辦</a:t>
+            </a:r>
+            <a:endParaRPr lang="en-US" sz="1100" dirty="0"/>
+          </a:p>
+        </p:txBody>
+      </p:sp>
+      <p:sp>
+        <p:nvSpPr>
+          <p:cNvPr id="30" name="Shape 28"/>
+          <p:cNvSpPr/>
+          <p:nvPr/>
+        </p:nvSpPr>
+        <p:spPr>
+          <a:xfrm>
+            <a:off x="548640" y="5029200"/>
+            <a:ext cx="11109960" cy="1280160"/>
+          </a:xfrm>
+          <a:prstGeom prst="rect">
+            <a:avLst/>
+          </a:prstGeom>
+          <a:solidFill>
+            <a:srgbClr val="1E2761"/>
+          </a:solidFill>
+          <a:ln w="12700">
+            <a:solidFill>
+              <a:srgbClr val="E2E8F0"/>
+            </a:solidFill>
+            <a:prstDash val="solid"/>
+          </a:ln>
+          <a:effectLst>
+            <a:outerShdw sx="100000" sy="100000" kx="0" ky="0" algn="bl" rotWithShape="0" blurRad="88900" dist="38100" dir="8100000">
+              <a:srgbClr val="000000">
+                <a:alpha val="12000"/>
+              </a:srgbClr>
+            </a:outerShdw>
+          </a:effectLst>
+        </p:spPr>
+      </p:sp>
+      <p:sp>
+        <p:nvSpPr>
+          <p:cNvPr id="31" name="Text 29"/>
+          <p:cNvSpPr/>
+          <p:nvPr/>
+        </p:nvSpPr>
+        <p:spPr>
+          <a:xfrm>
+            <a:off x="868680" y="5029200"/>
+            <a:ext cx="10515600" cy="1280160"/>
+          </a:xfrm>
+          <a:prstGeom prst="rect">
+            <a:avLst/>
+          </a:prstGeom>
+          <a:noFill/>
+          <a:ln/>
+        </p:spPr>
+        <p:txBody>
+          <a:bodyPr wrap="square" lIns="0" tIns="0" rIns="0" bIns="0" rtlCol="0" anchor="ctr"/>
+          <a:lstStyle/>
+          <a:p>
+            <a:pPr indent="0" marL="0">
+              <a:lnSpc>
+                <a:spcPts val="2100"/>
+              </a:lnSpc>
+              <a:buNone/>
+            </a:pPr>
+            <a:r>
+              <a:rPr lang="en-US" sz="1350" b="1" dirty="0">
+                <a:solidFill>
+                  <a:srgbClr val="E8A33D"/>
+                </a:solidFill>
+                <a:latin typeface="Calibri" pitchFamily="34" charset="0"/>
+                <a:ea typeface="Calibri" pitchFamily="34" charset="-122"/>
+                <a:cs typeface="Calibri" pitchFamily="34" charset="-120"/>
+              </a:rPr>
+              <a:t>配套（已就緒）：</a:t>
+            </a:r>
+            <a:pPr indent="0" marL="0">
+              <a:lnSpc>
+                <a:spcPts val="2100"/>
+              </a:lnSpc>
+              <a:buNone/>
+            </a:pPr>
+            <a:r>
+              <a:rPr lang="en-US" sz="1350" dirty="0">
+                <a:solidFill>
+                  <a:srgbClr val="FFFFFF"/>
+                </a:solidFill>
+                <a:latin typeface="Calibri" pitchFamily="34" charset="0"/>
+                <a:ea typeface="Calibri" pitchFamily="34" charset="-122"/>
+                <a:cs typeface="Calibri" pitchFamily="34" charset="-120"/>
+              </a:rPr>
+              <a:t>holdout 照妖鏡確認進步是真泛化、MAP-Elites 把 review_generation 當維度保護文字品質。</a:t>
+            </a:r>
+            <a:pPr indent="0" marL="0">
+              <a:lnSpc>
+                <a:spcPts val="2100"/>
+              </a:lnSpc>
+              <a:buNone/>
+            </a:pPr>
+            <a:r>
+              <a:rPr lang="en-US" sz="1350" dirty="0">
+                <a:solidFill>
+                  <a:srgbClr val="CADCFC"/>
+                </a:solidFill>
+                <a:latin typeface="Calibri" pitchFamily="34" charset="0"/>
+                <a:ea typeface="Calibri" pitchFamily="34" charset="-122"/>
+                <a:cs typeface="Calibri" pitchFamily="34" charset="-120"/>
+              </a:rPr>
+              <a:t>　前兩條治「卡在原地」，第三條給「新方向」。</a:t>
+            </a:r>
+            <a:endParaRPr lang="en-US" sz="1350" dirty="0"/>
+          </a:p>
+        </p:txBody>
+      </p:sp>
+      <p:sp>
+        <p:nvSpPr>
+          <p:cNvPr id="32" name="Text 30"/>
+          <p:cNvSpPr/>
+          <p:nvPr/>
+        </p:nvSpPr>
+        <p:spPr>
+          <a:xfrm>
+            <a:off x="502920" y="6583680"/>
+            <a:ext cx="11338560" cy="201168"/>
+          </a:xfrm>
+          <a:prstGeom prst="rect">
+            <a:avLst/>
+          </a:prstGeom>
+          <a:noFill/>
+          <a:ln/>
+        </p:spPr>
+        <p:txBody>
+          <a:bodyPr wrap="square" lIns="0" tIns="0" rIns="0" bIns="0" rtlCol="0" anchor="ctr"/>
+          <a:lstStyle/>
+          <a:p>
+            <a:pPr indent="0" marL="0">
+              <a:buNone/>
+            </a:pPr>
+            <a:r>
+              <a:rPr lang="en-US" sz="900" b="1" dirty="0">
+                <a:solidFill>
+                  <a:srgbClr val="E8A33D"/>
+                </a:solidFill>
+                <a:latin typeface="Consolas" pitchFamily="34" charset="0"/>
+                <a:ea typeface="Consolas" pitchFamily="34" charset="-122"/>
+                <a:cs typeface="Consolas" pitchFamily="34" charset="-120"/>
+              </a:rPr>
+              <a:t>‹code›  </a:t>
+            </a:r>
+            <a:pPr indent="0" marL="0">
+              <a:buNone/>
+            </a:pPr>
+            <a:r>
+              <a:rPr lang="en-US" sz="900" dirty="0">
+                <a:solidFill>
+                  <a:srgbClr val="6B7280"/>
+                </a:solidFill>
+                <a:latin typeface="Consolas" pitchFamily="34" charset="0"/>
+                <a:ea typeface="Consolas" pitchFamily="34" charset="-122"/>
+                <a:cs typeface="Consolas" pitchFamily="34" charset="-120"/>
+              </a:rPr>
+              <a:t>加 task </a:t>
             </a:r>
             <a:pPr indent="0" marL="0">
               <a:buNone/>
@@ -16550,7 +17308,77 @@
                   </a:extLst>
                 </a:hlinkClick>
               </a:rPr>
-              <a:t>openevolve_config.yaml:18</a:t>
+              <a:t>openevolve_evaluator.py:115</a:t>
+            </a:r>
+            <a:pPr indent="0" marL="0">
+              <a:buNone/>
+            </a:pPr>
+            <a:r>
+              <a:rPr lang="en-US" sz="900" dirty="0">
+                <a:solidFill>
+                  <a:srgbClr val="6B7280"/>
+                </a:solidFill>
+                <a:latin typeface="Consolas" pitchFamily="34" charset="0"/>
+                <a:ea typeface="Consolas" pitchFamily="34" charset="-122"/>
+                <a:cs typeface="Consolas" pitchFamily="34" charset="-120"/>
+              </a:rPr>
+              <a:t> · 島/遷移 </a:t>
+            </a:r>
+            <a:pPr indent="0" marL="0">
+              <a:buNone/>
+            </a:pPr>
+            <a:r>
+              <a:rPr lang="en-US" sz="900" u="sng" dirty="0">
+                <a:solidFill>
+                  <a:srgbClr val="3A5BA0"/>
+                </a:solidFill>
+                <a:latin typeface="Consolas" pitchFamily="34" charset="0"/>
+                <a:ea typeface="Consolas" pitchFamily="34" charset="-122"/>
+                <a:cs typeface="Consolas" pitchFamily="34" charset="-120"/>
+                <a:hlinkClick r:id="rId2" invalidUrl="" action="" tgtFrame="" tooltip="" history="1" highlightClick="0" endSnd="0">
+                  <a:extLst>
+                    <a:ext uri="{A12FA001-AC4F-418D-AE19-62706E023703}">
+                      <ahyp:hlinkClr xmlns:ahyp="http://schemas.microsoft.com/office/drawing/2018/hyperlinkcolor" val="tx"/>
+                    </a:ext>
+                  </a:extLst>
+                </a:hlinkClick>
+              </a:rPr>
+              <a:t>openevolve_config.yaml:71-78</a:t>
+            </a:r>
+            <a:pPr indent="0" marL="0">
+              <a:buNone/>
+            </a:pPr>
+            <a:r>
+              <a:rPr lang="en-US" sz="900" dirty="0">
+                <a:solidFill>
+                  <a:srgbClr val="6B7280"/>
+                </a:solidFill>
+                <a:latin typeface="Consolas" pitchFamily="34" charset="0"/>
+                <a:ea typeface="Consolas" pitchFamily="34" charset="-122"/>
+                <a:cs typeface="Consolas" pitchFamily="34" charset="-120"/>
+              </a:rPr>
+              <a:t> · 工具進化 </a:t>
+            </a:r>
+            <a:pPr indent="0" marL="0">
+              <a:buNone/>
+            </a:pPr>
+            <a:r>
+              <a:rPr lang="en-US" sz="900" u="sng" dirty="0">
+                <a:solidFill>
+                  <a:srgbClr val="3A5BA0"/>
+                </a:solidFill>
+                <a:latin typeface="Consolas" pitchFamily="34" charset="0"/>
+                <a:ea typeface="Consolas" pitchFamily="34" charset="-122"/>
+                <a:cs typeface="Consolas" pitchFamily="34" charset="-120"/>
+                <a:hlinkClick r:id="rId3" invalidUrl="" action="" tgtFrame="" tooltip="" history="1" highlightClick="0" endSnd="0">
+                  <a:extLst>
+                    <a:ext uri="{A12FA001-AC4F-418D-AE19-62706E023703}">
+                      <ahyp:hlinkClr xmlns:ahyp="http://schemas.microsoft.com/office/drawing/2018/hyperlinkcolor" val="tx"/>
+                    </a:ext>
+                  </a:extLst>
+                </a:hlinkClick>
+              </a:rPr>
+              <a:t>evolvable_tools.py:18-58</a:t>
             </a:r>
             <a:endParaRPr lang="en-US" sz="900" dirty="0"/>
           </a:p>
@@ -16641,7 +17469,7 @@
                 <a:ea typeface="Calibri" pitchFamily="34" charset="-122"/>
                 <a:cs typeface="Calibri" pitchFamily="34" charset="-120"/>
               </a:rPr>
-              <a:t>PART 7 · 反思</a:t>
+              <a:t>PART 6 · 高潮</a:t>
             </a:r>
             <a:endParaRPr lang="en-US" sz="1200" dirty="0"/>
           </a:p>
@@ -16680,7 +17508,7 @@
                 <a:ea typeface="Georgia" pitchFamily="34" charset="-122"/>
                 <a:cs typeface="Georgia" pitchFamily="34" charset="-120"/>
               </a:rPr>
-              <a:t>什麼該誰做？</a:t>
+              <a:t>連「失敗」也是協作的洞察</a:t>
             </a:r>
             <a:endParaRPr lang="en-US" sz="2800" dirty="0"/>
           </a:p>
@@ -16688,20 +17516,59 @@
       </p:sp>
       <p:sp>
         <p:nvSpPr>
-          <p:cNvPr id="5" name="Shape 3"/>
-          <p:cNvSpPr/>
-          <p:nvPr/>
-        </p:nvSpPr>
-        <p:spPr>
-          <a:xfrm>
-            <a:off x="548640" y="2011680"/>
-            <a:ext cx="3520440" cy="2743200"/>
+          <p:cNvPr id="5" name="Text 3"/>
+          <p:cNvSpPr/>
+          <p:nvPr/>
+        </p:nvSpPr>
+        <p:spPr>
+          <a:xfrm>
+            <a:off x="548640" y="1920240"/>
+            <a:ext cx="10972800" cy="457200"/>
+          </a:xfrm>
+          <a:prstGeom prst="rect">
+            <a:avLst/>
+          </a:prstGeom>
+          <a:noFill/>
+          <a:ln/>
+        </p:spPr>
+        <p:txBody>
+          <a:bodyPr wrap="square" lIns="0" tIns="0" rIns="0" bIns="0" rtlCol="0" anchor="ctr"/>
+          <a:lstStyle/>
+          <a:p>
+            <a:pPr indent="0" marL="0">
+              <a:buNone/>
+            </a:pPr>
+            <a:r>
+              <a:rPr lang="en-US" sz="1800" dirty="0">
+                <a:solidFill>
+                  <a:srgbClr val="23272E"/>
+                </a:solidFill>
+                <a:latin typeface="Calibri" pitchFamily="34" charset="0"/>
+                <a:ea typeface="Calibri" pitchFamily="34" charset="-122"/>
+                <a:cs typeface="Calibri" pitchFamily="34" charset="-120"/>
+              </a:rPr>
+              <a:t>8 次低分崩潰 → 我請 Claude 爬梳資料歸因：</a:t>
+            </a:r>
+            <a:endParaRPr lang="en-US" sz="1800" dirty="0"/>
+          </a:p>
+        </p:txBody>
+      </p:sp>
+      <p:sp>
+        <p:nvSpPr>
+          <p:cNvPr id="6" name="Shape 4"/>
+          <p:cNvSpPr/>
+          <p:nvPr/>
+        </p:nvSpPr>
+        <p:spPr>
+          <a:xfrm>
+            <a:off x="548640" y="2743200"/>
+            <a:ext cx="5440680" cy="2194560"/>
           </a:xfrm>
           <a:prstGeom prst="rect">
             <a:avLst/>
           </a:prstGeom>
           <a:solidFill>
-            <a:srgbClr val="FFFFFF"/>
+            <a:srgbClr val="F7E9E7"/>
           </a:solidFill>
           <a:ln w="12700">
             <a:solidFill>
@@ -16720,141 +17587,93 @@
       </p:sp>
       <p:sp>
         <p:nvSpPr>
-          <p:cNvPr id="6" name="Shape 4"/>
-          <p:cNvSpPr/>
-          <p:nvPr/>
-        </p:nvSpPr>
-        <p:spPr>
-          <a:xfrm>
-            <a:off x="548640" y="2011680"/>
-            <a:ext cx="3520440" cy="128016"/>
-          </a:xfrm>
-          <a:prstGeom prst="rect">
-            <a:avLst/>
-          </a:prstGeom>
-          <a:solidFill>
-            <a:srgbClr val="2E9E6B"/>
-          </a:solidFill>
-          <a:ln/>
-        </p:spPr>
-      </p:sp>
-      <p:sp>
-        <p:nvSpPr>
           <p:cNvPr id="7" name="Text 5"/>
           <p:cNvSpPr/>
           <p:nvPr/>
         </p:nvSpPr>
         <p:spPr>
           <a:xfrm>
-            <a:off x="749808" y="2286000"/>
-            <a:ext cx="3154680" cy="731520"/>
-          </a:xfrm>
-          <a:prstGeom prst="rect">
-            <a:avLst/>
-          </a:prstGeom>
-          <a:noFill/>
-          <a:ln/>
-        </p:spPr>
-        <p:txBody>
-          <a:bodyPr wrap="square" lIns="0" tIns="0" rIns="0" bIns="0" rtlCol="0" anchor="ctr"/>
-          <a:lstStyle/>
-          <a:p>
-            <a:pPr indent="0" marL="0">
-              <a:buNone/>
-            </a:pPr>
-            <a:r>
-              <a:rPr lang="en-US" sz="1600" b="1" dirty="0">
-                <a:solidFill>
-                  <a:srgbClr val="2E9E6B"/>
+            <a:off x="822960" y="3017520"/>
+            <a:ext cx="4937760" cy="1737360"/>
+          </a:xfrm>
+          <a:prstGeom prst="rect">
+            <a:avLst/>
+          </a:prstGeom>
+          <a:noFill/>
+          <a:ln/>
+        </p:spPr>
+        <p:txBody>
+          <a:bodyPr wrap="square" lIns="0" tIns="0" rIns="0" bIns="0" rtlCol="0" anchor="ctr"/>
+          <a:lstStyle/>
+          <a:p>
+            <a:pPr indent="0" marL="0">
+              <a:lnSpc>
+                <a:spcPts val="3000"/>
+              </a:lnSpc>
+              <a:buNone/>
+            </a:pPr>
+            <a:r>
+              <a:rPr lang="en-US" sz="4400" b="1" dirty="0">
+                <a:solidFill>
+                  <a:srgbClr val="C0453B"/>
                 </a:solidFill>
                 <a:latin typeface="Georgia" pitchFamily="34" charset="0"/>
                 <a:ea typeface="Georgia" pitchFamily="34" charset="-122"/>
                 <a:cs typeface="Georgia" pitchFamily="34" charset="-120"/>
               </a:rPr>
-              <a:t>我（Human）親自做</a:t>
-            </a:r>
-            <a:endParaRPr lang="en-US" sz="1600" dirty="0"/>
-          </a:p>
-        </p:txBody>
-      </p:sp>
-      <p:sp>
-        <p:nvSpPr>
-          <p:cNvPr id="8" name="Text 6"/>
-          <p:cNvSpPr/>
-          <p:nvPr/>
-        </p:nvSpPr>
-        <p:spPr>
-          <a:xfrm>
-            <a:off x="749808" y="3108960"/>
-            <a:ext cx="3154680" cy="1463040"/>
-          </a:xfrm>
-          <a:prstGeom prst="rect">
-            <a:avLst/>
-          </a:prstGeom>
-          <a:noFill/>
-          <a:ln/>
-        </p:spPr>
-        <p:txBody>
-          <a:bodyPr wrap="square" lIns="0" tIns="0" rIns="0" bIns="0" rtlCol="0" anchor="ctr"/>
-          <a:lstStyle/>
+              <a:t>5 次</a:t>
+            </a:r>
+            <a:endParaRPr lang="en-US" sz="4400" dirty="0"/>
+          </a:p>
           <a:p>
             <a:pPr indent="0" marL="0">
               <a:lnSpc>
-                <a:spcPts val="2400"/>
+                <a:spcPts val="3000"/>
               </a:lnSpc>
               <a:buNone/>
             </a:pPr>
             <a:r>
-              <a:rPr lang="en-US" sz="1500" dirty="0">
+              <a:rPr lang="en-US" sz="4400" dirty="0">
                 <a:solidFill>
                   <a:srgbClr val="23272E"/>
                 </a:solidFill>
-                <a:latin typeface="Calibri" pitchFamily="34" charset="0"/>
-                <a:ea typeface="Calibri" pitchFamily="34" charset="-122"/>
-                <a:cs typeface="Calibri" pitchFamily="34" charset="-120"/>
-              </a:rPr>
-              <a:t>方向 · 價值判斷</a:t>
-            </a:r>
-            <a:endParaRPr lang="en-US" sz="1500" dirty="0"/>
-          </a:p>
-          <a:p>
+              </a:rPr>
+              <a:t>YAML 語法壞掉</a:t>
+            </a:r>
             <a:pPr indent="0" marL="0">
               <a:lnSpc>
-                <a:spcPts val="2400"/>
+                <a:spcPts val="3000"/>
               </a:lnSpc>
               <a:buNone/>
             </a:pPr>
             <a:r>
-              <a:rPr lang="en-US" sz="1500" dirty="0">
-                <a:solidFill>
-                  <a:srgbClr val="23272E"/>
-                </a:solidFill>
-                <a:latin typeface="Calibri" pitchFamily="34" charset="0"/>
-                <a:ea typeface="Calibri" pitchFamily="34" charset="-122"/>
-                <a:cs typeface="Calibri" pitchFamily="34" charset="-120"/>
-              </a:rPr>
-              <a:t>不可逆決策 · 領域/物理知識</a:t>
-            </a:r>
-            <a:endParaRPr lang="en-US" sz="1500" dirty="0"/>
-          </a:p>
-        </p:txBody>
-      </p:sp>
-      <p:sp>
-        <p:nvSpPr>
-          <p:cNvPr id="9" name="Shape 7"/>
-          <p:cNvSpPr/>
-          <p:nvPr/>
-        </p:nvSpPr>
-        <p:spPr>
-          <a:xfrm>
-            <a:off x="4370832" y="2011680"/>
-            <a:ext cx="3520440" cy="2743200"/>
+              <a:rPr lang="en-US" sz="1200" dirty="0">
+                <a:solidFill>
+                  <a:srgbClr val="6B7280"/>
+                </a:solidFill>
+              </a:rPr>
+              <a:t>（full-rewrite 風險，繞過 clamp）</a:t>
+            </a:r>
+            <a:endParaRPr lang="en-US" sz="4400" dirty="0"/>
+          </a:p>
+        </p:txBody>
+      </p:sp>
+      <p:sp>
+        <p:nvSpPr>
+          <p:cNvPr id="8" name="Shape 6"/>
+          <p:cNvSpPr/>
+          <p:nvPr/>
+        </p:nvSpPr>
+        <p:spPr>
+          <a:xfrm>
+            <a:off x="6217920" y="2743200"/>
+            <a:ext cx="5440680" cy="2194560"/>
           </a:xfrm>
           <a:prstGeom prst="rect">
             <a:avLst/>
           </a:prstGeom>
           <a:solidFill>
-            <a:srgbClr val="FFFFFF"/>
+            <a:srgbClr val="FBF1E0"/>
           </a:solidFill>
           <a:ln w="12700">
             <a:solidFill>
@@ -16873,312 +17692,111 @@
       </p:sp>
       <p:sp>
         <p:nvSpPr>
-          <p:cNvPr id="10" name="Shape 8"/>
-          <p:cNvSpPr/>
-          <p:nvPr/>
-        </p:nvSpPr>
-        <p:spPr>
-          <a:xfrm>
-            <a:off x="4370832" y="2011680"/>
-            <a:ext cx="3520440" cy="128016"/>
-          </a:xfrm>
-          <a:prstGeom prst="rect">
-            <a:avLst/>
-          </a:prstGeom>
-          <a:solidFill>
-            <a:srgbClr val="3A5BA0"/>
-          </a:solidFill>
-          <a:ln/>
-        </p:spPr>
-      </p:sp>
-      <p:sp>
-        <p:nvSpPr>
-          <p:cNvPr id="11" name="Text 9"/>
-          <p:cNvSpPr/>
-          <p:nvPr/>
-        </p:nvSpPr>
-        <p:spPr>
-          <a:xfrm>
-            <a:off x="4572000" y="2286000"/>
-            <a:ext cx="3154680" cy="731520"/>
-          </a:xfrm>
-          <a:prstGeom prst="rect">
-            <a:avLst/>
-          </a:prstGeom>
-          <a:noFill/>
-          <a:ln/>
-        </p:spPr>
-        <p:txBody>
-          <a:bodyPr wrap="square" lIns="0" tIns="0" rIns="0" bIns="0" rtlCol="0" anchor="ctr"/>
-          <a:lstStyle/>
-          <a:p>
-            <a:pPr indent="0" marL="0">
-              <a:buNone/>
-            </a:pPr>
-            <a:r>
-              <a:rPr lang="en-US" sz="1600" b="1" dirty="0">
-                <a:solidFill>
-                  <a:srgbClr val="3A5BA0"/>
+          <p:cNvPr id="9" name="Text 7"/>
+          <p:cNvSpPr/>
+          <p:nvPr/>
+        </p:nvSpPr>
+        <p:spPr>
+          <a:xfrm>
+            <a:off x="6492240" y="3017520"/>
+            <a:ext cx="4937760" cy="1737360"/>
+          </a:xfrm>
+          <a:prstGeom prst="rect">
+            <a:avLst/>
+          </a:prstGeom>
+          <a:noFill/>
+          <a:ln/>
+        </p:spPr>
+        <p:txBody>
+          <a:bodyPr wrap="square" lIns="0" tIns="0" rIns="0" bIns="0" rtlCol="0" anchor="ctr"/>
+          <a:lstStyle/>
+          <a:p>
+            <a:pPr indent="0" marL="0">
+              <a:lnSpc>
+                <a:spcPts val="3000"/>
+              </a:lnSpc>
+              <a:buNone/>
+            </a:pPr>
+            <a:r>
+              <a:rPr lang="en-US" sz="4400" b="1" dirty="0">
+                <a:solidFill>
+                  <a:srgbClr val="B5791F"/>
                 </a:solidFill>
                 <a:latin typeface="Georgia" pitchFamily="34" charset="0"/>
                 <a:ea typeface="Georgia" pitchFamily="34" charset="-122"/>
                 <a:cs typeface="Georgia" pitchFamily="34" charset="-120"/>
               </a:rPr>
-              <a:t>交給 Claude</a:t>
-            </a:r>
-            <a:endParaRPr lang="en-US" sz="1600" dirty="0"/>
-          </a:p>
-        </p:txBody>
-      </p:sp>
-      <p:sp>
-        <p:nvSpPr>
-          <p:cNvPr id="12" name="Text 10"/>
-          <p:cNvSpPr/>
-          <p:nvPr/>
-        </p:nvSpPr>
-        <p:spPr>
-          <a:xfrm>
-            <a:off x="4572000" y="3108960"/>
-            <a:ext cx="3154680" cy="1463040"/>
-          </a:xfrm>
-          <a:prstGeom prst="rect">
-            <a:avLst/>
-          </a:prstGeom>
-          <a:noFill/>
-          <a:ln/>
-        </p:spPr>
-        <p:txBody>
-          <a:bodyPr wrap="square" lIns="0" tIns="0" rIns="0" bIns="0" rtlCol="0" anchor="ctr"/>
-          <a:lstStyle/>
+              <a:t>3 次</a:t>
+            </a:r>
+            <a:endParaRPr lang="en-US" sz="4400" dirty="0"/>
+          </a:p>
           <a:p>
             <a:pPr indent="0" marL="0">
               <a:lnSpc>
-                <a:spcPts val="2400"/>
+                <a:spcPts val="3000"/>
               </a:lnSpc>
               <a:buNone/>
             </a:pPr>
             <a:r>
-              <a:rPr lang="en-US" sz="1500" dirty="0">
+              <a:rPr lang="en-US" sz="4400" dirty="0">
                 <a:solidFill>
                   <a:srgbClr val="23272E"/>
                 </a:solidFill>
-                <a:latin typeface="Calibri" pitchFamily="34" charset="0"/>
-                <a:ea typeface="Calibri" pitchFamily="34" charset="-122"/>
-                <a:cs typeface="Calibri" pitchFamily="34" charset="-120"/>
-              </a:rPr>
-              <a:t>實作 · 驗證 · 分析</a:t>
-            </a:r>
-            <a:endParaRPr lang="en-US" sz="1500" dirty="0"/>
-          </a:p>
-          <a:p>
+              </a:rPr>
+              <a:t>rate limit 429</a:t>
+            </a:r>
             <a:pPr indent="0" marL="0">
               <a:lnSpc>
-                <a:spcPts val="2400"/>
+                <a:spcPts val="3000"/>
               </a:lnSpc>
               <a:buNone/>
             </a:pPr>
             <a:r>
-              <a:rPr lang="en-US" sz="1500" dirty="0">
-                <a:solidFill>
-                  <a:srgbClr val="23272E"/>
-                </a:solidFill>
-                <a:latin typeface="Calibri" pitchFamily="34" charset="0"/>
-                <a:ea typeface="Calibri" pitchFamily="34" charset="-122"/>
-                <a:cs typeface="Calibri" pitchFamily="34" charset="-120"/>
-              </a:rPr>
-              <a:t>文件 · 誠實回報</a:t>
-            </a:r>
-            <a:endParaRPr lang="en-US" sz="1500" dirty="0"/>
-          </a:p>
-        </p:txBody>
-      </p:sp>
-      <p:sp>
-        <p:nvSpPr>
-          <p:cNvPr id="13" name="Shape 11"/>
-          <p:cNvSpPr/>
-          <p:nvPr/>
-        </p:nvSpPr>
-        <p:spPr>
-          <a:xfrm>
-            <a:off x="8193024" y="2011680"/>
-            <a:ext cx="3520440" cy="2743200"/>
-          </a:xfrm>
-          <a:prstGeom prst="rect">
-            <a:avLst/>
-          </a:prstGeom>
-          <a:solidFill>
-            <a:srgbClr val="FFFFFF"/>
-          </a:solidFill>
-          <a:ln w="12700">
-            <a:solidFill>
-              <a:srgbClr val="E2E8F0"/>
-            </a:solidFill>
-            <a:prstDash val="solid"/>
-          </a:ln>
-          <a:effectLst>
-            <a:outerShdw sx="100000" sy="100000" kx="0" ky="0" algn="bl" rotWithShape="0" blurRad="88900" dist="38100" dir="8100000">
-              <a:srgbClr val="000000">
-                <a:alpha val="12000"/>
-              </a:srgbClr>
-            </a:outerShdw>
-          </a:effectLst>
-        </p:spPr>
-      </p:sp>
-      <p:sp>
-        <p:nvSpPr>
-          <p:cNvPr id="14" name="Shape 12"/>
-          <p:cNvSpPr/>
-          <p:nvPr/>
-        </p:nvSpPr>
-        <p:spPr>
-          <a:xfrm>
-            <a:off x="8193024" y="2011680"/>
-            <a:ext cx="3520440" cy="128016"/>
-          </a:xfrm>
-          <a:prstGeom prst="rect">
-            <a:avLst/>
-          </a:prstGeom>
-          <a:solidFill>
-            <a:srgbClr val="E8A33D"/>
-          </a:solidFill>
-          <a:ln/>
-        </p:spPr>
-      </p:sp>
-      <p:sp>
-        <p:nvSpPr>
-          <p:cNvPr id="15" name="Text 13"/>
-          <p:cNvSpPr/>
-          <p:nvPr/>
-        </p:nvSpPr>
-        <p:spPr>
-          <a:xfrm>
-            <a:off x="8394192" y="2286000"/>
-            <a:ext cx="3154680" cy="731520"/>
-          </a:xfrm>
-          <a:prstGeom prst="rect">
-            <a:avLst/>
-          </a:prstGeom>
-          <a:noFill/>
-          <a:ln/>
-        </p:spPr>
-        <p:txBody>
-          <a:bodyPr wrap="square" lIns="0" tIns="0" rIns="0" bIns="0" rtlCol="0" anchor="ctr"/>
-          <a:lstStyle/>
-          <a:p>
-            <a:pPr indent="0" marL="0">
-              <a:buNone/>
-            </a:pPr>
-            <a:r>
-              <a:rPr lang="en-US" sz="1600" b="1" dirty="0">
-                <a:solidFill>
-                  <a:srgbClr val="E8A33D"/>
+              <a:rPr lang="en-US" sz="1200" dirty="0">
+                <a:solidFill>
+                  <a:srgbClr val="6B7280"/>
+                </a:solidFill>
+              </a:rPr>
+              <a:t>（NVIDIA NIM 限流）</a:t>
+            </a:r>
+            <a:endParaRPr lang="en-US" sz="4400" dirty="0"/>
+          </a:p>
+        </p:txBody>
+      </p:sp>
+      <p:sp>
+        <p:nvSpPr>
+          <p:cNvPr id="10" name="Text 8"/>
+          <p:cNvSpPr/>
+          <p:nvPr/>
+        </p:nvSpPr>
+        <p:spPr>
+          <a:xfrm>
+            <a:off x="548640" y="5394960"/>
+            <a:ext cx="11109960" cy="548640"/>
+          </a:xfrm>
+          <a:prstGeom prst="rect">
+            <a:avLst/>
+          </a:prstGeom>
+          <a:noFill/>
+          <a:ln/>
+        </p:spPr>
+        <p:txBody>
+          <a:bodyPr wrap="square" lIns="0" tIns="0" rIns="0" bIns="0" rtlCol="0" anchor="ctr"/>
+          <a:lstStyle/>
+          <a:p>
+            <a:pPr algn="ctr" indent="0" marL="0">
+              <a:buNone/>
+            </a:pPr>
+            <a:r>
+              <a:rPr lang="en-US" sz="1700" i="1" dirty="0">
+                <a:solidFill>
+                  <a:srgbClr val="1E2761"/>
                 </a:solidFill>
                 <a:latin typeface="Georgia" pitchFamily="34" charset="0"/>
                 <a:ea typeface="Georgia" pitchFamily="34" charset="-122"/>
                 <a:cs typeface="Georgia" pitchFamily="34" charset="-120"/>
               </a:rPr>
-              <a:t>交給進化（OpenEvolve）</a:t>
-            </a:r>
-            <a:endParaRPr lang="en-US" sz="1600" dirty="0"/>
-          </a:p>
-        </p:txBody>
-      </p:sp>
-      <p:sp>
-        <p:nvSpPr>
-          <p:cNvPr id="16" name="Text 14"/>
-          <p:cNvSpPr/>
-          <p:nvPr/>
-        </p:nvSpPr>
-        <p:spPr>
-          <a:xfrm>
-            <a:off x="8394192" y="3108960"/>
-            <a:ext cx="3154680" cy="1463040"/>
-          </a:xfrm>
-          <a:prstGeom prst="rect">
-            <a:avLst/>
-          </a:prstGeom>
-          <a:noFill/>
-          <a:ln/>
-        </p:spPr>
-        <p:txBody>
-          <a:bodyPr wrap="square" lIns="0" tIns="0" rIns="0" bIns="0" rtlCol="0" anchor="ctr"/>
-          <a:lstStyle/>
-          <a:p>
-            <a:pPr indent="0" marL="0">
-              <a:lnSpc>
-                <a:spcPts val="2400"/>
-              </a:lnSpc>
-              <a:buNone/>
-            </a:pPr>
-            <a:r>
-              <a:rPr lang="en-US" sz="1500" dirty="0">
-                <a:solidFill>
-                  <a:srgbClr val="23272E"/>
-                </a:solidFill>
-                <a:latin typeface="Calibri" pitchFamily="34" charset="0"/>
-                <a:ea typeface="Calibri" pitchFamily="34" charset="-122"/>
-                <a:cs typeface="Calibri" pitchFamily="34" charset="-120"/>
-              </a:rPr>
-              <a:t>安全框架內的</a:t>
-            </a:r>
-            <a:endParaRPr lang="en-US" sz="1500" dirty="0"/>
-          </a:p>
-          <a:p>
-            <a:pPr indent="0" marL="0">
-              <a:lnSpc>
-                <a:spcPts val="2400"/>
-              </a:lnSpc>
-              <a:buNone/>
-            </a:pPr>
-            <a:r>
-              <a:rPr lang="en-US" sz="1500" dirty="0">
-                <a:solidFill>
-                  <a:srgbClr val="23272E"/>
-                </a:solidFill>
-                <a:latin typeface="Calibri" pitchFamily="34" charset="0"/>
-                <a:ea typeface="Calibri" pitchFamily="34" charset="-122"/>
-                <a:cs typeface="Calibri" pitchFamily="34" charset="-120"/>
-              </a:rPr>
-              <a:t>大規模探索與發明</a:t>
-            </a:r>
-            <a:endParaRPr lang="en-US" sz="1500" dirty="0"/>
-          </a:p>
-        </p:txBody>
-      </p:sp>
-      <p:sp>
-        <p:nvSpPr>
-          <p:cNvPr id="17" name="Text 15"/>
-          <p:cNvSpPr/>
-          <p:nvPr/>
-        </p:nvSpPr>
-        <p:spPr>
-          <a:xfrm>
-            <a:off x="548640" y="5120640"/>
-            <a:ext cx="10972800" cy="548640"/>
-          </a:xfrm>
-          <a:prstGeom prst="rect">
-            <a:avLst/>
-          </a:prstGeom>
-          <a:noFill/>
-          <a:ln/>
-        </p:spPr>
-        <p:txBody>
-          <a:bodyPr wrap="square" lIns="0" tIns="0" rIns="0" bIns="0" rtlCol="0" anchor="ctr"/>
-          <a:lstStyle/>
-          <a:p>
-            <a:pPr algn="ctr" indent="0" marL="0">
-              <a:buNone/>
-            </a:pPr>
-            <a:r>
-              <a:rPr lang="en-US" sz="1700" b="1" dirty="0">
-                <a:solidFill>
-                  <a:srgbClr val="1E2761"/>
-                </a:solidFill>
-                <a:latin typeface="Georgia" pitchFamily="34" charset="0"/>
-                <a:ea typeface="Georgia" pitchFamily="34" charset="-122"/>
-                <a:cs typeface="Georgia" pitchFamily="34" charset="-120"/>
-              </a:rPr>
-              <a:t>我用三條判準分工：可逆性 · 是否需要價值判斷 · 搜尋空間大小。</a:t>
+              <a:t>協作不只產出成功，也共同理解失敗——成功與失敗，都是我們三層一起讀懂的。</a:t>
             </a:r>
             <a:endParaRPr lang="en-US" sz="1700" dirty="0"/>
           </a:p>
@@ -17186,7 +17804,7 @@
       </p:sp>
       <p:sp>
         <p:nvSpPr>
-          <p:cNvPr id="18" name="Text 16"/>
+          <p:cNvPr id="11" name="Text 9"/>
           <p:cNvSpPr/>
           <p:nvPr/>
         </p:nvSpPr>
@@ -17231,7 +17849,7 @@
                 <a:ea typeface="Consolas" pitchFamily="34" charset="-122"/>
                 <a:cs typeface="Consolas" pitchFamily="34" charset="-120"/>
               </a:rPr>
-              <a:t>對應：我→config/*.yaml ｜ Claude→src/ + tests/ ｜ 進化→EVOLVE-BLOCK（</a:t>
+              <a:t>diff_based_evolution:false（full-rewrite 風險）見 </a:t>
             </a:r>
             <a:pPr indent="0" marL="0">
               <a:buNone/>
@@ -17252,56 +17870,7 @@
                   </a:extLst>
                 </a:hlinkClick>
               </a:rPr>
-              <a:t>agents_evolving.yaml</a:t>
-            </a:r>
-            <a:pPr indent="0" marL="0">
-              <a:buNone/>
-            </a:pPr>
-            <a:r>
-              <a:rPr lang="en-US" sz="900" dirty="0">
-                <a:solidFill>
-                  <a:srgbClr val="6B7280"/>
-                </a:solidFill>
-                <a:latin typeface="Consolas" pitchFamily="34" charset="0"/>
-                <a:ea typeface="Consolas" pitchFamily="34" charset="-122"/>
-                <a:cs typeface="Consolas" pitchFamily="34" charset="-120"/>
-              </a:rPr>
-              <a:t> / </a:t>
-            </a:r>
-            <a:pPr indent="0" marL="0">
-              <a:buNone/>
-            </a:pPr>
-            <a:r>
-              <a:rPr lang="en-US" sz="900" u="sng" dirty="0">
-                <a:solidFill>
-                  <a:srgbClr val="3A5BA0"/>
-                </a:solidFill>
-                <a:latin typeface="Consolas" pitchFamily="34" charset="0"/>
-                <a:ea typeface="Consolas" pitchFamily="34" charset="-122"/>
-                <a:cs typeface="Consolas" pitchFamily="34" charset="-120"/>
-                <a:hlinkClick r:id="rId2" invalidUrl="" action="" tgtFrame="" tooltip="" history="1" highlightClick="0" endSnd="0">
-                  <a:extLst>
-                    <a:ext uri="{A12FA001-AC4F-418D-AE19-62706E023703}">
-                      <ahyp:hlinkClr xmlns:ahyp="http://schemas.microsoft.com/office/drawing/2018/hyperlinkcolor" val="tx"/>
-                    </a:ext>
-                  </a:extLst>
-                </a:hlinkClick>
-              </a:rPr>
-              <a:t>evolvable_tools.py</a:t>
-            </a:r>
-            <a:pPr indent="0" marL="0">
-              <a:buNone/>
-            </a:pPr>
-            <a:r>
-              <a:rPr lang="en-US" sz="900" dirty="0">
-                <a:solidFill>
-                  <a:srgbClr val="6B7280"/>
-                </a:solidFill>
-                <a:latin typeface="Consolas" pitchFamily="34" charset="0"/>
-                <a:ea typeface="Consolas" pitchFamily="34" charset="-122"/>
-                <a:cs typeface="Consolas" pitchFamily="34" charset="-120"/>
-              </a:rPr>
-              <a:t>）</a:t>
+              <a:t>openevolve_config.yaml:18</a:t>
             </a:r>
             <a:endParaRPr lang="en-US" sz="900" dirty="0"/>
           </a:p>
@@ -17431,7 +18000,7 @@
                 <a:ea typeface="Georgia" pitchFamily="34" charset="-122"/>
                 <a:cs typeface="Georgia" pitchFamily="34" charset="-120"/>
               </a:rPr>
-              <a:t>Key Takeaways</a:t>
+              <a:t>什麼該誰做？</a:t>
             </a:r>
             <a:endParaRPr lang="en-US" sz="2800" dirty="0"/>
           </a:p>
@@ -17445,8 +18014,8 @@
         </p:nvSpPr>
         <p:spPr>
           <a:xfrm>
-            <a:off x="548640" y="1828800"/>
-            <a:ext cx="11109960" cy="868680"/>
+            <a:off x="548640" y="2011680"/>
+            <a:ext cx="3520440" cy="2743200"/>
           </a:xfrm>
           <a:prstGeom prst="rect">
             <a:avLst/>
@@ -17477,14 +18046,14 @@
         </p:nvSpPr>
         <p:spPr>
           <a:xfrm>
-            <a:off x="822960" y="2029968"/>
-            <a:ext cx="457200" cy="457200"/>
-          </a:xfrm>
-          <a:prstGeom prst="ellipse">
+            <a:off x="548640" y="2011680"/>
+            <a:ext cx="3520440" cy="128016"/>
+          </a:xfrm>
+          <a:prstGeom prst="rect">
             <a:avLst/>
           </a:prstGeom>
           <a:solidFill>
-            <a:srgbClr val="E8A33D"/>
+            <a:srgbClr val="2E9E6B"/>
           </a:solidFill>
           <a:ln/>
         </p:spPr>
@@ -17497,34 +18066,34 @@
         </p:nvSpPr>
         <p:spPr>
           <a:xfrm>
-            <a:off x="822960" y="2029968"/>
-            <a:ext cx="457200" cy="457200"/>
-          </a:xfrm>
-          <a:prstGeom prst="rect">
-            <a:avLst/>
-          </a:prstGeom>
-          <a:noFill/>
-          <a:ln/>
-        </p:spPr>
-        <p:txBody>
-          <a:bodyPr wrap="square" lIns="0" tIns="0" rIns="0" bIns="0" rtlCol="0" anchor="ctr"/>
-          <a:lstStyle/>
-          <a:p>
-            <a:pPr algn="ctr" indent="0" marL="0">
-              <a:buNone/>
-            </a:pPr>
-            <a:r>
-              <a:rPr lang="en-US" sz="1800" b="1" dirty="0">
-                <a:solidFill>
-                  <a:srgbClr val="1E2761"/>
+            <a:off x="749808" y="2286000"/>
+            <a:ext cx="3154680" cy="731520"/>
+          </a:xfrm>
+          <a:prstGeom prst="rect">
+            <a:avLst/>
+          </a:prstGeom>
+          <a:noFill/>
+          <a:ln/>
+        </p:spPr>
+        <p:txBody>
+          <a:bodyPr wrap="square" lIns="0" tIns="0" rIns="0" bIns="0" rtlCol="0" anchor="ctr"/>
+          <a:lstStyle/>
+          <a:p>
+            <a:pPr indent="0" marL="0">
+              <a:buNone/>
+            </a:pPr>
+            <a:r>
+              <a:rPr lang="en-US" sz="1600" b="1" dirty="0">
+                <a:solidFill>
+                  <a:srgbClr val="2E9E6B"/>
                 </a:solidFill>
                 <a:latin typeface="Georgia" pitchFamily="34" charset="0"/>
                 <a:ea typeface="Georgia" pitchFamily="34" charset="-122"/>
                 <a:cs typeface="Georgia" pitchFamily="34" charset="-120"/>
               </a:rPr>
-              <a:t>1</a:t>
-            </a:r>
-            <a:endParaRPr lang="en-US" sz="1800" dirty="0"/>
+              <a:t>我（Human）親自做</a:t>
+            </a:r>
+            <a:endParaRPr lang="en-US" sz="1600" dirty="0"/>
           </a:p>
         </p:txBody>
       </p:sp>
@@ -17536,24 +18105,27 @@
         </p:nvSpPr>
         <p:spPr>
           <a:xfrm>
-            <a:off x="1463040" y="1828800"/>
-            <a:ext cx="10058400" cy="868680"/>
-          </a:xfrm>
-          <a:prstGeom prst="rect">
-            <a:avLst/>
-          </a:prstGeom>
-          <a:noFill/>
-          <a:ln/>
-        </p:spPr>
-        <p:txBody>
-          <a:bodyPr wrap="square" lIns="0" tIns="0" rIns="0" bIns="0" rtlCol="0" anchor="ctr"/>
-          <a:lstStyle/>
-          <a:p>
-            <a:pPr indent="0" marL="0">
-              <a:buNone/>
-            </a:pPr>
-            <a:r>
-              <a:rPr lang="en-US" sz="1550" dirty="0">
+            <a:off x="749808" y="3108960"/>
+            <a:ext cx="3154680" cy="1463040"/>
+          </a:xfrm>
+          <a:prstGeom prst="rect">
+            <a:avLst/>
+          </a:prstGeom>
+          <a:noFill/>
+          <a:ln/>
+        </p:spPr>
+        <p:txBody>
+          <a:bodyPr wrap="square" lIns="0" tIns="0" rIns="0" bIns="0" rtlCol="0" anchor="ctr"/>
+          <a:lstStyle/>
+          <a:p>
+            <a:pPr indent="0" marL="0">
+              <a:lnSpc>
+                <a:spcPts val="2400"/>
+              </a:lnSpc>
+              <a:buNone/>
+            </a:pPr>
+            <a:r>
+              <a:rPr lang="en-US" sz="1500" dirty="0">
                 <a:solidFill>
                   <a:srgbClr val="23272E"/>
                 </a:solidFill>
@@ -17561,9 +18133,29 @@
                 <a:ea typeface="Calibri" pitchFamily="34" charset="-122"/>
                 <a:cs typeface="Calibri" pitchFamily="34" charset="-120"/>
               </a:rPr>
-              <a:t>進化能設計 agent，但要防它把自己改壞 → 護欄越往內越強（最壞只是退化）</a:t>
-            </a:r>
-            <a:endParaRPr lang="en-US" sz="1550" dirty="0"/>
+              <a:t>方向 · 價值判斷</a:t>
+            </a:r>
+            <a:endParaRPr lang="en-US" sz="1500" dirty="0"/>
+          </a:p>
+          <a:p>
+            <a:pPr indent="0" marL="0">
+              <a:lnSpc>
+                <a:spcPts val="2400"/>
+              </a:lnSpc>
+              <a:buNone/>
+            </a:pPr>
+            <a:r>
+              <a:rPr lang="en-US" sz="1500" dirty="0">
+                <a:solidFill>
+                  <a:srgbClr val="23272E"/>
+                </a:solidFill>
+                <a:latin typeface="Calibri" pitchFamily="34" charset="0"/>
+                <a:ea typeface="Calibri" pitchFamily="34" charset="-122"/>
+                <a:cs typeface="Calibri" pitchFamily="34" charset="-120"/>
+              </a:rPr>
+              <a:t>不可逆決策 · 領域/物理知識</a:t>
+            </a:r>
+            <a:endParaRPr lang="en-US" sz="1500" dirty="0"/>
           </a:p>
         </p:txBody>
       </p:sp>
@@ -17575,8 +18167,8 @@
         </p:nvSpPr>
         <p:spPr>
           <a:xfrm>
-            <a:off x="548640" y="2834640"/>
-            <a:ext cx="11109960" cy="868680"/>
+            <a:off x="4370832" y="2011680"/>
+            <a:ext cx="3520440" cy="2743200"/>
           </a:xfrm>
           <a:prstGeom prst="rect">
             <a:avLst/>
@@ -17607,14 +18199,14 @@
         </p:nvSpPr>
         <p:spPr>
           <a:xfrm>
-            <a:off x="822960" y="3035808"/>
-            <a:ext cx="457200" cy="457200"/>
-          </a:xfrm>
-          <a:prstGeom prst="ellipse">
+            <a:off x="4370832" y="2011680"/>
+            <a:ext cx="3520440" cy="128016"/>
+          </a:xfrm>
+          <a:prstGeom prst="rect">
             <a:avLst/>
           </a:prstGeom>
           <a:solidFill>
-            <a:srgbClr val="E8A33D"/>
+            <a:srgbClr val="3A5BA0"/>
           </a:solidFill>
           <a:ln/>
         </p:spPr>
@@ -17627,34 +18219,34 @@
         </p:nvSpPr>
         <p:spPr>
           <a:xfrm>
-            <a:off x="822960" y="3035808"/>
-            <a:ext cx="457200" cy="457200"/>
-          </a:xfrm>
-          <a:prstGeom prst="rect">
-            <a:avLst/>
-          </a:prstGeom>
-          <a:noFill/>
-          <a:ln/>
-        </p:spPr>
-        <p:txBody>
-          <a:bodyPr wrap="square" lIns="0" tIns="0" rIns="0" bIns="0" rtlCol="0" anchor="ctr"/>
-          <a:lstStyle/>
-          <a:p>
-            <a:pPr algn="ctr" indent="0" marL="0">
-              <a:buNone/>
-            </a:pPr>
-            <a:r>
-              <a:rPr lang="en-US" sz="1800" b="1" dirty="0">
-                <a:solidFill>
-                  <a:srgbClr val="1E2761"/>
+            <a:off x="4572000" y="2286000"/>
+            <a:ext cx="3154680" cy="731520"/>
+          </a:xfrm>
+          <a:prstGeom prst="rect">
+            <a:avLst/>
+          </a:prstGeom>
+          <a:noFill/>
+          <a:ln/>
+        </p:spPr>
+        <p:txBody>
+          <a:bodyPr wrap="square" lIns="0" tIns="0" rIns="0" bIns="0" rtlCol="0" anchor="ctr"/>
+          <a:lstStyle/>
+          <a:p>
+            <a:pPr indent="0" marL="0">
+              <a:buNone/>
+            </a:pPr>
+            <a:r>
+              <a:rPr lang="en-US" sz="1600" b="1" dirty="0">
+                <a:solidFill>
+                  <a:srgbClr val="3A5BA0"/>
                 </a:solidFill>
                 <a:latin typeface="Georgia" pitchFamily="34" charset="0"/>
                 <a:ea typeface="Georgia" pitchFamily="34" charset="-122"/>
                 <a:cs typeface="Georgia" pitchFamily="34" charset="-120"/>
               </a:rPr>
-              <a:t>2</a:t>
-            </a:r>
-            <a:endParaRPr lang="en-US" sz="1800" dirty="0"/>
+              <a:t>交給 Claude</a:t>
+            </a:r>
+            <a:endParaRPr lang="en-US" sz="1600" dirty="0"/>
           </a:p>
         </p:txBody>
       </p:sp>
@@ -17666,24 +18258,27 @@
         </p:nvSpPr>
         <p:spPr>
           <a:xfrm>
-            <a:off x="1463040" y="2834640"/>
-            <a:ext cx="10058400" cy="868680"/>
-          </a:xfrm>
-          <a:prstGeom prst="rect">
-            <a:avLst/>
-          </a:prstGeom>
-          <a:noFill/>
-          <a:ln/>
-        </p:spPr>
-        <p:txBody>
-          <a:bodyPr wrap="square" lIns="0" tIns="0" rIns="0" bIns="0" rtlCol="0" anchor="ctr"/>
-          <a:lstStyle/>
-          <a:p>
-            <a:pPr indent="0" marL="0">
-              <a:buNone/>
-            </a:pPr>
-            <a:r>
-              <a:rPr lang="en-US" sz="1550" dirty="0">
+            <a:off x="4572000" y="3108960"/>
+            <a:ext cx="3154680" cy="1463040"/>
+          </a:xfrm>
+          <a:prstGeom prst="rect">
+            <a:avLst/>
+          </a:prstGeom>
+          <a:noFill/>
+          <a:ln/>
+        </p:spPr>
+        <p:txBody>
+          <a:bodyPr wrap="square" lIns="0" tIns="0" rIns="0" bIns="0" rtlCol="0" anchor="ctr"/>
+          <a:lstStyle/>
+          <a:p>
+            <a:pPr indent="0" marL="0">
+              <a:lnSpc>
+                <a:spcPts val="2400"/>
+              </a:lnSpc>
+              <a:buNone/>
+            </a:pPr>
+            <a:r>
+              <a:rPr lang="en-US" sz="1500" dirty="0">
                 <a:solidFill>
                   <a:srgbClr val="23272E"/>
                 </a:solidFill>
@@ -17691,9 +18286,29 @@
                 <a:ea typeface="Calibri" pitchFamily="34" charset="-122"/>
                 <a:cs typeface="Calibri" pitchFamily="34" charset="-120"/>
               </a:rPr>
-              <a:t>協議 / 策略分離 + 優雅退化 = 可安全進化的地形</a:t>
-            </a:r>
-            <a:endParaRPr lang="en-US" sz="1550" dirty="0"/>
+              <a:t>實作 · 驗證 · 分析</a:t>
+            </a:r>
+            <a:endParaRPr lang="en-US" sz="1500" dirty="0"/>
+          </a:p>
+          <a:p>
+            <a:pPr indent="0" marL="0">
+              <a:lnSpc>
+                <a:spcPts val="2400"/>
+              </a:lnSpc>
+              <a:buNone/>
+            </a:pPr>
+            <a:r>
+              <a:rPr lang="en-US" sz="1500" dirty="0">
+                <a:solidFill>
+                  <a:srgbClr val="23272E"/>
+                </a:solidFill>
+                <a:latin typeface="Calibri" pitchFamily="34" charset="0"/>
+                <a:ea typeface="Calibri" pitchFamily="34" charset="-122"/>
+                <a:cs typeface="Calibri" pitchFamily="34" charset="-120"/>
+              </a:rPr>
+              <a:t>文件 · 誠實回報</a:t>
+            </a:r>
+            <a:endParaRPr lang="en-US" sz="1500" dirty="0"/>
           </a:p>
         </p:txBody>
       </p:sp>
@@ -17705,8 +18320,8 @@
         </p:nvSpPr>
         <p:spPr>
           <a:xfrm>
-            <a:off x="548640" y="3840480"/>
-            <a:ext cx="11109960" cy="868680"/>
+            <a:off x="8193024" y="2011680"/>
+            <a:ext cx="3520440" cy="2743200"/>
           </a:xfrm>
           <a:prstGeom prst="rect">
             <a:avLst/>
@@ -17737,10 +18352,10 @@
         </p:nvSpPr>
         <p:spPr>
           <a:xfrm>
-            <a:off x="822960" y="4041648"/>
-            <a:ext cx="457200" cy="457200"/>
-          </a:xfrm>
-          <a:prstGeom prst="ellipse">
+            <a:off x="8193024" y="2011680"/>
+            <a:ext cx="3520440" cy="128016"/>
+          </a:xfrm>
+          <a:prstGeom prst="rect">
             <a:avLst/>
           </a:prstGeom>
           <a:solidFill>
@@ -17757,34 +18372,34 @@
         </p:nvSpPr>
         <p:spPr>
           <a:xfrm>
-            <a:off x="822960" y="4041648"/>
-            <a:ext cx="457200" cy="457200"/>
-          </a:xfrm>
-          <a:prstGeom prst="rect">
-            <a:avLst/>
-          </a:prstGeom>
-          <a:noFill/>
-          <a:ln/>
-        </p:spPr>
-        <p:txBody>
-          <a:bodyPr wrap="square" lIns="0" tIns="0" rIns="0" bIns="0" rtlCol="0" anchor="ctr"/>
-          <a:lstStyle/>
-          <a:p>
-            <a:pPr algn="ctr" indent="0" marL="0">
-              <a:buNone/>
-            </a:pPr>
-            <a:r>
-              <a:rPr lang="en-US" sz="1800" b="1" dirty="0">
-                <a:solidFill>
-                  <a:srgbClr val="1E2761"/>
+            <a:off x="8394192" y="2286000"/>
+            <a:ext cx="3154680" cy="731520"/>
+          </a:xfrm>
+          <a:prstGeom prst="rect">
+            <a:avLst/>
+          </a:prstGeom>
+          <a:noFill/>
+          <a:ln/>
+        </p:spPr>
+        <p:txBody>
+          <a:bodyPr wrap="square" lIns="0" tIns="0" rIns="0" bIns="0" rtlCol="0" anchor="ctr"/>
+          <a:lstStyle/>
+          <a:p>
+            <a:pPr indent="0" marL="0">
+              <a:buNone/>
+            </a:pPr>
+            <a:r>
+              <a:rPr lang="en-US" sz="1600" b="1" dirty="0">
+                <a:solidFill>
+                  <a:srgbClr val="E8A33D"/>
                 </a:solidFill>
                 <a:latin typeface="Georgia" pitchFamily="34" charset="0"/>
                 <a:ea typeface="Georgia" pitchFamily="34" charset="-122"/>
                 <a:cs typeface="Georgia" pitchFamily="34" charset="-120"/>
               </a:rPr>
-              <a:t>3</a:t>
-            </a:r>
-            <a:endParaRPr lang="en-US" sz="1800" dirty="0"/>
+              <a:t>交給進化（OpenEvolve）</a:t>
+            </a:r>
+            <a:endParaRPr lang="en-US" sz="1600" dirty="0"/>
           </a:p>
         </p:txBody>
       </p:sp>
@@ -17796,24 +18411,27 @@
         </p:nvSpPr>
         <p:spPr>
           <a:xfrm>
-            <a:off x="1463040" y="3840480"/>
-            <a:ext cx="10058400" cy="868680"/>
-          </a:xfrm>
-          <a:prstGeom prst="rect">
-            <a:avLst/>
-          </a:prstGeom>
-          <a:noFill/>
-          <a:ln/>
-        </p:spPr>
-        <p:txBody>
-          <a:bodyPr wrap="square" lIns="0" tIns="0" rIns="0" bIns="0" rtlCol="0" anchor="ctr"/>
-          <a:lstStyle/>
-          <a:p>
-            <a:pPr indent="0" marL="0">
-              <a:buNone/>
-            </a:pPr>
-            <a:r>
-              <a:rPr lang="en-US" sz="1550" dirty="0">
+            <a:off x="8394192" y="3108960"/>
+            <a:ext cx="3154680" cy="1463040"/>
+          </a:xfrm>
+          <a:prstGeom prst="rect">
+            <a:avLst/>
+          </a:prstGeom>
+          <a:noFill/>
+          <a:ln/>
+        </p:spPr>
+        <p:txBody>
+          <a:bodyPr wrap="square" lIns="0" tIns="0" rIns="0" bIns="0" rtlCol="0" anchor="ctr"/>
+          <a:lstStyle/>
+          <a:p>
+            <a:pPr indent="0" marL="0">
+              <a:lnSpc>
+                <a:spcPts val="2400"/>
+              </a:lnSpc>
+              <a:buNone/>
+            </a:pPr>
+            <a:r>
+              <a:rPr lang="en-US" sz="1500" dirty="0">
                 <a:solidFill>
                   <a:srgbClr val="23272E"/>
                 </a:solidFill>
@@ -17821,21 +18439,333 @@
                 <a:ea typeface="Calibri" pitchFamily="34" charset="-122"/>
                 <a:cs typeface="Calibri" pitchFamily="34" charset="-120"/>
               </a:rPr>
-              <a:t>誠實回報 + 人類把關不可逆 = 協作安全地基；分數健康 ≠ 功能正確</a:t>
-            </a:r>
-            <a:endParaRPr lang="en-US" sz="1550" dirty="0"/>
-          </a:p>
-        </p:txBody>
-      </p:sp>
-      <p:sp>
-        <p:nvSpPr>
-          <p:cNvPr id="17" name="Shape 15"/>
-          <p:cNvSpPr/>
-          <p:nvPr/>
-        </p:nvSpPr>
-        <p:spPr>
-          <a:xfrm>
-            <a:off x="548640" y="4846320"/>
+              <a:t>安全框架內的</a:t>
+            </a:r>
+            <a:endParaRPr lang="en-US" sz="1500" dirty="0"/>
+          </a:p>
+          <a:p>
+            <a:pPr indent="0" marL="0">
+              <a:lnSpc>
+                <a:spcPts val="2400"/>
+              </a:lnSpc>
+              <a:buNone/>
+            </a:pPr>
+            <a:r>
+              <a:rPr lang="en-US" sz="1500" dirty="0">
+                <a:solidFill>
+                  <a:srgbClr val="23272E"/>
+                </a:solidFill>
+                <a:latin typeface="Calibri" pitchFamily="34" charset="0"/>
+                <a:ea typeface="Calibri" pitchFamily="34" charset="-122"/>
+                <a:cs typeface="Calibri" pitchFamily="34" charset="-120"/>
+              </a:rPr>
+              <a:t>大規模探索與發明</a:t>
+            </a:r>
+            <a:endParaRPr lang="en-US" sz="1500" dirty="0"/>
+          </a:p>
+        </p:txBody>
+      </p:sp>
+      <p:sp>
+        <p:nvSpPr>
+          <p:cNvPr id="17" name="Text 15"/>
+          <p:cNvSpPr/>
+          <p:nvPr/>
+        </p:nvSpPr>
+        <p:spPr>
+          <a:xfrm>
+            <a:off x="548640" y="5120640"/>
+            <a:ext cx="10972800" cy="548640"/>
+          </a:xfrm>
+          <a:prstGeom prst="rect">
+            <a:avLst/>
+          </a:prstGeom>
+          <a:noFill/>
+          <a:ln/>
+        </p:spPr>
+        <p:txBody>
+          <a:bodyPr wrap="square" lIns="0" tIns="0" rIns="0" bIns="0" rtlCol="0" anchor="ctr"/>
+          <a:lstStyle/>
+          <a:p>
+            <a:pPr algn="ctr" indent="0" marL="0">
+              <a:buNone/>
+            </a:pPr>
+            <a:r>
+              <a:rPr lang="en-US" sz="1700" b="1" dirty="0">
+                <a:solidFill>
+                  <a:srgbClr val="1E2761"/>
+                </a:solidFill>
+                <a:latin typeface="Georgia" pitchFamily="34" charset="0"/>
+                <a:ea typeface="Georgia" pitchFamily="34" charset="-122"/>
+                <a:cs typeface="Georgia" pitchFamily="34" charset="-120"/>
+              </a:rPr>
+              <a:t>我用三條判準分工：可逆性 · 是否需要價值判斷 · 搜尋空間大小。</a:t>
+            </a:r>
+            <a:endParaRPr lang="en-US" sz="1700" dirty="0"/>
+          </a:p>
+        </p:txBody>
+      </p:sp>
+      <p:sp>
+        <p:nvSpPr>
+          <p:cNvPr id="18" name="Text 16"/>
+          <p:cNvSpPr/>
+          <p:nvPr/>
+        </p:nvSpPr>
+        <p:spPr>
+          <a:xfrm>
+            <a:off x="502920" y="6583680"/>
+            <a:ext cx="11338560" cy="201168"/>
+          </a:xfrm>
+          <a:prstGeom prst="rect">
+            <a:avLst/>
+          </a:prstGeom>
+          <a:noFill/>
+          <a:ln/>
+        </p:spPr>
+        <p:txBody>
+          <a:bodyPr wrap="square" lIns="0" tIns="0" rIns="0" bIns="0" rtlCol="0" anchor="ctr"/>
+          <a:lstStyle/>
+          <a:p>
+            <a:pPr indent="0" marL="0">
+              <a:buNone/>
+            </a:pPr>
+            <a:r>
+              <a:rPr lang="en-US" sz="900" b="1" dirty="0">
+                <a:solidFill>
+                  <a:srgbClr val="E8A33D"/>
+                </a:solidFill>
+                <a:latin typeface="Consolas" pitchFamily="34" charset="0"/>
+                <a:ea typeface="Consolas" pitchFamily="34" charset="-122"/>
+                <a:cs typeface="Consolas" pitchFamily="34" charset="-120"/>
+              </a:rPr>
+              <a:t>‹code›  </a:t>
+            </a:r>
+            <a:pPr indent="0" marL="0">
+              <a:buNone/>
+            </a:pPr>
+            <a:r>
+              <a:rPr lang="en-US" sz="900" dirty="0">
+                <a:solidFill>
+                  <a:srgbClr val="6B7280"/>
+                </a:solidFill>
+                <a:latin typeface="Consolas" pitchFamily="34" charset="0"/>
+                <a:ea typeface="Consolas" pitchFamily="34" charset="-122"/>
+                <a:cs typeface="Consolas" pitchFamily="34" charset="-120"/>
+              </a:rPr>
+              <a:t>對應：我→config/*.yaml ｜ Claude→src/ + tests/ ｜ 進化→EVOLVE-BLOCK（</a:t>
+            </a:r>
+            <a:pPr indent="0" marL="0">
+              <a:buNone/>
+            </a:pPr>
+            <a:r>
+              <a:rPr lang="en-US" sz="900" u="sng" dirty="0">
+                <a:solidFill>
+                  <a:srgbClr val="3A5BA0"/>
+                </a:solidFill>
+                <a:latin typeface="Consolas" pitchFamily="34" charset="0"/>
+                <a:ea typeface="Consolas" pitchFamily="34" charset="-122"/>
+                <a:cs typeface="Consolas" pitchFamily="34" charset="-120"/>
+                <a:hlinkClick r:id="rId1" invalidUrl="" action="" tgtFrame="" tooltip="" history="1" highlightClick="0" endSnd="0">
+                  <a:extLst>
+                    <a:ext uri="{A12FA001-AC4F-418D-AE19-62706E023703}">
+                      <ahyp:hlinkClr xmlns:ahyp="http://schemas.microsoft.com/office/drawing/2018/hyperlinkcolor" val="tx"/>
+                    </a:ext>
+                  </a:extLst>
+                </a:hlinkClick>
+              </a:rPr>
+              <a:t>agents_evolving.yaml</a:t>
+            </a:r>
+            <a:pPr indent="0" marL="0">
+              <a:buNone/>
+            </a:pPr>
+            <a:r>
+              <a:rPr lang="en-US" sz="900" dirty="0">
+                <a:solidFill>
+                  <a:srgbClr val="6B7280"/>
+                </a:solidFill>
+                <a:latin typeface="Consolas" pitchFamily="34" charset="0"/>
+                <a:ea typeface="Consolas" pitchFamily="34" charset="-122"/>
+                <a:cs typeface="Consolas" pitchFamily="34" charset="-120"/>
+              </a:rPr>
+              <a:t> / </a:t>
+            </a:r>
+            <a:pPr indent="0" marL="0">
+              <a:buNone/>
+            </a:pPr>
+            <a:r>
+              <a:rPr lang="en-US" sz="900" u="sng" dirty="0">
+                <a:solidFill>
+                  <a:srgbClr val="3A5BA0"/>
+                </a:solidFill>
+                <a:latin typeface="Consolas" pitchFamily="34" charset="0"/>
+                <a:ea typeface="Consolas" pitchFamily="34" charset="-122"/>
+                <a:cs typeface="Consolas" pitchFamily="34" charset="-120"/>
+                <a:hlinkClick r:id="rId2" invalidUrl="" action="" tgtFrame="" tooltip="" history="1" highlightClick="0" endSnd="0">
+                  <a:extLst>
+                    <a:ext uri="{A12FA001-AC4F-418D-AE19-62706E023703}">
+                      <ahyp:hlinkClr xmlns:ahyp="http://schemas.microsoft.com/office/drawing/2018/hyperlinkcolor" val="tx"/>
+                    </a:ext>
+                  </a:extLst>
+                </a:hlinkClick>
+              </a:rPr>
+              <a:t>evolvable_tools.py</a:t>
+            </a:r>
+            <a:pPr indent="0" marL="0">
+              <a:buNone/>
+            </a:pPr>
+            <a:r>
+              <a:rPr lang="en-US" sz="900" dirty="0">
+                <a:solidFill>
+                  <a:srgbClr val="6B7280"/>
+                </a:solidFill>
+                <a:latin typeface="Consolas" pitchFamily="34" charset="0"/>
+                <a:ea typeface="Consolas" pitchFamily="34" charset="-122"/>
+                <a:cs typeface="Consolas" pitchFamily="34" charset="-120"/>
+              </a:rPr>
+              <a:t>）</a:t>
+            </a:r>
+            <a:endParaRPr lang="en-US" sz="900" dirty="0"/>
+          </a:p>
+        </p:txBody>
+      </p:sp>
+    </p:spTree>
+  </p:cSld>
+  <p:clrMapOvr>
+    <a:masterClrMapping/>
+  </p:clrMapOvr>
+</p:sld>
+</file>
+
+<file path=ppt/slides/slide27.xml><?xml version="1.0" encoding="utf-8"?>
+<p:sld xmlns:a="http://schemas.openxmlformats.org/drawingml/2006/main" xmlns:r="http://schemas.openxmlformats.org/officeDocument/2006/relationships" xmlns:p="http://schemas.openxmlformats.org/presentationml/2006/main">
+  <p:cSld name="Slide 27">
+    <p:bg>
+      <p:bgPr>
+        <a:solidFill>
+          <a:srgbClr val="F4F7FB"/>
+        </a:solidFill>
+      </p:bgPr>
+    </p:bg>
+    <p:spTree>
+      <p:nvGrpSpPr>
+        <p:cNvPr id="1" name=""/>
+        <p:cNvGrpSpPr/>
+        <p:nvPr/>
+      </p:nvGrpSpPr>
+      <p:grpSpPr>
+        <a:xfrm>
+          <a:off x="0" y="0"/>
+          <a:ext cx="0" cy="0"/>
+          <a:chOff x="0" y="0"/>
+          <a:chExt cx="0" cy="0"/>
+        </a:xfrm>
+      </p:grpSpPr>
+      <p:sp>
+        <p:nvSpPr>
+          <p:cNvPr id="2" name="Shape 0"/>
+          <p:cNvSpPr/>
+          <p:nvPr/>
+        </p:nvSpPr>
+        <p:spPr>
+          <a:xfrm>
+            <a:off x="502920" y="457200"/>
+            <a:ext cx="146304" cy="146304"/>
+          </a:xfrm>
+          <a:prstGeom prst="ellipse">
+            <a:avLst/>
+          </a:prstGeom>
+          <a:solidFill>
+            <a:srgbClr val="E8A33D"/>
+          </a:solidFill>
+          <a:ln/>
+        </p:spPr>
+      </p:sp>
+      <p:sp>
+        <p:nvSpPr>
+          <p:cNvPr id="3" name="Text 1"/>
+          <p:cNvSpPr/>
+          <p:nvPr/>
+        </p:nvSpPr>
+        <p:spPr>
+          <a:xfrm>
+            <a:off x="731520" y="420624"/>
+            <a:ext cx="10058400" cy="274320"/>
+          </a:xfrm>
+          <a:prstGeom prst="rect">
+            <a:avLst/>
+          </a:prstGeom>
+          <a:noFill/>
+          <a:ln/>
+        </p:spPr>
+        <p:txBody>
+          <a:bodyPr wrap="square" lIns="0" tIns="0" rIns="0" bIns="0" rtlCol="0" anchor="ctr"/>
+          <a:lstStyle/>
+          <a:p>
+            <a:pPr indent="0" marL="0">
+              <a:buNone/>
+            </a:pPr>
+            <a:r>
+              <a:rPr lang="en-US" sz="1200" b="1" spc="200" kern="0" dirty="0">
+                <a:solidFill>
+                  <a:srgbClr val="3A5BA0"/>
+                </a:solidFill>
+                <a:latin typeface="Calibri" pitchFamily="34" charset="0"/>
+                <a:ea typeface="Calibri" pitchFamily="34" charset="-122"/>
+                <a:cs typeface="Calibri" pitchFamily="34" charset="-120"/>
+              </a:rPr>
+              <a:t>PART 7 · 反思</a:t>
+            </a:r>
+            <a:endParaRPr lang="en-US" sz="1200" dirty="0"/>
+          </a:p>
+        </p:txBody>
+      </p:sp>
+      <p:sp>
+        <p:nvSpPr>
+          <p:cNvPr id="4" name="Text 2"/>
+          <p:cNvSpPr/>
+          <p:nvPr/>
+        </p:nvSpPr>
+        <p:spPr>
+          <a:xfrm>
+            <a:off x="502920" y="713232"/>
+            <a:ext cx="11155680" cy="777240"/>
+          </a:xfrm>
+          <a:prstGeom prst="rect">
+            <a:avLst/>
+          </a:prstGeom>
+          <a:noFill/>
+          <a:ln/>
+        </p:spPr>
+        <p:txBody>
+          <a:bodyPr wrap="square" lIns="0" tIns="0" rIns="0" bIns="0" rtlCol="0" anchor="ctr"/>
+          <a:lstStyle/>
+          <a:p>
+            <a:pPr indent="0" marL="0">
+              <a:buNone/>
+            </a:pPr>
+            <a:r>
+              <a:rPr lang="en-US" sz="2800" b="1" dirty="0">
+                <a:solidFill>
+                  <a:srgbClr val="1E2761"/>
+                </a:solidFill>
+                <a:latin typeface="Georgia" pitchFamily="34" charset="0"/>
+                <a:ea typeface="Georgia" pitchFamily="34" charset="-122"/>
+                <a:cs typeface="Georgia" pitchFamily="34" charset="-120"/>
+              </a:rPr>
+              <a:t>Key Takeaways</a:t>
+            </a:r>
+            <a:endParaRPr lang="en-US" sz="2800" dirty="0"/>
+          </a:p>
+        </p:txBody>
+      </p:sp>
+      <p:sp>
+        <p:nvSpPr>
+          <p:cNvPr id="5" name="Shape 3"/>
+          <p:cNvSpPr/>
+          <p:nvPr/>
+        </p:nvSpPr>
+        <p:spPr>
+          <a:xfrm>
+            <a:off x="548640" y="1828800"/>
             <a:ext cx="11109960" cy="868680"/>
           </a:xfrm>
           <a:prstGeom prst="rect">
@@ -17861,6 +18791,396 @@
       </p:sp>
       <p:sp>
         <p:nvSpPr>
+          <p:cNvPr id="6" name="Shape 4"/>
+          <p:cNvSpPr/>
+          <p:nvPr/>
+        </p:nvSpPr>
+        <p:spPr>
+          <a:xfrm>
+            <a:off x="822960" y="2029968"/>
+            <a:ext cx="457200" cy="457200"/>
+          </a:xfrm>
+          <a:prstGeom prst="ellipse">
+            <a:avLst/>
+          </a:prstGeom>
+          <a:solidFill>
+            <a:srgbClr val="E8A33D"/>
+          </a:solidFill>
+          <a:ln/>
+        </p:spPr>
+      </p:sp>
+      <p:sp>
+        <p:nvSpPr>
+          <p:cNvPr id="7" name="Text 5"/>
+          <p:cNvSpPr/>
+          <p:nvPr/>
+        </p:nvSpPr>
+        <p:spPr>
+          <a:xfrm>
+            <a:off x="822960" y="2029968"/>
+            <a:ext cx="457200" cy="457200"/>
+          </a:xfrm>
+          <a:prstGeom prst="rect">
+            <a:avLst/>
+          </a:prstGeom>
+          <a:noFill/>
+          <a:ln/>
+        </p:spPr>
+        <p:txBody>
+          <a:bodyPr wrap="square" lIns="0" tIns="0" rIns="0" bIns="0" rtlCol="0" anchor="ctr"/>
+          <a:lstStyle/>
+          <a:p>
+            <a:pPr algn="ctr" indent="0" marL="0">
+              <a:buNone/>
+            </a:pPr>
+            <a:r>
+              <a:rPr lang="en-US" sz="1800" b="1" dirty="0">
+                <a:solidFill>
+                  <a:srgbClr val="1E2761"/>
+                </a:solidFill>
+                <a:latin typeface="Georgia" pitchFamily="34" charset="0"/>
+                <a:ea typeface="Georgia" pitchFamily="34" charset="-122"/>
+                <a:cs typeface="Georgia" pitchFamily="34" charset="-120"/>
+              </a:rPr>
+              <a:t>1</a:t>
+            </a:r>
+            <a:endParaRPr lang="en-US" sz="1800" dirty="0"/>
+          </a:p>
+        </p:txBody>
+      </p:sp>
+      <p:sp>
+        <p:nvSpPr>
+          <p:cNvPr id="8" name="Text 6"/>
+          <p:cNvSpPr/>
+          <p:nvPr/>
+        </p:nvSpPr>
+        <p:spPr>
+          <a:xfrm>
+            <a:off x="1463040" y="1828800"/>
+            <a:ext cx="10058400" cy="868680"/>
+          </a:xfrm>
+          <a:prstGeom prst="rect">
+            <a:avLst/>
+          </a:prstGeom>
+          <a:noFill/>
+          <a:ln/>
+        </p:spPr>
+        <p:txBody>
+          <a:bodyPr wrap="square" lIns="0" tIns="0" rIns="0" bIns="0" rtlCol="0" anchor="ctr"/>
+          <a:lstStyle/>
+          <a:p>
+            <a:pPr indent="0" marL="0">
+              <a:buNone/>
+            </a:pPr>
+            <a:r>
+              <a:rPr lang="en-US" sz="1550" dirty="0">
+                <a:solidFill>
+                  <a:srgbClr val="23272E"/>
+                </a:solidFill>
+                <a:latin typeface="Calibri" pitchFamily="34" charset="0"/>
+                <a:ea typeface="Calibri" pitchFamily="34" charset="-122"/>
+                <a:cs typeface="Calibri" pitchFamily="34" charset="-120"/>
+              </a:rPr>
+              <a:t>進化能設計 agent，但要防它把自己改壞 → 護欄越往內越強（最壞只是退化）</a:t>
+            </a:r>
+            <a:endParaRPr lang="en-US" sz="1550" dirty="0"/>
+          </a:p>
+        </p:txBody>
+      </p:sp>
+      <p:sp>
+        <p:nvSpPr>
+          <p:cNvPr id="9" name="Shape 7"/>
+          <p:cNvSpPr/>
+          <p:nvPr/>
+        </p:nvSpPr>
+        <p:spPr>
+          <a:xfrm>
+            <a:off x="548640" y="2834640"/>
+            <a:ext cx="11109960" cy="868680"/>
+          </a:xfrm>
+          <a:prstGeom prst="rect">
+            <a:avLst/>
+          </a:prstGeom>
+          <a:solidFill>
+            <a:srgbClr val="FFFFFF"/>
+          </a:solidFill>
+          <a:ln w="12700">
+            <a:solidFill>
+              <a:srgbClr val="E2E8F0"/>
+            </a:solidFill>
+            <a:prstDash val="solid"/>
+          </a:ln>
+          <a:effectLst>
+            <a:outerShdw sx="100000" sy="100000" kx="0" ky="0" algn="bl" rotWithShape="0" blurRad="88900" dist="38100" dir="8100000">
+              <a:srgbClr val="000000">
+                <a:alpha val="12000"/>
+              </a:srgbClr>
+            </a:outerShdw>
+          </a:effectLst>
+        </p:spPr>
+      </p:sp>
+      <p:sp>
+        <p:nvSpPr>
+          <p:cNvPr id="10" name="Shape 8"/>
+          <p:cNvSpPr/>
+          <p:nvPr/>
+        </p:nvSpPr>
+        <p:spPr>
+          <a:xfrm>
+            <a:off x="822960" y="3035808"/>
+            <a:ext cx="457200" cy="457200"/>
+          </a:xfrm>
+          <a:prstGeom prst="ellipse">
+            <a:avLst/>
+          </a:prstGeom>
+          <a:solidFill>
+            <a:srgbClr val="E8A33D"/>
+          </a:solidFill>
+          <a:ln/>
+        </p:spPr>
+      </p:sp>
+      <p:sp>
+        <p:nvSpPr>
+          <p:cNvPr id="11" name="Text 9"/>
+          <p:cNvSpPr/>
+          <p:nvPr/>
+        </p:nvSpPr>
+        <p:spPr>
+          <a:xfrm>
+            <a:off x="822960" y="3035808"/>
+            <a:ext cx="457200" cy="457200"/>
+          </a:xfrm>
+          <a:prstGeom prst="rect">
+            <a:avLst/>
+          </a:prstGeom>
+          <a:noFill/>
+          <a:ln/>
+        </p:spPr>
+        <p:txBody>
+          <a:bodyPr wrap="square" lIns="0" tIns="0" rIns="0" bIns="0" rtlCol="0" anchor="ctr"/>
+          <a:lstStyle/>
+          <a:p>
+            <a:pPr algn="ctr" indent="0" marL="0">
+              <a:buNone/>
+            </a:pPr>
+            <a:r>
+              <a:rPr lang="en-US" sz="1800" b="1" dirty="0">
+                <a:solidFill>
+                  <a:srgbClr val="1E2761"/>
+                </a:solidFill>
+                <a:latin typeface="Georgia" pitchFamily="34" charset="0"/>
+                <a:ea typeface="Georgia" pitchFamily="34" charset="-122"/>
+                <a:cs typeface="Georgia" pitchFamily="34" charset="-120"/>
+              </a:rPr>
+              <a:t>2</a:t>
+            </a:r>
+            <a:endParaRPr lang="en-US" sz="1800" dirty="0"/>
+          </a:p>
+        </p:txBody>
+      </p:sp>
+      <p:sp>
+        <p:nvSpPr>
+          <p:cNvPr id="12" name="Text 10"/>
+          <p:cNvSpPr/>
+          <p:nvPr/>
+        </p:nvSpPr>
+        <p:spPr>
+          <a:xfrm>
+            <a:off x="1463040" y="2834640"/>
+            <a:ext cx="10058400" cy="868680"/>
+          </a:xfrm>
+          <a:prstGeom prst="rect">
+            <a:avLst/>
+          </a:prstGeom>
+          <a:noFill/>
+          <a:ln/>
+        </p:spPr>
+        <p:txBody>
+          <a:bodyPr wrap="square" lIns="0" tIns="0" rIns="0" bIns="0" rtlCol="0" anchor="ctr"/>
+          <a:lstStyle/>
+          <a:p>
+            <a:pPr indent="0" marL="0">
+              <a:buNone/>
+            </a:pPr>
+            <a:r>
+              <a:rPr lang="en-US" sz="1550" dirty="0">
+                <a:solidFill>
+                  <a:srgbClr val="23272E"/>
+                </a:solidFill>
+                <a:latin typeface="Calibri" pitchFamily="34" charset="0"/>
+                <a:ea typeface="Calibri" pitchFamily="34" charset="-122"/>
+                <a:cs typeface="Calibri" pitchFamily="34" charset="-120"/>
+              </a:rPr>
+              <a:t>協議 / 策略分離 + 優雅退化 = 可安全進化的地形</a:t>
+            </a:r>
+            <a:endParaRPr lang="en-US" sz="1550" dirty="0"/>
+          </a:p>
+        </p:txBody>
+      </p:sp>
+      <p:sp>
+        <p:nvSpPr>
+          <p:cNvPr id="13" name="Shape 11"/>
+          <p:cNvSpPr/>
+          <p:nvPr/>
+        </p:nvSpPr>
+        <p:spPr>
+          <a:xfrm>
+            <a:off x="548640" y="3840480"/>
+            <a:ext cx="11109960" cy="868680"/>
+          </a:xfrm>
+          <a:prstGeom prst="rect">
+            <a:avLst/>
+          </a:prstGeom>
+          <a:solidFill>
+            <a:srgbClr val="FFFFFF"/>
+          </a:solidFill>
+          <a:ln w="12700">
+            <a:solidFill>
+              <a:srgbClr val="E2E8F0"/>
+            </a:solidFill>
+            <a:prstDash val="solid"/>
+          </a:ln>
+          <a:effectLst>
+            <a:outerShdw sx="100000" sy="100000" kx="0" ky="0" algn="bl" rotWithShape="0" blurRad="88900" dist="38100" dir="8100000">
+              <a:srgbClr val="000000">
+                <a:alpha val="12000"/>
+              </a:srgbClr>
+            </a:outerShdw>
+          </a:effectLst>
+        </p:spPr>
+      </p:sp>
+      <p:sp>
+        <p:nvSpPr>
+          <p:cNvPr id="14" name="Shape 12"/>
+          <p:cNvSpPr/>
+          <p:nvPr/>
+        </p:nvSpPr>
+        <p:spPr>
+          <a:xfrm>
+            <a:off x="822960" y="4041648"/>
+            <a:ext cx="457200" cy="457200"/>
+          </a:xfrm>
+          <a:prstGeom prst="ellipse">
+            <a:avLst/>
+          </a:prstGeom>
+          <a:solidFill>
+            <a:srgbClr val="E8A33D"/>
+          </a:solidFill>
+          <a:ln/>
+        </p:spPr>
+      </p:sp>
+      <p:sp>
+        <p:nvSpPr>
+          <p:cNvPr id="15" name="Text 13"/>
+          <p:cNvSpPr/>
+          <p:nvPr/>
+        </p:nvSpPr>
+        <p:spPr>
+          <a:xfrm>
+            <a:off x="822960" y="4041648"/>
+            <a:ext cx="457200" cy="457200"/>
+          </a:xfrm>
+          <a:prstGeom prst="rect">
+            <a:avLst/>
+          </a:prstGeom>
+          <a:noFill/>
+          <a:ln/>
+        </p:spPr>
+        <p:txBody>
+          <a:bodyPr wrap="square" lIns="0" tIns="0" rIns="0" bIns="0" rtlCol="0" anchor="ctr"/>
+          <a:lstStyle/>
+          <a:p>
+            <a:pPr algn="ctr" indent="0" marL="0">
+              <a:buNone/>
+            </a:pPr>
+            <a:r>
+              <a:rPr lang="en-US" sz="1800" b="1" dirty="0">
+                <a:solidFill>
+                  <a:srgbClr val="1E2761"/>
+                </a:solidFill>
+                <a:latin typeface="Georgia" pitchFamily="34" charset="0"/>
+                <a:ea typeface="Georgia" pitchFamily="34" charset="-122"/>
+                <a:cs typeface="Georgia" pitchFamily="34" charset="-120"/>
+              </a:rPr>
+              <a:t>3</a:t>
+            </a:r>
+            <a:endParaRPr lang="en-US" sz="1800" dirty="0"/>
+          </a:p>
+        </p:txBody>
+      </p:sp>
+      <p:sp>
+        <p:nvSpPr>
+          <p:cNvPr id="16" name="Text 14"/>
+          <p:cNvSpPr/>
+          <p:nvPr/>
+        </p:nvSpPr>
+        <p:spPr>
+          <a:xfrm>
+            <a:off x="1463040" y="3840480"/>
+            <a:ext cx="10058400" cy="868680"/>
+          </a:xfrm>
+          <a:prstGeom prst="rect">
+            <a:avLst/>
+          </a:prstGeom>
+          <a:noFill/>
+          <a:ln/>
+        </p:spPr>
+        <p:txBody>
+          <a:bodyPr wrap="square" lIns="0" tIns="0" rIns="0" bIns="0" rtlCol="0" anchor="ctr"/>
+          <a:lstStyle/>
+          <a:p>
+            <a:pPr indent="0" marL="0">
+              <a:buNone/>
+            </a:pPr>
+            <a:r>
+              <a:rPr lang="en-US" sz="1550" dirty="0">
+                <a:solidFill>
+                  <a:srgbClr val="23272E"/>
+                </a:solidFill>
+                <a:latin typeface="Calibri" pitchFamily="34" charset="0"/>
+                <a:ea typeface="Calibri" pitchFamily="34" charset="-122"/>
+                <a:cs typeface="Calibri" pitchFamily="34" charset="-120"/>
+              </a:rPr>
+              <a:t>誠實回報 + 人類把關不可逆 = 協作安全地基；分數健康 ≠ 功能正確</a:t>
+            </a:r>
+            <a:endParaRPr lang="en-US" sz="1550" dirty="0"/>
+          </a:p>
+        </p:txBody>
+      </p:sp>
+      <p:sp>
+        <p:nvSpPr>
+          <p:cNvPr id="17" name="Shape 15"/>
+          <p:cNvSpPr/>
+          <p:nvPr/>
+        </p:nvSpPr>
+        <p:spPr>
+          <a:xfrm>
+            <a:off x="548640" y="4846320"/>
+            <a:ext cx="11109960" cy="868680"/>
+          </a:xfrm>
+          <a:prstGeom prst="rect">
+            <a:avLst/>
+          </a:prstGeom>
+          <a:solidFill>
+            <a:srgbClr val="FFFFFF"/>
+          </a:solidFill>
+          <a:ln w="12700">
+            <a:solidFill>
+              <a:srgbClr val="E2E8F0"/>
+            </a:solidFill>
+            <a:prstDash val="solid"/>
+          </a:ln>
+          <a:effectLst>
+            <a:outerShdw sx="100000" sy="100000" kx="0" ky="0" algn="bl" rotWithShape="0" blurRad="88900" dist="38100" dir="8100000">
+              <a:srgbClr val="000000">
+                <a:alpha val="12000"/>
+              </a:srgbClr>
+            </a:outerShdw>
+          </a:effectLst>
+        </p:spPr>
+      </p:sp>
+      <p:sp>
+        <p:nvSpPr>
           <p:cNvPr id="18" name="Shape 16"/>
           <p:cNvSpPr/>
           <p:nvPr/>
@@ -18004,9 +19324,9 @@
 </p:sld>
 </file>
 
-<file path=ppt/slides/slide27.xml><?xml version="1.0" encoding="utf-8"?>
+<file path=ppt/slides/slide28.xml><?xml version="1.0" encoding="utf-8"?>
 <p:sld xmlns:a="http://schemas.openxmlformats.org/drawingml/2006/main" xmlns:r="http://schemas.openxmlformats.org/officeDocument/2006/relationships" xmlns:p="http://schemas.openxmlformats.org/presentationml/2006/main">
-  <p:cSld name="Slide 27">
+  <p:cSld name="Slide 28">
     <p:bg>
       <p:bgPr>
         <a:solidFill>

</xml_diff>

<commit_message>
docs: fix L-numbering collision on the failure-taxonomy slide
S10 labelled the 5 failure modes L1–L5, but Part 3 uses L0/L1/L2 for the
three *defenses* — so "L1"/"L2" meant two different things across slides
(and S10 contradicted its own "5 種失敗模式" wording). Relabel the failure
modes ①–⑤ so L0/L1/L2 now refers only to the defenses, everywhere.

Co-Authored-By: Claude Opus 4.8 <noreply@anthropic.com>
</commit_message>
<xml_diff>
--- a/docs/slides/人AI進化_整合教學投影片.pptx
+++ b/docs/slides/人AI進化_整合教學投影片.pptx
@@ -5439,21 +5439,21 @@
           <a:bodyPr wrap="square" lIns="0" tIns="0" rIns="0" bIns="0" rtlCol="0" anchor="ctr"/>
           <a:lstStyle/>
           <a:p>
-            <a:pPr indent="0" marL="0">
-              <a:buNone/>
-            </a:pPr>
-            <a:r>
-              <a:rPr lang="en-US" sz="1500" b="1" dirty="0">
+            <a:pPr algn="ctr" indent="0" marL="0">
+              <a:buNone/>
+            </a:pPr>
+            <a:r>
+              <a:rPr lang="en-US" sz="1700" b="1" dirty="0">
                 <a:solidFill>
                   <a:srgbClr val="C0453B"/>
                 </a:solidFill>
-                <a:latin typeface="Consolas" pitchFamily="34" charset="0"/>
-                <a:ea typeface="Consolas" pitchFamily="34" charset="-122"/>
-                <a:cs typeface="Consolas" pitchFamily="34" charset="-120"/>
-              </a:rPr>
-              <a:t>L1</a:t>
-            </a:r>
-            <a:endParaRPr lang="en-US" sz="1500" dirty="0"/>
+                <a:latin typeface="Georgia" pitchFamily="34" charset="0"/>
+                <a:ea typeface="Georgia" pitchFamily="34" charset="-122"/>
+                <a:cs typeface="Georgia" pitchFamily="34" charset="-120"/>
+              </a:rPr>
+              <a:t>①</a:t>
+            </a:r>
+            <a:endParaRPr lang="en-US" sz="1700" dirty="0"/>
           </a:p>
         </p:txBody>
       </p:sp>
@@ -5608,21 +5608,21 @@
           <a:bodyPr wrap="square" lIns="0" tIns="0" rIns="0" bIns="0" rtlCol="0" anchor="ctr"/>
           <a:lstStyle/>
           <a:p>
-            <a:pPr indent="0" marL="0">
-              <a:buNone/>
-            </a:pPr>
-            <a:r>
-              <a:rPr lang="en-US" sz="1500" b="1" dirty="0">
+            <a:pPr algn="ctr" indent="0" marL="0">
+              <a:buNone/>
+            </a:pPr>
+            <a:r>
+              <a:rPr lang="en-US" sz="1700" b="1" dirty="0">
                 <a:solidFill>
                   <a:srgbClr val="E8A33D"/>
                 </a:solidFill>
-                <a:latin typeface="Consolas" pitchFamily="34" charset="0"/>
-                <a:ea typeface="Consolas" pitchFamily="34" charset="-122"/>
-                <a:cs typeface="Consolas" pitchFamily="34" charset="-120"/>
-              </a:rPr>
-              <a:t>L2</a:t>
-            </a:r>
-            <a:endParaRPr lang="en-US" sz="1500" dirty="0"/>
+                <a:latin typeface="Georgia" pitchFamily="34" charset="0"/>
+                <a:ea typeface="Georgia" pitchFamily="34" charset="-122"/>
+                <a:cs typeface="Georgia" pitchFamily="34" charset="-120"/>
+              </a:rPr>
+              <a:t>②</a:t>
+            </a:r>
+            <a:endParaRPr lang="en-US" sz="1700" dirty="0"/>
           </a:p>
         </p:txBody>
       </p:sp>
@@ -5777,21 +5777,21 @@
           <a:bodyPr wrap="square" lIns="0" tIns="0" rIns="0" bIns="0" rtlCol="0" anchor="ctr"/>
           <a:lstStyle/>
           <a:p>
-            <a:pPr indent="0" marL="0">
-              <a:buNone/>
-            </a:pPr>
-            <a:r>
-              <a:rPr lang="en-US" sz="1500" b="1" dirty="0">
+            <a:pPr algn="ctr" indent="0" marL="0">
+              <a:buNone/>
+            </a:pPr>
+            <a:r>
+              <a:rPr lang="en-US" sz="1700" b="1" dirty="0">
                 <a:solidFill>
                   <a:srgbClr val="E8A33D"/>
                 </a:solidFill>
-                <a:latin typeface="Consolas" pitchFamily="34" charset="0"/>
-                <a:ea typeface="Consolas" pitchFamily="34" charset="-122"/>
-                <a:cs typeface="Consolas" pitchFamily="34" charset="-120"/>
-              </a:rPr>
-              <a:t>L3</a:t>
-            </a:r>
-            <a:endParaRPr lang="en-US" sz="1500" dirty="0"/>
+                <a:latin typeface="Georgia" pitchFamily="34" charset="0"/>
+                <a:ea typeface="Georgia" pitchFamily="34" charset="-122"/>
+                <a:cs typeface="Georgia" pitchFamily="34" charset="-120"/>
+              </a:rPr>
+              <a:t>③</a:t>
+            </a:r>
+            <a:endParaRPr lang="en-US" sz="1700" dirty="0"/>
           </a:p>
         </p:txBody>
       </p:sp>
@@ -5946,21 +5946,21 @@
           <a:bodyPr wrap="square" lIns="0" tIns="0" rIns="0" bIns="0" rtlCol="0" anchor="ctr"/>
           <a:lstStyle/>
           <a:p>
-            <a:pPr indent="0" marL="0">
-              <a:buNone/>
-            </a:pPr>
-            <a:r>
-              <a:rPr lang="en-US" sz="1500" b="1" dirty="0">
+            <a:pPr algn="ctr" indent="0" marL="0">
+              <a:buNone/>
+            </a:pPr>
+            <a:r>
+              <a:rPr lang="en-US" sz="1700" b="1" dirty="0">
                 <a:solidFill>
                   <a:srgbClr val="3A5BA0"/>
                 </a:solidFill>
-                <a:latin typeface="Consolas" pitchFamily="34" charset="0"/>
-                <a:ea typeface="Consolas" pitchFamily="34" charset="-122"/>
-                <a:cs typeface="Consolas" pitchFamily="34" charset="-120"/>
-              </a:rPr>
-              <a:t>L4</a:t>
-            </a:r>
-            <a:endParaRPr lang="en-US" sz="1500" dirty="0"/>
+                <a:latin typeface="Georgia" pitchFamily="34" charset="0"/>
+                <a:ea typeface="Georgia" pitchFamily="34" charset="-122"/>
+                <a:cs typeface="Georgia" pitchFamily="34" charset="-120"/>
+              </a:rPr>
+              <a:t>④</a:t>
+            </a:r>
+            <a:endParaRPr lang="en-US" sz="1700" dirty="0"/>
           </a:p>
         </p:txBody>
       </p:sp>
@@ -6115,21 +6115,21 @@
           <a:bodyPr wrap="square" lIns="0" tIns="0" rIns="0" bIns="0" rtlCol="0" anchor="ctr"/>
           <a:lstStyle/>
           <a:p>
-            <a:pPr indent="0" marL="0">
-              <a:buNone/>
-            </a:pPr>
-            <a:r>
-              <a:rPr lang="en-US" sz="1500" b="1" dirty="0">
+            <a:pPr algn="ctr" indent="0" marL="0">
+              <a:buNone/>
+            </a:pPr>
+            <a:r>
+              <a:rPr lang="en-US" sz="1700" b="1" dirty="0">
                 <a:solidFill>
                   <a:srgbClr val="3A5BA0"/>
                 </a:solidFill>
-                <a:latin typeface="Consolas" pitchFamily="34" charset="0"/>
-                <a:ea typeface="Consolas" pitchFamily="34" charset="-122"/>
-                <a:cs typeface="Consolas" pitchFamily="34" charset="-120"/>
-              </a:rPr>
-              <a:t>L5</a:t>
-            </a:r>
-            <a:endParaRPr lang="en-US" sz="1500" dirty="0"/>
+                <a:latin typeface="Georgia" pitchFamily="34" charset="0"/>
+                <a:ea typeface="Georgia" pitchFamily="34" charset="-122"/>
+                <a:cs typeface="Georgia" pitchFamily="34" charset="-120"/>
+              </a:rPr>
+              <a:t>⑤</a:t>
+            </a:r>
+            <a:endParaRPr lang="en-US" sz="1700" dirty="0"/>
           </a:p>
         </p:txBody>
       </p:sp>

</xml_diff>